<commit_message>
Livrables : Dossier + deck mis à jour avec le volet haute disponibilité
- dossier.html/PDF : montage 5 PC, bascule & reprise de transaction sans double
  débit, réplication, recette HA 13/13 (intégrés aux sections archi/remédiation/essais)
- build-deck.js/PPTX : nouvelle slide "Haute disponibilité" (topologie + failover),
  deck revalidé

Co-Authored-By: Claude Opus 4.8 <noreply@anthropic.com>
</commit_message>
<xml_diff>
--- a/livrables/Presentation-RESILIENCE-ALPHA.pptx
+++ b/livrables/Presentation-RESILIENCE-ALPHA.pptx
@@ -15,9 +15,10 @@
     <p:sldId id="263" r:id="rId9"/>
     <p:sldId id="264" r:id="rId10"/>
     <p:sldId id="265" r:id="rId11"/>
+    <p:sldId id="266" r:id="rId12"/>
   </p:sldIdLst>
   <p:notesMasterIdLst>
-    <p:notesMasterId r:id="rId12"/>
+    <p:notesMasterId r:id="rId13"/>
   </p:notesMasterIdLst>
   <p:sldSz cx="12192000" cy="6858000"/>
   <p:notesSz cx="6858000" cy="12192000"/>
@@ -875,6 +876,94 @@
             <a:fld id="{F7021451-1387-4CA6-816F-3879F97B5CBC}" type="slidenum">
               <a:rPr lang="en-US"/>
               <a:t>10</a:t>
+            </a:fld>
+            <a:endParaRPr lang="en-US"/>
+          </a:p>
+        </p:txBody>
+      </p:sp>
+    </p:spTree>
+    <p:extLst>
+      <p:ext uri="{BB962C8B-B14F-4D97-AF65-F5344CB8AC3E}">
+        <p14:creationId xmlns:p14="http://schemas.microsoft.com/office/powerpoint/2010/main" val="1024086991"/>
+      </p:ext>
+    </p:extLst>
+  </p:cSld>
+  <p:clrMapOvr>
+    <a:masterClrMapping/>
+  </p:clrMapOvr>
+</p:notes>
+</file>
+
+<file path=ppt/notesSlides/notesSlide11.xml><?xml version="1.0" encoding="utf-8"?>
+<p:notes xmlns:a="http://schemas.openxmlformats.org/drawingml/2006/main" xmlns:r="http://schemas.openxmlformats.org/officeDocument/2006/relationships" xmlns:p="http://schemas.openxmlformats.org/presentationml/2006/main">
+  <p:cSld>
+    <p:spTree>
+      <p:nvGrpSpPr>
+        <p:cNvPr id="1" name=""/>
+        <p:cNvGrpSpPr/>
+        <p:nvPr/>
+      </p:nvGrpSpPr>
+      <p:grpSpPr>
+        <a:xfrm>
+          <a:off x="0" y="0"/>
+          <a:ext cx="0" cy="0"/>
+          <a:chOff x="0" y="0"/>
+          <a:chExt cx="0" cy="0"/>
+        </a:xfrm>
+      </p:grpSpPr>
+      <p:sp>
+        <p:nvSpPr>
+          <p:cNvPr id="2" name="Slide Image Placeholder 1"/>
+          <p:cNvSpPr>
+            <a:spLocks noGrp="1" noRot="1" noChangeAspect="1"/>
+          </p:cNvSpPr>
+          <p:nvPr>
+            <p:ph type="sldImg"/>
+          </p:nvPr>
+        </p:nvSpPr>
+        <p:spPr/>
+      </p:sp>
+      <p:sp>
+        <p:nvSpPr>
+          <p:cNvPr id="3" name="Notes Placeholder 2"/>
+          <p:cNvSpPr>
+            <a:spLocks noGrp="1"/>
+          </p:cNvSpPr>
+          <p:nvPr>
+            <p:ph type="body" idx="1"/>
+          </p:nvPr>
+        </p:nvSpPr>
+        <p:spPr/>
+        <p:txBody>
+          <a:bodyPr/>
+          <a:lstStyle/>
+          <a:p>
+            <a:r>
+              <a:rPr lang="en-US" dirty="0"/>
+              <a:t/>
+            </a:r>
+            <a:endParaRPr lang="en-US" dirty="0"/>
+          </a:p>
+        </p:txBody>
+      </p:sp>
+      <p:sp>
+        <p:nvSpPr>
+          <p:cNvPr id="4" name="Slide Number Placeholder 3"/>
+          <p:cNvSpPr>
+            <a:spLocks noGrp="1"/>
+          </p:cNvSpPr>
+          <p:nvPr>
+            <p:ph type="sldNum" sz="quarter" idx="10"/>
+          </p:nvPr>
+        </p:nvSpPr>
+        <p:spPr/>
+        <p:txBody>
+          <a:bodyPr/>
+          <a:lstStyle/>
+          <a:p>
+            <a:fld id="{F7021451-1387-4CA6-816F-3879F97B5CBC}" type="slidenum">
+              <a:rPr lang="en-US"/>
+              <a:t>11</a:t>
             </a:fld>
             <a:endParaRPr lang="en-US"/>
           </a:p>
@@ -2159,6 +2248,479 @@
     <p:bg>
       <p:bgPr>
         <a:solidFill>
+          <a:srgbClr val="FFFFFF"/>
+        </a:solidFill>
+      </p:bgPr>
+    </p:bg>
+    <p:spTree>
+      <p:nvGrpSpPr>
+        <p:cNvPr id="1" name=""/>
+        <p:cNvGrpSpPr/>
+        <p:nvPr/>
+      </p:nvGrpSpPr>
+      <p:grpSpPr>
+        <a:xfrm>
+          <a:off x="0" y="0"/>
+          <a:ext cx="0" cy="0"/>
+          <a:chOff x="0" y="0"/>
+          <a:chExt cx="0" cy="0"/>
+        </a:xfrm>
+      </p:grpSpPr>
+      <p:sp>
+        <p:nvSpPr>
+          <p:cNvPr id="2" name="Text 0"/>
+          <p:cNvSpPr txBox="1"/>
+          <p:nvPr/>
+        </p:nvSpPr>
+        <p:spPr>
+          <a:xfrm>
+            <a:off x="548640" y="411480"/>
+            <a:ext cx="10972800" cy="274320"/>
+          </a:xfrm>
+          <a:prstGeom prst="rect">
+            <a:avLst/>
+          </a:prstGeom>
+          <a:noFill/>
+          <a:ln/>
+        </p:spPr>
+        <p:txBody>
+          <a:bodyPr wrap="square" lIns="0" tIns="0" rIns="0" bIns="0" rtlCol="0" anchor="ctr"/>
+          <a:lstStyle/>
+          <a:p>
+            <a:pPr indent="0" marL="0">
+              <a:buNone/>
+            </a:pPr>
+            <a:r>
+              <a:rPr lang="en-US" sz="1200" b="1" spc="200" kern="0" dirty="0">
+                <a:solidFill>
+                  <a:srgbClr val="4B3FA6"/>
+                </a:solidFill>
+                <a:latin typeface="Calibri" pitchFamily="34" charset="0"/>
+                <a:ea typeface="Calibri" pitchFamily="34" charset="-122"/>
+                <a:cs typeface="Calibri" pitchFamily="34" charset="-120"/>
+              </a:rPr>
+              <a:t>TRANSFORMATION</a:t>
+            </a:r>
+            <a:endParaRPr lang="en-US" sz="1200" dirty="0"/>
+          </a:p>
+        </p:txBody>
+      </p:sp>
+      <p:sp>
+        <p:nvSpPr>
+          <p:cNvPr id="3" name="Text 1"/>
+          <p:cNvSpPr txBox="1"/>
+          <p:nvPr/>
+        </p:nvSpPr>
+        <p:spPr>
+          <a:xfrm>
+            <a:off x="548640" y="658368"/>
+            <a:ext cx="11064240" cy="640080"/>
+          </a:xfrm>
+          <a:prstGeom prst="rect">
+            <a:avLst/>
+          </a:prstGeom>
+          <a:noFill/>
+          <a:ln/>
+        </p:spPr>
+        <p:txBody>
+          <a:bodyPr wrap="square" lIns="0" tIns="0" rIns="0" bIns="0" rtlCol="0" anchor="ctr"/>
+          <a:lstStyle/>
+          <a:p>
+            <a:pPr indent="0" marL="0">
+              <a:buNone/>
+            </a:pPr>
+            <a:r>
+              <a:rPr lang="en-US" sz="3000" b="1" dirty="0">
+                <a:solidFill>
+                  <a:srgbClr val="261E48"/>
+                </a:solidFill>
+                <a:latin typeface="Calibri" pitchFamily="34" charset="0"/>
+                <a:ea typeface="Calibri" pitchFamily="34" charset="-122"/>
+                <a:cs typeface="Calibri" pitchFamily="34" charset="-120"/>
+              </a:rPr>
+              <a:t>Gouvernance &amp; conformité</a:t>
+            </a:r>
+            <a:endParaRPr lang="en-US" sz="3000" dirty="0"/>
+          </a:p>
+        </p:txBody>
+      </p:sp>
+      <p:sp>
+        <p:nvSpPr>
+          <p:cNvPr id="4" name="Shape 2"/>
+          <p:cNvSpPr/>
+          <p:nvPr/>
+        </p:nvSpPr>
+        <p:spPr>
+          <a:xfrm>
+            <a:off x="548640" y="1737360"/>
+            <a:ext cx="11064240" cy="1005840"/>
+          </a:xfrm>
+          <a:prstGeom prst="roundRect">
+            <a:avLst>
+              <a:gd name="adj" fmla="val 7273"/>
+            </a:avLst>
+          </a:prstGeom>
+          <a:solidFill>
+            <a:srgbClr val="EEF0F8"/>
+          </a:solidFill>
+          <a:ln/>
+          <a:effectLst>
+            <a:outerShdw sx="100000" sy="100000" kx="0" ky="0" algn="bl" rotWithShape="0" blurRad="76200" dist="25400" dir="5400000">
+              <a:srgbClr val="888888">
+                <a:alpha val="25000"/>
+              </a:srgbClr>
+            </a:outerShdw>
+          </a:effectLst>
+        </p:spPr>
+      </p:sp>
+      <p:sp>
+        <p:nvSpPr>
+          <p:cNvPr id="5" name="Text 3"/>
+          <p:cNvSpPr txBox="1"/>
+          <p:nvPr/>
+        </p:nvSpPr>
+        <p:spPr>
+          <a:xfrm>
+            <a:off x="777240" y="1901952"/>
+            <a:ext cx="2743200" cy="640080"/>
+          </a:xfrm>
+          <a:prstGeom prst="rect">
+            <a:avLst/>
+          </a:prstGeom>
+          <a:noFill/>
+          <a:ln/>
+        </p:spPr>
+        <p:txBody>
+          <a:bodyPr wrap="square" lIns="0" tIns="0" rIns="0" bIns="0" rtlCol="0" anchor="ctr"/>
+          <a:lstStyle/>
+          <a:p>
+            <a:pPr indent="0" marL="0">
+              <a:buNone/>
+            </a:pPr>
+            <a:r>
+              <a:rPr lang="en-US" sz="1600" b="1" dirty="0">
+                <a:solidFill>
+                  <a:srgbClr val="4B3FA6"/>
+                </a:solidFill>
+                <a:latin typeface="Calibri" pitchFamily="34" charset="0"/>
+                <a:ea typeface="Calibri" pitchFamily="34" charset="-122"/>
+                <a:cs typeface="Calibri" pitchFamily="34" charset="-120"/>
+              </a:rPr>
+              <a:t>EBIOS RM</a:t>
+            </a:r>
+            <a:endParaRPr lang="en-US" sz="1600" dirty="0"/>
+          </a:p>
+        </p:txBody>
+      </p:sp>
+      <p:sp>
+        <p:nvSpPr>
+          <p:cNvPr id="6" name="Text 4"/>
+          <p:cNvSpPr txBox="1"/>
+          <p:nvPr/>
+        </p:nvSpPr>
+        <p:spPr>
+          <a:xfrm>
+            <a:off x="3566160" y="1920240"/>
+            <a:ext cx="7863840" cy="685800"/>
+          </a:xfrm>
+          <a:prstGeom prst="rect">
+            <a:avLst/>
+          </a:prstGeom>
+          <a:noFill/>
+          <a:ln/>
+        </p:spPr>
+        <p:txBody>
+          <a:bodyPr wrap="square" lIns="0" tIns="0" rIns="0" bIns="0" rtlCol="0" anchor="ctr"/>
+          <a:lstStyle/>
+          <a:p>
+            <a:pPr indent="0" marL="0">
+              <a:buNone/>
+            </a:pPr>
+            <a:r>
+              <a:rPr lang="en-US" sz="1350" dirty="0">
+                <a:solidFill>
+                  <a:srgbClr val="261E48"/>
+                </a:solidFill>
+                <a:latin typeface="Calibri" pitchFamily="34" charset="0"/>
+                <a:ea typeface="Calibri" pitchFamily="34" charset="-122"/>
+                <a:cs typeface="Calibri" pitchFamily="34" charset="-120"/>
+              </a:rPr>
+              <a:t>Risques reliés à l'architecture et aux attaques réellement testées</a:t>
+            </a:r>
+            <a:endParaRPr lang="en-US" sz="1350" dirty="0"/>
+          </a:p>
+        </p:txBody>
+      </p:sp>
+      <p:sp>
+        <p:nvSpPr>
+          <p:cNvPr id="7" name="Shape 5"/>
+          <p:cNvSpPr/>
+          <p:nvPr/>
+        </p:nvSpPr>
+        <p:spPr>
+          <a:xfrm>
+            <a:off x="548640" y="2926080"/>
+            <a:ext cx="11064240" cy="1005840"/>
+          </a:xfrm>
+          <a:prstGeom prst="roundRect">
+            <a:avLst>
+              <a:gd name="adj" fmla="val 7273"/>
+            </a:avLst>
+          </a:prstGeom>
+          <a:solidFill>
+            <a:srgbClr val="EEF0F8"/>
+          </a:solidFill>
+          <a:ln/>
+          <a:effectLst>
+            <a:outerShdw sx="100000" sy="100000" kx="0" ky="0" algn="bl" rotWithShape="0" blurRad="76200" dist="25400" dir="5400000">
+              <a:srgbClr val="888888">
+                <a:alpha val="25000"/>
+              </a:srgbClr>
+            </a:outerShdw>
+          </a:effectLst>
+        </p:spPr>
+      </p:sp>
+      <p:sp>
+        <p:nvSpPr>
+          <p:cNvPr id="8" name="Text 6"/>
+          <p:cNvSpPr txBox="1"/>
+          <p:nvPr/>
+        </p:nvSpPr>
+        <p:spPr>
+          <a:xfrm>
+            <a:off x="777240" y="3090672"/>
+            <a:ext cx="2743200" cy="640080"/>
+          </a:xfrm>
+          <a:prstGeom prst="rect">
+            <a:avLst/>
+          </a:prstGeom>
+          <a:noFill/>
+          <a:ln/>
+        </p:spPr>
+        <p:txBody>
+          <a:bodyPr wrap="square" lIns="0" tIns="0" rIns="0" bIns="0" rtlCol="0" anchor="ctr"/>
+          <a:lstStyle/>
+          <a:p>
+            <a:pPr indent="0" marL="0">
+              <a:buNone/>
+            </a:pPr>
+            <a:r>
+              <a:rPr lang="en-US" sz="1600" b="1" dirty="0">
+                <a:solidFill>
+                  <a:srgbClr val="4B3FA6"/>
+                </a:solidFill>
+                <a:latin typeface="Calibri" pitchFamily="34" charset="0"/>
+                <a:ea typeface="Calibri" pitchFamily="34" charset="-122"/>
+                <a:cs typeface="Calibri" pitchFamily="34" charset="-120"/>
+              </a:rPr>
+              <a:t>PCA / PRA</a:t>
+            </a:r>
+            <a:endParaRPr lang="en-US" sz="1600" dirty="0"/>
+          </a:p>
+        </p:txBody>
+      </p:sp>
+      <p:sp>
+        <p:nvSpPr>
+          <p:cNvPr id="9" name="Text 7"/>
+          <p:cNvSpPr txBox="1"/>
+          <p:nvPr/>
+        </p:nvSpPr>
+        <p:spPr>
+          <a:xfrm>
+            <a:off x="3566160" y="3108960"/>
+            <a:ext cx="7863840" cy="685800"/>
+          </a:xfrm>
+          <a:prstGeom prst="rect">
+            <a:avLst/>
+          </a:prstGeom>
+          <a:noFill/>
+          <a:ln/>
+        </p:spPr>
+        <p:txBody>
+          <a:bodyPr wrap="square" lIns="0" tIns="0" rIns="0" bIns="0" rtlCol="0" anchor="ctr"/>
+          <a:lstStyle/>
+          <a:p>
+            <a:pPr indent="0" marL="0">
+              <a:buNone/>
+            </a:pPr>
+            <a:r>
+              <a:rPr lang="en-US" sz="1350" dirty="0">
+                <a:solidFill>
+                  <a:srgbClr val="261E48"/>
+                </a:solidFill>
+                <a:latin typeface="Calibri" pitchFamily="34" charset="0"/>
+                <a:ea typeface="Calibri" pitchFamily="34" charset="-122"/>
+                <a:cs typeface="Calibri" pitchFamily="34" charset="-120"/>
+              </a:rPr>
+              <a:t>Services vitaux, RTO ~15 s mesuré, 2 playbooks, responsabilités</a:t>
+            </a:r>
+            <a:endParaRPr lang="en-US" sz="1350" dirty="0"/>
+          </a:p>
+        </p:txBody>
+      </p:sp>
+      <p:sp>
+        <p:nvSpPr>
+          <p:cNvPr id="10" name="Shape 8"/>
+          <p:cNvSpPr/>
+          <p:nvPr/>
+        </p:nvSpPr>
+        <p:spPr>
+          <a:xfrm>
+            <a:off x="548640" y="4114800"/>
+            <a:ext cx="11064240" cy="1005840"/>
+          </a:xfrm>
+          <a:prstGeom prst="roundRect">
+            <a:avLst>
+              <a:gd name="adj" fmla="val 7273"/>
+            </a:avLst>
+          </a:prstGeom>
+          <a:solidFill>
+            <a:srgbClr val="EEF0F8"/>
+          </a:solidFill>
+          <a:ln/>
+          <a:effectLst>
+            <a:outerShdw sx="100000" sy="100000" kx="0" ky="0" algn="bl" rotWithShape="0" blurRad="76200" dist="25400" dir="5400000">
+              <a:srgbClr val="888888">
+                <a:alpha val="25000"/>
+              </a:srgbClr>
+            </a:outerShdw>
+          </a:effectLst>
+        </p:spPr>
+      </p:sp>
+      <p:sp>
+        <p:nvSpPr>
+          <p:cNvPr id="11" name="Text 9"/>
+          <p:cNvSpPr txBox="1"/>
+          <p:nvPr/>
+        </p:nvSpPr>
+        <p:spPr>
+          <a:xfrm>
+            <a:off x="777240" y="4279392"/>
+            <a:ext cx="2743200" cy="640080"/>
+          </a:xfrm>
+          <a:prstGeom prst="rect">
+            <a:avLst/>
+          </a:prstGeom>
+          <a:noFill/>
+          <a:ln/>
+        </p:spPr>
+        <p:txBody>
+          <a:bodyPr wrap="square" lIns="0" tIns="0" rIns="0" bIns="0" rtlCol="0" anchor="ctr"/>
+          <a:lstStyle/>
+          <a:p>
+            <a:pPr indent="0" marL="0">
+              <a:buNone/>
+            </a:pPr>
+            <a:r>
+              <a:rPr lang="en-US" sz="1600" b="1" dirty="0">
+                <a:solidFill>
+                  <a:srgbClr val="4B3FA6"/>
+                </a:solidFill>
+                <a:latin typeface="Calibri" pitchFamily="34" charset="0"/>
+                <a:ea typeface="Calibri" pitchFamily="34" charset="-122"/>
+                <a:cs typeface="Calibri" pitchFamily="34" charset="-120"/>
+              </a:rPr>
+              <a:t>NIS2 / DORA</a:t>
+            </a:r>
+            <a:endParaRPr lang="en-US" sz="1600" dirty="0"/>
+          </a:p>
+        </p:txBody>
+      </p:sp>
+      <p:sp>
+        <p:nvSpPr>
+          <p:cNvPr id="12" name="Text 10"/>
+          <p:cNvSpPr txBox="1"/>
+          <p:nvPr/>
+        </p:nvSpPr>
+        <p:spPr>
+          <a:xfrm>
+            <a:off x="3566160" y="4297680"/>
+            <a:ext cx="7863840" cy="685800"/>
+          </a:xfrm>
+          <a:prstGeom prst="rect">
+            <a:avLst/>
+          </a:prstGeom>
+          <a:noFill/>
+          <a:ln/>
+        </p:spPr>
+        <p:txBody>
+          <a:bodyPr wrap="square" lIns="0" tIns="0" rIns="0" bIns="0" rtlCol="0" anchor="ctr"/>
+          <a:lstStyle/>
+          <a:p>
+            <a:pPr indent="0" marL="0">
+              <a:buNone/>
+            </a:pPr>
+            <a:r>
+              <a:rPr lang="en-US" sz="1350" dirty="0">
+                <a:solidFill>
+                  <a:srgbClr val="261E48"/>
+                </a:solidFill>
+                <a:latin typeface="Calibri" pitchFamily="34" charset="0"/>
+                <a:ea typeface="Calibri" pitchFamily="34" charset="-122"/>
+                <a:cs typeface="Calibri" pitchFamily="34" charset="-120"/>
+              </a:rPr>
+              <a:t>Exigences pertinentes vs non démontrables en 4 jours</a:t>
+            </a:r>
+            <a:endParaRPr lang="en-US" sz="1350" dirty="0"/>
+          </a:p>
+        </p:txBody>
+      </p:sp>
+      <p:sp>
+        <p:nvSpPr>
+          <p:cNvPr id="13" name="Text 11"/>
+          <p:cNvSpPr txBox="1"/>
+          <p:nvPr/>
+        </p:nvSpPr>
+        <p:spPr>
+          <a:xfrm>
+            <a:off x="548640" y="5486400"/>
+            <a:ext cx="10972800" cy="822960"/>
+          </a:xfrm>
+          <a:prstGeom prst="rect">
+            <a:avLst/>
+          </a:prstGeom>
+          <a:noFill/>
+          <a:ln/>
+        </p:spPr>
+        <p:txBody>
+          <a:bodyPr wrap="square" lIns="0" tIns="0" rIns="0" bIns="0" rtlCol="0" anchor="ctr"/>
+          <a:lstStyle/>
+          <a:p>
+            <a:pPr indent="0" marL="0">
+              <a:lnSpc>
+                <a:spcPct val="120000"/>
+              </a:lnSpc>
+              <a:buNone/>
+            </a:pPr>
+            <a:r>
+              <a:rPr lang="en-US" sz="1350" b="1" dirty="0">
+                <a:solidFill>
+                  <a:srgbClr val="261E48"/>
+                </a:solidFill>
+                <a:latin typeface="Calibri" pitchFamily="34" charset="0"/>
+                <a:ea typeface="Calibri" pitchFamily="34" charset="-122"/>
+                <a:cs typeface="Calibri" pitchFamily="34" charset="-120"/>
+              </a:rPr>
+              <a:t>Recommandations : industrialiser la reprise (HA + WAF réseau) · formaliser la notification d'incident · tests de résilience réguliers.</a:t>
+            </a:r>
+            <a:endParaRPr lang="en-US" sz="1350" dirty="0"/>
+          </a:p>
+        </p:txBody>
+      </p:sp>
+    </p:spTree>
+  </p:cSld>
+  <p:clrMapOvr>
+    <a:masterClrMapping/>
+  </p:clrMapOvr>
+</p:sld>
+</file>
+
+<file path=ppt/slides/slide11.xml><?xml version="1.0" encoding="utf-8"?>
+<p:sld xmlns:a="http://schemas.openxmlformats.org/drawingml/2006/main" xmlns:r="http://schemas.openxmlformats.org/officeDocument/2006/relationships" xmlns:p="http://schemas.openxmlformats.org/presentationml/2006/main">
+  <p:cSld name="Slide 11">
+    <p:bg>
+      <p:bgPr>
+        <a:solidFill>
           <a:srgbClr val="261E48"/>
         </a:solidFill>
       </p:bgPr>
@@ -5567,7 +6129,7 @@
                 <a:ea typeface="Calibri" pitchFamily="34" charset="-122"/>
                 <a:cs typeface="Calibri" pitchFamily="34" charset="-120"/>
               </a:rPr>
-              <a:t>CYBERSÉCURITÉ</a:t>
+              <a:t>MONTAGE 5 PC</a:t>
             </a:r>
             <a:endParaRPr lang="en-US" sz="1200" dirty="0"/>
           </a:p>
@@ -5606,7 +6168,7 @@
                 <a:ea typeface="Calibri" pitchFamily="34" charset="-122"/>
                 <a:cs typeface="Calibri" pitchFamily="34" charset="-120"/>
               </a:rPr>
-              <a:t>Défense &amp; sécurité</a:t>
+              <a:t>Haute disponibilité : le service ne tombe pas</a:t>
             </a:r>
             <a:endParaRPr lang="en-US" sz="3000" dirty="0"/>
           </a:p>
@@ -5620,12 +6182,12 @@
         </p:nvSpPr>
         <p:spPr>
           <a:xfrm>
-            <a:off x="548640" y="1737360"/>
-            <a:ext cx="3566160" cy="1828800"/>
+            <a:off x="548640" y="1645920"/>
+            <a:ext cx="5486400" cy="4114800"/>
           </a:xfrm>
           <a:prstGeom prst="roundRect">
             <a:avLst>
-              <a:gd name="adj" fmla="val 4000"/>
+              <a:gd name="adj" fmla="val 1778"/>
             </a:avLst>
           </a:prstGeom>
           <a:solidFill>
@@ -5649,34 +6211,34 @@
         </p:nvSpPr>
         <p:spPr>
           <a:xfrm>
-            <a:off x="731520" y="1920240"/>
-            <a:ext cx="914400" cy="548640"/>
-          </a:xfrm>
-          <a:prstGeom prst="rect">
-            <a:avLst/>
-          </a:prstGeom>
-          <a:noFill/>
-          <a:ln/>
-        </p:spPr>
-        <p:txBody>
-          <a:bodyPr wrap="square" lIns="0" tIns="0" rIns="0" bIns="0" rtlCol="0" anchor="ctr"/>
-          <a:lstStyle/>
-          <a:p>
-            <a:pPr indent="0" marL="0">
-              <a:buNone/>
-            </a:pPr>
-            <a:r>
-              <a:rPr lang="en-US" sz="2600" dirty="0">
-                <a:solidFill>
-                  <a:srgbClr val="000000"/>
-                </a:solidFill>
-                <a:latin typeface="Calibri" pitchFamily="34" charset="0"/>
-                <a:ea typeface="Calibri" pitchFamily="34" charset="-122"/>
-                <a:cs typeface="Calibri" pitchFamily="34" charset="-120"/>
-              </a:rPr>
-              <a:t>🛡️</a:t>
-            </a:r>
-            <a:endParaRPr lang="en-US" sz="2600" dirty="0"/>
+            <a:off x="777240" y="1810512"/>
+            <a:ext cx="5029200" cy="411480"/>
+          </a:xfrm>
+          <a:prstGeom prst="rect">
+            <a:avLst/>
+          </a:prstGeom>
+          <a:noFill/>
+          <a:ln/>
+        </p:spPr>
+        <p:txBody>
+          <a:bodyPr wrap="square" lIns="0" tIns="0" rIns="0" bIns="0" rtlCol="0" anchor="ctr"/>
+          <a:lstStyle/>
+          <a:p>
+            <a:pPr indent="0" marL="0">
+              <a:buNone/>
+            </a:pPr>
+            <a:r>
+              <a:rPr lang="en-US" sz="1500" b="1" dirty="0">
+                <a:solidFill>
+                  <a:srgbClr val="261E48"/>
+                </a:solidFill>
+                <a:latin typeface="Calibri" pitchFamily="34" charset="0"/>
+                <a:ea typeface="Calibri" pitchFamily="34" charset="-122"/>
+                <a:cs typeface="Calibri" pitchFamily="34" charset="-120"/>
+              </a:rPr>
+              <a:t>🖥️ Topologie</a:t>
+            </a:r>
+            <a:endParaRPr lang="en-US" sz="1500" dirty="0"/>
           </a:p>
         </p:txBody>
       </p:sp>
@@ -5688,24 +6250,27 @@
         </p:nvSpPr>
         <p:spPr>
           <a:xfrm>
-            <a:off x="731520" y="2514600"/>
-            <a:ext cx="3200400" cy="365760"/>
-          </a:xfrm>
-          <a:prstGeom prst="rect">
-            <a:avLst/>
-          </a:prstGeom>
-          <a:noFill/>
-          <a:ln/>
-        </p:spPr>
-        <p:txBody>
-          <a:bodyPr wrap="square" lIns="0" tIns="0" rIns="0" bIns="0" rtlCol="0" anchor="ctr"/>
-          <a:lstStyle/>
-          <a:p>
-            <a:pPr indent="0" marL="0">
-              <a:buNone/>
-            </a:pPr>
-            <a:r>
-              <a:rPr lang="en-US" sz="1500" b="1" dirty="0">
+            <a:off x="777240" y="2286000"/>
+            <a:ext cx="5074920" cy="3291840"/>
+          </a:xfrm>
+          <a:prstGeom prst="rect">
+            <a:avLst/>
+          </a:prstGeom>
+          <a:noFill/>
+          <a:ln/>
+        </p:spPr>
+        <p:txBody>
+          <a:bodyPr wrap="square" lIns="0" tIns="0" rIns="0" bIns="0" rtlCol="0" anchor="ctr"/>
+          <a:lstStyle/>
+          <a:p>
+            <a:pPr indent="0" marL="0">
+              <a:lnSpc>
+                <a:spcPct val="125000"/>
+              </a:lnSpc>
+              <a:buNone/>
+            </a:pPr>
+            <a:r>
+              <a:rPr lang="en-US" sz="1350" dirty="0">
                 <a:solidFill>
                   <a:srgbClr val="261E48"/>
                 </a:solidFill>
@@ -5713,69 +6278,130 @@
                 <a:ea typeface="Calibri" pitchFamily="34" charset="-122"/>
                 <a:cs typeface="Calibri" pitchFamily="34" charset="-120"/>
               </a:rPr>
-              <a:t>WAF applicatif</a:t>
-            </a:r>
-            <a:endParaRPr lang="en-US" sz="1500" dirty="0"/>
-          </a:p>
-        </p:txBody>
-      </p:sp>
-      <p:sp>
-        <p:nvSpPr>
-          <p:cNvPr id="7" name="Text 5"/>
-          <p:cNvSpPr txBox="1"/>
-          <p:nvPr/>
-        </p:nvSpPr>
-        <p:spPr>
-          <a:xfrm>
-            <a:off x="731520" y="2880360"/>
-            <a:ext cx="3200400" cy="594360"/>
-          </a:xfrm>
-          <a:prstGeom prst="rect">
-            <a:avLst/>
-          </a:prstGeom>
-          <a:noFill/>
-          <a:ln/>
-        </p:spPr>
-        <p:txBody>
-          <a:bodyPr wrap="square" lIns="0" tIns="0" rIns="0" bIns="0" rtlCol="0" anchor="ctr"/>
-          <a:lstStyle/>
-          <a:p>
-            <a:pPr indent="0" marL="0">
-              <a:buNone/>
-            </a:pPr>
-            <a:r>
-              <a:rPr lang="en-US" sz="1200" dirty="0">
-                <a:solidFill>
-                  <a:srgbClr val="6A6594"/>
-                </a:solidFill>
-                <a:latin typeface="Calibri" pitchFamily="34" charset="0"/>
-                <a:ea typeface="Calibri" pitchFamily="34" charset="-122"/>
-                <a:cs typeface="Calibri" pitchFamily="34" charset="-120"/>
-              </a:rPr>
-              <a:t>SQLi/XSS bloqués (403) + métrique + log</a:t>
-            </a:r>
-            <a:endParaRPr lang="en-US" sz="1200" dirty="0"/>
-          </a:p>
-        </p:txBody>
-      </p:sp>
-      <p:sp>
-        <p:nvSpPr>
-          <p:cNvPr id="8" name="Shape 6"/>
+              <a:t>• HOST-PRINCIPAL : serveur + cockpit</a:t>
+            </a:r>
+            <a:endParaRPr lang="en-US" sz="1350" dirty="0"/>
+          </a:p>
+          <a:p>
+            <a:pPr indent="0" marL="0">
+              <a:lnSpc>
+                <a:spcPct val="125000"/>
+              </a:lnSpc>
+              <a:buNone/>
+            </a:pPr>
+            <a:r>
+              <a:rPr lang="en-US" sz="1350" dirty="0">
+                <a:solidFill>
+                  <a:srgbClr val="261E48"/>
+                </a:solidFill>
+                <a:latin typeface="Calibri" pitchFamily="34" charset="0"/>
+                <a:ea typeface="Calibri" pitchFamily="34" charset="-122"/>
+                <a:cs typeface="Calibri" pitchFamily="34" charset="-120"/>
+              </a:rPr>
+              <a:t>• HOST-BACKUP : réplique le principal</a:t>
+            </a:r>
+            <a:endParaRPr lang="en-US" sz="1350" dirty="0"/>
+          </a:p>
+          <a:p>
+            <a:pPr indent="0" marL="0">
+              <a:lnSpc>
+                <a:spcPct val="125000"/>
+              </a:lnSpc>
+              <a:buNone/>
+            </a:pPr>
+            <a:r>
+              <a:rPr lang="en-US" sz="1350" dirty="0">
+                <a:solidFill>
+                  <a:srgbClr val="261E48"/>
+                </a:solidFill>
+                <a:latin typeface="Calibri" pitchFamily="34" charset="0"/>
+                <a:ea typeface="Calibri" pitchFamily="34" charset="-122"/>
+                <a:cs typeface="Calibri" pitchFamily="34" charset="-120"/>
+              </a:rPr>
+              <a:t>  (comptes + clés d'idempotence)</a:t>
+            </a:r>
+            <a:endParaRPr lang="en-US" sz="1350" dirty="0"/>
+          </a:p>
+          <a:p>
+            <a:pPr indent="0" marL="0">
+              <a:lnSpc>
+                <a:spcPct val="125000"/>
+              </a:lnSpc>
+              <a:buNone/>
+            </a:pPr>
+            <a:r>
+              <a:rPr lang="en-US" sz="1350" dirty="0">
+                <a:solidFill>
+                  <a:srgbClr val="261E48"/>
+                </a:solidFill>
+                <a:latin typeface="Calibri" pitchFamily="34" charset="0"/>
+                <a:ea typeface="Calibri" pitchFamily="34" charset="-122"/>
+                <a:cs typeface="Calibri" pitchFamily="34" charset="-120"/>
+              </a:rPr>
+              <a:t>• CLIENT-A / CLIENT-B : app de paiement</a:t>
+            </a:r>
+            <a:endParaRPr lang="en-US" sz="1350" dirty="0"/>
+          </a:p>
+          <a:p>
+            <a:pPr indent="0" marL="0">
+              <a:lnSpc>
+                <a:spcPct val="125000"/>
+              </a:lnSpc>
+              <a:buNone/>
+            </a:pPr>
+            <a:r>
+              <a:rPr lang="en-US" sz="1350" dirty="0">
+                <a:solidFill>
+                  <a:srgbClr val="261E48"/>
+                </a:solidFill>
+                <a:latin typeface="Calibri" pitchFamily="34" charset="0"/>
+                <a:ea typeface="Calibri" pitchFamily="34" charset="-122"/>
+                <a:cs typeface="Calibri" pitchFamily="34" charset="-120"/>
+              </a:rPr>
+              <a:t>  (login + recherche + transfert)</a:t>
+            </a:r>
+            <a:endParaRPr lang="en-US" sz="1350" dirty="0"/>
+          </a:p>
+          <a:p>
+            <a:pPr indent="0" marL="0">
+              <a:lnSpc>
+                <a:spcPct val="125000"/>
+              </a:lnSpc>
+              <a:buNone/>
+            </a:pPr>
+            <a:r>
+              <a:rPr lang="en-US" sz="1350" dirty="0">
+                <a:solidFill>
+                  <a:srgbClr val="261E48"/>
+                </a:solidFill>
+                <a:latin typeface="Calibri" pitchFamily="34" charset="0"/>
+                <a:ea typeface="Calibri" pitchFamily="34" charset="-122"/>
+                <a:cs typeface="Calibri" pitchFamily="34" charset="-120"/>
+              </a:rPr>
+              <a:t>• ATTAQUANT : vise le principal</a:t>
+            </a:r>
+            <a:endParaRPr lang="en-US" sz="1350" dirty="0"/>
+          </a:p>
+        </p:txBody>
+      </p:sp>
+      <p:sp>
+        <p:nvSpPr>
+          <p:cNvPr id="7" name="Shape 5"/>
           <p:cNvSpPr/>
           <p:nvPr/>
         </p:nvSpPr>
         <p:spPr>
           <a:xfrm>
-            <a:off x="4297680" y="1737360"/>
-            <a:ext cx="3566160" cy="1828800"/>
+            <a:off x="6217920" y="1645920"/>
+            <a:ext cx="5394960" cy="4114800"/>
           </a:xfrm>
           <a:prstGeom prst="roundRect">
             <a:avLst>
-              <a:gd name="adj" fmla="val 4000"/>
+              <a:gd name="adj" fmla="val 1778"/>
             </a:avLst>
           </a:prstGeom>
           <a:solidFill>
-            <a:srgbClr val="EEF0F8"/>
+            <a:srgbClr val="E3F3EC"/>
           </a:solidFill>
           <a:ln/>
           <a:effectLst>
@@ -5789,40 +6415,162 @@
       </p:sp>
       <p:sp>
         <p:nvSpPr>
+          <p:cNvPr id="8" name="Text 6"/>
+          <p:cNvSpPr txBox="1"/>
+          <p:nvPr/>
+        </p:nvSpPr>
+        <p:spPr>
+          <a:xfrm>
+            <a:off x="6446520" y="1810512"/>
+            <a:ext cx="4937760" cy="411480"/>
+          </a:xfrm>
+          <a:prstGeom prst="rect">
+            <a:avLst/>
+          </a:prstGeom>
+          <a:noFill/>
+          <a:ln/>
+        </p:spPr>
+        <p:txBody>
+          <a:bodyPr wrap="square" lIns="0" tIns="0" rIns="0" bIns="0" rtlCol="0" anchor="ctr"/>
+          <a:lstStyle/>
+          <a:p>
+            <a:pPr indent="0" marL="0">
+              <a:buNone/>
+            </a:pPr>
+            <a:r>
+              <a:rPr lang="en-US" sz="1500" b="1" dirty="0">
+                <a:solidFill>
+                  <a:srgbClr val="1E8E6A"/>
+                </a:solidFill>
+                <a:latin typeface="Calibri" pitchFamily="34" charset="0"/>
+                <a:ea typeface="Calibri" pitchFamily="34" charset="-122"/>
+                <a:cs typeface="Calibri" pitchFamily="34" charset="-120"/>
+              </a:rPr>
+              <a:t>🔁 Bascule &amp; reprise</a:t>
+            </a:r>
+            <a:endParaRPr lang="en-US" sz="1500" dirty="0"/>
+          </a:p>
+        </p:txBody>
+      </p:sp>
+      <p:sp>
+        <p:nvSpPr>
           <p:cNvPr id="9" name="Text 7"/>
           <p:cNvSpPr txBox="1"/>
           <p:nvPr/>
         </p:nvSpPr>
         <p:spPr>
           <a:xfrm>
-            <a:off x="4480560" y="1920240"/>
-            <a:ext cx="914400" cy="548640"/>
-          </a:xfrm>
-          <a:prstGeom prst="rect">
-            <a:avLst/>
-          </a:prstGeom>
-          <a:noFill/>
-          <a:ln/>
-        </p:spPr>
-        <p:txBody>
-          <a:bodyPr wrap="square" lIns="0" tIns="0" rIns="0" bIns="0" rtlCol="0" anchor="ctr"/>
-          <a:lstStyle/>
-          <a:p>
-            <a:pPr indent="0" marL="0">
-              <a:buNone/>
-            </a:pPr>
-            <a:r>
-              <a:rPr lang="en-US" sz="2600" dirty="0">
-                <a:solidFill>
-                  <a:srgbClr val="000000"/>
-                </a:solidFill>
-                <a:latin typeface="Calibri" pitchFamily="34" charset="0"/>
-                <a:ea typeface="Calibri" pitchFamily="34" charset="-122"/>
-                <a:cs typeface="Calibri" pitchFamily="34" charset="-120"/>
-              </a:rPr>
-              <a:t>📊</a:t>
-            </a:r>
-            <a:endParaRPr lang="en-US" sz="2600" dirty="0"/>
+            <a:off x="6446520" y="2286000"/>
+            <a:ext cx="4983480" cy="2743200"/>
+          </a:xfrm>
+          <a:prstGeom prst="rect">
+            <a:avLst/>
+          </a:prstGeom>
+          <a:noFill/>
+          <a:ln/>
+        </p:spPr>
+        <p:txBody>
+          <a:bodyPr wrap="square" lIns="0" tIns="0" rIns="0" bIns="0" rtlCol="0" anchor="ctr"/>
+          <a:lstStyle/>
+          <a:p>
+            <a:pPr indent="0" marL="0">
+              <a:lnSpc>
+                <a:spcPct val="130000"/>
+              </a:lnSpc>
+              <a:buNone/>
+            </a:pPr>
+            <a:r>
+              <a:rPr lang="en-US" sz="1350" dirty="0">
+                <a:solidFill>
+                  <a:srgbClr val="261E48"/>
+                </a:solidFill>
+                <a:latin typeface="Calibri" pitchFamily="34" charset="0"/>
+                <a:ea typeface="Calibri" pitchFamily="34" charset="-122"/>
+                <a:cs typeface="Calibri" pitchFamily="34" charset="-120"/>
+              </a:rPr>
+              <a:t>1. Le serveur principal tombe</a:t>
+            </a:r>
+            <a:endParaRPr lang="en-US" sz="1350" dirty="0"/>
+          </a:p>
+          <a:p>
+            <a:pPr indent="0" marL="0">
+              <a:lnSpc>
+                <a:spcPct val="130000"/>
+              </a:lnSpc>
+              <a:buNone/>
+            </a:pPr>
+            <a:r>
+              <a:rPr lang="en-US" sz="1350" dirty="0">
+                <a:solidFill>
+                  <a:srgbClr val="261E48"/>
+                </a:solidFill>
+                <a:latin typeface="Calibri" pitchFamily="34" charset="0"/>
+                <a:ea typeface="Calibri" pitchFamily="34" charset="-122"/>
+                <a:cs typeface="Calibri" pitchFamily="34" charset="-120"/>
+              </a:rPr>
+              <a:t>2. Le client bascule AUTOMATIQUEMENT sur le backup</a:t>
+            </a:r>
+            <a:endParaRPr lang="en-US" sz="1350" dirty="0"/>
+          </a:p>
+          <a:p>
+            <a:pPr indent="0" marL="0">
+              <a:lnSpc>
+                <a:spcPct val="130000"/>
+              </a:lnSpc>
+              <a:buNone/>
+            </a:pPr>
+            <a:r>
+              <a:rPr lang="en-US" sz="1350" dirty="0">
+                <a:solidFill>
+                  <a:srgbClr val="261E48"/>
+                </a:solidFill>
+                <a:latin typeface="Calibri" pitchFamily="34" charset="0"/>
+                <a:ea typeface="Calibri" pitchFamily="34" charset="-122"/>
+                <a:cs typeface="Calibri" pitchFamily="34" charset="-120"/>
+              </a:rPr>
+              <a:t>3. La transaction en cours est REPRISE</a:t>
+            </a:r>
+            <a:endParaRPr lang="en-US" sz="1350" dirty="0"/>
+          </a:p>
+          <a:p>
+            <a:pPr indent="0" marL="0">
+              <a:lnSpc>
+                <a:spcPct val="130000"/>
+              </a:lnSpc>
+              <a:buNone/>
+            </a:pPr>
+            <a:r>
+              <a:rPr lang="en-US" sz="1350" dirty="0">
+                <a:solidFill>
+                  <a:srgbClr val="261E48"/>
+                </a:solidFill>
+                <a:latin typeface="Calibri" pitchFamily="34" charset="0"/>
+                <a:ea typeface="Calibri" pitchFamily="34" charset="-122"/>
+                <a:cs typeface="Calibri" pitchFamily="34" charset="-120"/>
+              </a:rPr>
+              <a:t>   (clé d'idempotence) — sans double débit</a:t>
+            </a:r>
+            <a:endParaRPr lang="en-US" sz="1350" dirty="0"/>
+          </a:p>
+          <a:p>
+            <a:pPr indent="0" marL="0">
+              <a:lnSpc>
+                <a:spcPct val="130000"/>
+              </a:lnSpc>
+              <a:buNone/>
+            </a:pPr>
+            <a:r>
+              <a:rPr lang="en-US" sz="1350" dirty="0">
+                <a:solidFill>
+                  <a:srgbClr val="261E48"/>
+                </a:solidFill>
+                <a:latin typeface="Calibri" pitchFamily="34" charset="0"/>
+                <a:ea typeface="Calibri" pitchFamily="34" charset="-122"/>
+                <a:cs typeface="Calibri" pitchFamily="34" charset="-120"/>
+              </a:rPr>
+              <a:t>4. Service maintenu, zéro intervention</a:t>
+            </a:r>
+            <a:endParaRPr lang="en-US" sz="1350" dirty="0"/>
           </a:p>
         </p:txBody>
       </p:sp>
@@ -5834,8 +6582,8 @@
         </p:nvSpPr>
         <p:spPr>
           <a:xfrm>
-            <a:off x="4480560" y="2514600"/>
-            <a:ext cx="3200400" cy="365760"/>
+            <a:off x="6446520" y="5212080"/>
+            <a:ext cx="4937760" cy="457200"/>
           </a:xfrm>
           <a:prstGeom prst="rect">
             <a:avLst/>
@@ -5853,638 +6601,15 @@
             <a:r>
               <a:rPr lang="en-US" sz="1500" b="1" dirty="0">
                 <a:solidFill>
-                  <a:srgbClr val="261E48"/>
-                </a:solidFill>
-                <a:latin typeface="Calibri" pitchFamily="34" charset="0"/>
-                <a:ea typeface="Calibri" pitchFamily="34" charset="-122"/>
-                <a:cs typeface="Calibri" pitchFamily="34" charset="-120"/>
-              </a:rPr>
-              <a:t>Fonction SOC</a:t>
+                  <a:srgbClr val="1E8E6A"/>
+                </a:solidFill>
+                <a:latin typeface="Calibri" pitchFamily="34" charset="0"/>
+                <a:ea typeface="Calibri" pitchFamily="34" charset="-122"/>
+                <a:cs typeface="Calibri" pitchFamily="34" charset="-120"/>
+              </a:rPr>
+              <a:t>Recette failover : 13 / 13 ✓</a:t>
             </a:r>
             <a:endParaRPr lang="en-US" sz="1500" dirty="0"/>
-          </a:p>
-        </p:txBody>
-      </p:sp>
-      <p:sp>
-        <p:nvSpPr>
-          <p:cNvPr id="11" name="Text 9"/>
-          <p:cNvSpPr txBox="1"/>
-          <p:nvPr/>
-        </p:nvSpPr>
-        <p:spPr>
-          <a:xfrm>
-            <a:off x="4480560" y="2880360"/>
-            <a:ext cx="3200400" cy="594360"/>
-          </a:xfrm>
-          <a:prstGeom prst="rect">
-            <a:avLst/>
-          </a:prstGeom>
-          <a:noFill/>
-          <a:ln/>
-        </p:spPr>
-        <p:txBody>
-          <a:bodyPr wrap="square" lIns="0" tIns="0" rIns="0" bIns="0" rtlCol="0" anchor="ctr"/>
-          <a:lstStyle/>
-          <a:p>
-            <a:pPr indent="0" marL="0">
-              <a:buNone/>
-            </a:pPr>
-            <a:r>
-              <a:rPr lang="en-US" sz="1200" dirty="0">
-                <a:solidFill>
-                  <a:srgbClr val="6A6594"/>
-                </a:solidFill>
-                <a:latin typeface="Calibri" pitchFamily="34" charset="0"/>
-                <a:ea typeface="Calibri" pitchFamily="34" charset="-122"/>
-                <a:cs typeface="Calibri" pitchFamily="34" charset="-120"/>
-              </a:rPr>
-              <a:t>Loki + Prometheus + vue SOC du cockpit</a:t>
-            </a:r>
-            <a:endParaRPr lang="en-US" sz="1200" dirty="0"/>
-          </a:p>
-        </p:txBody>
-      </p:sp>
-      <p:sp>
-        <p:nvSpPr>
-          <p:cNvPr id="12" name="Shape 10"/>
-          <p:cNvSpPr/>
-          <p:nvPr/>
-        </p:nvSpPr>
-        <p:spPr>
-          <a:xfrm>
-            <a:off x="8046720" y="1737360"/>
-            <a:ext cx="3566160" cy="1828800"/>
-          </a:xfrm>
-          <a:prstGeom prst="roundRect">
-            <a:avLst>
-              <a:gd name="adj" fmla="val 4000"/>
-            </a:avLst>
-          </a:prstGeom>
-          <a:solidFill>
-            <a:srgbClr val="EEF0F8"/>
-          </a:solidFill>
-          <a:ln/>
-          <a:effectLst>
-            <a:outerShdw sx="100000" sy="100000" kx="0" ky="0" algn="bl" rotWithShape="0" blurRad="76200" dist="25400" dir="5400000">
-              <a:srgbClr val="888888">
-                <a:alpha val="25000"/>
-              </a:srgbClr>
-            </a:outerShdw>
-          </a:effectLst>
-        </p:spPr>
-      </p:sp>
-      <p:sp>
-        <p:nvSpPr>
-          <p:cNvPr id="13" name="Text 11"/>
-          <p:cNvSpPr txBox="1"/>
-          <p:nvPr/>
-        </p:nvSpPr>
-        <p:spPr>
-          <a:xfrm>
-            <a:off x="8229600" y="1920240"/>
-            <a:ext cx="914400" cy="548640"/>
-          </a:xfrm>
-          <a:prstGeom prst="rect">
-            <a:avLst/>
-          </a:prstGeom>
-          <a:noFill/>
-          <a:ln/>
-        </p:spPr>
-        <p:txBody>
-          <a:bodyPr wrap="square" lIns="0" tIns="0" rIns="0" bIns="0" rtlCol="0" anchor="ctr"/>
-          <a:lstStyle/>
-          <a:p>
-            <a:pPr indent="0" marL="0">
-              <a:buNone/>
-            </a:pPr>
-            <a:r>
-              <a:rPr lang="en-US" sz="2600" dirty="0">
-                <a:solidFill>
-                  <a:srgbClr val="000000"/>
-                </a:solidFill>
-                <a:latin typeface="Calibri" pitchFamily="34" charset="0"/>
-                <a:ea typeface="Calibri" pitchFamily="34" charset="-122"/>
-                <a:cs typeface="Calibri" pitchFamily="34" charset="-120"/>
-              </a:rPr>
-              <a:t>🔑</a:t>
-            </a:r>
-            <a:endParaRPr lang="en-US" sz="2600" dirty="0"/>
-          </a:p>
-        </p:txBody>
-      </p:sp>
-      <p:sp>
-        <p:nvSpPr>
-          <p:cNvPr id="14" name="Text 12"/>
-          <p:cNvSpPr txBox="1"/>
-          <p:nvPr/>
-        </p:nvSpPr>
-        <p:spPr>
-          <a:xfrm>
-            <a:off x="8229600" y="2514600"/>
-            <a:ext cx="3200400" cy="365760"/>
-          </a:xfrm>
-          <a:prstGeom prst="rect">
-            <a:avLst/>
-          </a:prstGeom>
-          <a:noFill/>
-          <a:ln/>
-        </p:spPr>
-        <p:txBody>
-          <a:bodyPr wrap="square" lIns="0" tIns="0" rIns="0" bIns="0" rtlCol="0" anchor="ctr"/>
-          <a:lstStyle/>
-          <a:p>
-            <a:pPr indent="0" marL="0">
-              <a:buNone/>
-            </a:pPr>
-            <a:r>
-              <a:rPr lang="en-US" sz="1500" b="1" dirty="0">
-                <a:solidFill>
-                  <a:srgbClr val="261E48"/>
-                </a:solidFill>
-                <a:latin typeface="Calibri" pitchFamily="34" charset="0"/>
-                <a:ea typeface="Calibri" pitchFamily="34" charset="-122"/>
-                <a:cs typeface="Calibri" pitchFamily="34" charset="-120"/>
-              </a:rPr>
-              <a:t>Secrets</a:t>
-            </a:r>
-            <a:endParaRPr lang="en-US" sz="1500" dirty="0"/>
-          </a:p>
-        </p:txBody>
-      </p:sp>
-      <p:sp>
-        <p:nvSpPr>
-          <p:cNvPr id="15" name="Text 13"/>
-          <p:cNvSpPr txBox="1"/>
-          <p:nvPr/>
-        </p:nvSpPr>
-        <p:spPr>
-          <a:xfrm>
-            <a:off x="8229600" y="2880360"/>
-            <a:ext cx="3200400" cy="594360"/>
-          </a:xfrm>
-          <a:prstGeom prst="rect">
-            <a:avLst/>
-          </a:prstGeom>
-          <a:noFill/>
-          <a:ln/>
-        </p:spPr>
-        <p:txBody>
-          <a:bodyPr wrap="square" lIns="0" tIns="0" rIns="0" bIns="0" rtlCol="0" anchor="ctr"/>
-          <a:lstStyle/>
-          <a:p>
-            <a:pPr indent="0" marL="0">
-              <a:buNone/>
-            </a:pPr>
-            <a:r>
-              <a:rPr lang="en-US" sz="1200" dirty="0">
-                <a:solidFill>
-                  <a:srgbClr val="6A6594"/>
-                </a:solidFill>
-                <a:latin typeface="Calibri" pitchFamily="34" charset="0"/>
-                <a:ea typeface="Calibri" pitchFamily="34" charset="-122"/>
-                <a:cs typeface="Calibri" pitchFamily="34" charset="-120"/>
-              </a:rPr>
-              <a:t>chiffrés (SOPS + age), rien en clair</a:t>
-            </a:r>
-            <a:endParaRPr lang="en-US" sz="1200" dirty="0"/>
-          </a:p>
-        </p:txBody>
-      </p:sp>
-      <p:sp>
-        <p:nvSpPr>
-          <p:cNvPr id="16" name="Shape 14"/>
-          <p:cNvSpPr/>
-          <p:nvPr/>
-        </p:nvSpPr>
-        <p:spPr>
-          <a:xfrm>
-            <a:off x="548640" y="3840480"/>
-            <a:ext cx="3566160" cy="1828800"/>
-          </a:xfrm>
-          <a:prstGeom prst="roundRect">
-            <a:avLst>
-              <a:gd name="adj" fmla="val 4000"/>
-            </a:avLst>
-          </a:prstGeom>
-          <a:solidFill>
-            <a:srgbClr val="EEF0F8"/>
-          </a:solidFill>
-          <a:ln/>
-          <a:effectLst>
-            <a:outerShdw sx="100000" sy="100000" kx="0" ky="0" algn="bl" rotWithShape="0" blurRad="76200" dist="25400" dir="5400000">
-              <a:srgbClr val="888888">
-                <a:alpha val="25000"/>
-              </a:srgbClr>
-            </a:outerShdw>
-          </a:effectLst>
-        </p:spPr>
-      </p:sp>
-      <p:sp>
-        <p:nvSpPr>
-          <p:cNvPr id="17" name="Text 15"/>
-          <p:cNvSpPr txBox="1"/>
-          <p:nvPr/>
-        </p:nvSpPr>
-        <p:spPr>
-          <a:xfrm>
-            <a:off x="731520" y="4023360"/>
-            <a:ext cx="914400" cy="548640"/>
-          </a:xfrm>
-          <a:prstGeom prst="rect">
-            <a:avLst/>
-          </a:prstGeom>
-          <a:noFill/>
-          <a:ln/>
-        </p:spPr>
-        <p:txBody>
-          <a:bodyPr wrap="square" lIns="0" tIns="0" rIns="0" bIns="0" rtlCol="0" anchor="ctr"/>
-          <a:lstStyle/>
-          <a:p>
-            <a:pPr indent="0" marL="0">
-              <a:buNone/>
-            </a:pPr>
-            <a:r>
-              <a:rPr lang="en-US" sz="2600" dirty="0">
-                <a:solidFill>
-                  <a:srgbClr val="000000"/>
-                </a:solidFill>
-                <a:latin typeface="Calibri" pitchFamily="34" charset="0"/>
-                <a:ea typeface="Calibri" pitchFamily="34" charset="-122"/>
-                <a:cs typeface="Calibri" pitchFamily="34" charset="-120"/>
-              </a:rPr>
-              <a:t>🔒</a:t>
-            </a:r>
-            <a:endParaRPr lang="en-US" sz="2600" dirty="0"/>
-          </a:p>
-        </p:txBody>
-      </p:sp>
-      <p:sp>
-        <p:nvSpPr>
-          <p:cNvPr id="18" name="Text 16"/>
-          <p:cNvSpPr txBox="1"/>
-          <p:nvPr/>
-        </p:nvSpPr>
-        <p:spPr>
-          <a:xfrm>
-            <a:off x="731520" y="4617720"/>
-            <a:ext cx="3200400" cy="365760"/>
-          </a:xfrm>
-          <a:prstGeom prst="rect">
-            <a:avLst/>
-          </a:prstGeom>
-          <a:noFill/>
-          <a:ln/>
-        </p:spPr>
-        <p:txBody>
-          <a:bodyPr wrap="square" lIns="0" tIns="0" rIns="0" bIns="0" rtlCol="0" anchor="ctr"/>
-          <a:lstStyle/>
-          <a:p>
-            <a:pPr indent="0" marL="0">
-              <a:buNone/>
-            </a:pPr>
-            <a:r>
-              <a:rPr lang="en-US" sz="1500" b="1" dirty="0">
-                <a:solidFill>
-                  <a:srgbClr val="261E48"/>
-                </a:solidFill>
-                <a:latin typeface="Calibri" pitchFamily="34" charset="0"/>
-                <a:ea typeface="Calibri" pitchFamily="34" charset="-122"/>
-                <a:cs typeface="Calibri" pitchFamily="34" charset="-120"/>
-              </a:rPr>
-              <a:t>Durcissement</a:t>
-            </a:r>
-            <a:endParaRPr lang="en-US" sz="1500" dirty="0"/>
-          </a:p>
-        </p:txBody>
-      </p:sp>
-      <p:sp>
-        <p:nvSpPr>
-          <p:cNvPr id="19" name="Text 17"/>
-          <p:cNvSpPr txBox="1"/>
-          <p:nvPr/>
-        </p:nvSpPr>
-        <p:spPr>
-          <a:xfrm>
-            <a:off x="731520" y="4983480"/>
-            <a:ext cx="3200400" cy="594360"/>
-          </a:xfrm>
-          <a:prstGeom prst="rect">
-            <a:avLst/>
-          </a:prstGeom>
-          <a:noFill/>
-          <a:ln/>
-        </p:spPr>
-        <p:txBody>
-          <a:bodyPr wrap="square" lIns="0" tIns="0" rIns="0" bIns="0" rtlCol="0" anchor="ctr"/>
-          <a:lstStyle/>
-          <a:p>
-            <a:pPr indent="0" marL="0">
-              <a:buNone/>
-            </a:pPr>
-            <a:r>
-              <a:rPr lang="en-US" sz="1200" dirty="0">
-                <a:solidFill>
-                  <a:srgbClr val="6A6594"/>
-                </a:solidFill>
-                <a:latin typeface="Calibri" pitchFamily="34" charset="0"/>
-                <a:ea typeface="Calibri" pitchFamily="34" charset="-122"/>
-                <a:cs typeface="Calibri" pitchFamily="34" charset="-120"/>
-              </a:rPr>
-              <a:t>no-new-privileges, base non exposée</a:t>
-            </a:r>
-            <a:endParaRPr lang="en-US" sz="1200" dirty="0"/>
-          </a:p>
-        </p:txBody>
-      </p:sp>
-      <p:sp>
-        <p:nvSpPr>
-          <p:cNvPr id="20" name="Shape 18"/>
-          <p:cNvSpPr/>
-          <p:nvPr/>
-        </p:nvSpPr>
-        <p:spPr>
-          <a:xfrm>
-            <a:off x="4297680" y="3840480"/>
-            <a:ext cx="3566160" cy="1828800"/>
-          </a:xfrm>
-          <a:prstGeom prst="roundRect">
-            <a:avLst>
-              <a:gd name="adj" fmla="val 4000"/>
-            </a:avLst>
-          </a:prstGeom>
-          <a:solidFill>
-            <a:srgbClr val="EEF0F8"/>
-          </a:solidFill>
-          <a:ln/>
-          <a:effectLst>
-            <a:outerShdw sx="100000" sy="100000" kx="0" ky="0" algn="bl" rotWithShape="0" blurRad="76200" dist="25400" dir="5400000">
-              <a:srgbClr val="888888">
-                <a:alpha val="25000"/>
-              </a:srgbClr>
-            </a:outerShdw>
-          </a:effectLst>
-        </p:spPr>
-      </p:sp>
-      <p:sp>
-        <p:nvSpPr>
-          <p:cNvPr id="21" name="Text 19"/>
-          <p:cNvSpPr txBox="1"/>
-          <p:nvPr/>
-        </p:nvSpPr>
-        <p:spPr>
-          <a:xfrm>
-            <a:off x="4480560" y="4023360"/>
-            <a:ext cx="914400" cy="548640"/>
-          </a:xfrm>
-          <a:prstGeom prst="rect">
-            <a:avLst/>
-          </a:prstGeom>
-          <a:noFill/>
-          <a:ln/>
-        </p:spPr>
-        <p:txBody>
-          <a:bodyPr wrap="square" lIns="0" tIns="0" rIns="0" bIns="0" rtlCol="0" anchor="ctr"/>
-          <a:lstStyle/>
-          <a:p>
-            <a:pPr indent="0" marL="0">
-              <a:buNone/>
-            </a:pPr>
-            <a:r>
-              <a:rPr lang="en-US" sz="2600" dirty="0">
-                <a:solidFill>
-                  <a:srgbClr val="000000"/>
-                </a:solidFill>
-                <a:latin typeface="Calibri" pitchFamily="34" charset="0"/>
-                <a:ea typeface="Calibri" pitchFamily="34" charset="-122"/>
-                <a:cs typeface="Calibri" pitchFamily="34" charset="-120"/>
-              </a:rPr>
-              <a:t>🧩</a:t>
-            </a:r>
-            <a:endParaRPr lang="en-US" sz="2600" dirty="0"/>
-          </a:p>
-        </p:txBody>
-      </p:sp>
-      <p:sp>
-        <p:nvSpPr>
-          <p:cNvPr id="22" name="Text 20"/>
-          <p:cNvSpPr txBox="1"/>
-          <p:nvPr/>
-        </p:nvSpPr>
-        <p:spPr>
-          <a:xfrm>
-            <a:off x="4480560" y="4617720"/>
-            <a:ext cx="3200400" cy="365760"/>
-          </a:xfrm>
-          <a:prstGeom prst="rect">
-            <a:avLst/>
-          </a:prstGeom>
-          <a:noFill/>
-          <a:ln/>
-        </p:spPr>
-        <p:txBody>
-          <a:bodyPr wrap="square" lIns="0" tIns="0" rIns="0" bIns="0" rtlCol="0" anchor="ctr"/>
-          <a:lstStyle/>
-          <a:p>
-            <a:pPr indent="0" marL="0">
-              <a:buNone/>
-            </a:pPr>
-            <a:r>
-              <a:rPr lang="en-US" sz="1500" b="1" dirty="0">
-                <a:solidFill>
-                  <a:srgbClr val="261E48"/>
-                </a:solidFill>
-                <a:latin typeface="Calibri" pitchFamily="34" charset="0"/>
-                <a:ea typeface="Calibri" pitchFamily="34" charset="-122"/>
-                <a:cs typeface="Calibri" pitchFamily="34" charset="-120"/>
-              </a:rPr>
-              <a:t>Moindre privilège</a:t>
-            </a:r>
-            <a:endParaRPr lang="en-US" sz="1500" dirty="0"/>
-          </a:p>
-        </p:txBody>
-      </p:sp>
-      <p:sp>
-        <p:nvSpPr>
-          <p:cNvPr id="23" name="Text 21"/>
-          <p:cNvSpPr txBox="1"/>
-          <p:nvPr/>
-        </p:nvSpPr>
-        <p:spPr>
-          <a:xfrm>
-            <a:off x="4480560" y="4983480"/>
-            <a:ext cx="3200400" cy="594360"/>
-          </a:xfrm>
-          <a:prstGeom prst="rect">
-            <a:avLst/>
-          </a:prstGeom>
-          <a:noFill/>
-          <a:ln/>
-        </p:spPr>
-        <p:txBody>
-          <a:bodyPr wrap="square" lIns="0" tIns="0" rIns="0" bIns="0" rtlCol="0" anchor="ctr"/>
-          <a:lstStyle/>
-          <a:p>
-            <a:pPr indent="0" marL="0">
-              <a:buNone/>
-            </a:pPr>
-            <a:r>
-              <a:rPr lang="en-US" sz="1200" dirty="0">
-                <a:solidFill>
-                  <a:srgbClr val="6A6594"/>
-                </a:solidFill>
-                <a:latin typeface="Calibri" pitchFamily="34" charset="0"/>
-                <a:ea typeface="Calibri" pitchFamily="34" charset="-122"/>
-                <a:cs typeface="Calibri" pitchFamily="34" charset="-120"/>
-              </a:rPr>
-              <a:t>token d'admin dédié à l'orchestrateur</a:t>
-            </a:r>
-            <a:endParaRPr lang="en-US" sz="1200" dirty="0"/>
-          </a:p>
-        </p:txBody>
-      </p:sp>
-      <p:sp>
-        <p:nvSpPr>
-          <p:cNvPr id="24" name="Shape 22"/>
-          <p:cNvSpPr/>
-          <p:nvPr/>
-        </p:nvSpPr>
-        <p:spPr>
-          <a:xfrm>
-            <a:off x="8046720" y="3840480"/>
-            <a:ext cx="3566160" cy="1828800"/>
-          </a:xfrm>
-          <a:prstGeom prst="roundRect">
-            <a:avLst>
-              <a:gd name="adj" fmla="val 4000"/>
-            </a:avLst>
-          </a:prstGeom>
-          <a:solidFill>
-            <a:srgbClr val="EEF0F8"/>
-          </a:solidFill>
-          <a:ln/>
-          <a:effectLst>
-            <a:outerShdw sx="100000" sy="100000" kx="0" ky="0" algn="bl" rotWithShape="0" blurRad="76200" dist="25400" dir="5400000">
-              <a:srgbClr val="888888">
-                <a:alpha val="25000"/>
-              </a:srgbClr>
-            </a:outerShdw>
-          </a:effectLst>
-        </p:spPr>
-      </p:sp>
-      <p:sp>
-        <p:nvSpPr>
-          <p:cNvPr id="25" name="Text 23"/>
-          <p:cNvSpPr txBox="1"/>
-          <p:nvPr/>
-        </p:nvSpPr>
-        <p:spPr>
-          <a:xfrm>
-            <a:off x="8229600" y="4023360"/>
-            <a:ext cx="914400" cy="548640"/>
-          </a:xfrm>
-          <a:prstGeom prst="rect">
-            <a:avLst/>
-          </a:prstGeom>
-          <a:noFill/>
-          <a:ln/>
-        </p:spPr>
-        <p:txBody>
-          <a:bodyPr wrap="square" lIns="0" tIns="0" rIns="0" bIns="0" rtlCol="0" anchor="ctr"/>
-          <a:lstStyle/>
-          <a:p>
-            <a:pPr indent="0" marL="0">
-              <a:buNone/>
-            </a:pPr>
-            <a:r>
-              <a:rPr lang="en-US" sz="2600" dirty="0">
-                <a:solidFill>
-                  <a:srgbClr val="000000"/>
-                </a:solidFill>
-                <a:latin typeface="Calibri" pitchFamily="34" charset="0"/>
-                <a:ea typeface="Calibri" pitchFamily="34" charset="-122"/>
-                <a:cs typeface="Calibri" pitchFamily="34" charset="-120"/>
-              </a:rPr>
-              <a:t>📈</a:t>
-            </a:r>
-            <a:endParaRPr lang="en-US" sz="2600" dirty="0"/>
-          </a:p>
-        </p:txBody>
-      </p:sp>
-      <p:sp>
-        <p:nvSpPr>
-          <p:cNvPr id="26" name="Text 24"/>
-          <p:cNvSpPr txBox="1"/>
-          <p:nvPr/>
-        </p:nvSpPr>
-        <p:spPr>
-          <a:xfrm>
-            <a:off x="8229600" y="4617720"/>
-            <a:ext cx="3200400" cy="365760"/>
-          </a:xfrm>
-          <a:prstGeom prst="rect">
-            <a:avLst/>
-          </a:prstGeom>
-          <a:noFill/>
-          <a:ln/>
-        </p:spPr>
-        <p:txBody>
-          <a:bodyPr wrap="square" lIns="0" tIns="0" rIns="0" bIns="0" rtlCol="0" anchor="ctr"/>
-          <a:lstStyle/>
-          <a:p>
-            <a:pPr indent="0" marL="0">
-              <a:buNone/>
-            </a:pPr>
-            <a:r>
-              <a:rPr lang="en-US" sz="1500" b="1" dirty="0">
-                <a:solidFill>
-                  <a:srgbClr val="261E48"/>
-                </a:solidFill>
-                <a:latin typeface="Calibri" pitchFamily="34" charset="0"/>
-                <a:ea typeface="Calibri" pitchFamily="34" charset="-122"/>
-                <a:cs typeface="Calibri" pitchFamily="34" charset="-120"/>
-              </a:rPr>
-              <a:t>Observabilité</a:t>
-            </a:r>
-            <a:endParaRPr lang="en-US" sz="1500" dirty="0"/>
-          </a:p>
-        </p:txBody>
-      </p:sp>
-      <p:sp>
-        <p:nvSpPr>
-          <p:cNvPr id="27" name="Text 25"/>
-          <p:cNvSpPr txBox="1"/>
-          <p:nvPr/>
-        </p:nvSpPr>
-        <p:spPr>
-          <a:xfrm>
-            <a:off x="8229600" y="4983480"/>
-            <a:ext cx="3200400" cy="594360"/>
-          </a:xfrm>
-          <a:prstGeom prst="rect">
-            <a:avLst/>
-          </a:prstGeom>
-          <a:noFill/>
-          <a:ln/>
-        </p:spPr>
-        <p:txBody>
-          <a:bodyPr wrap="square" lIns="0" tIns="0" rIns="0" bIns="0" rtlCol="0" anchor="ctr"/>
-          <a:lstStyle/>
-          <a:p>
-            <a:pPr indent="0" marL="0">
-              <a:buNone/>
-            </a:pPr>
-            <a:r>
-              <a:rPr lang="en-US" sz="1200" dirty="0">
-                <a:solidFill>
-                  <a:srgbClr val="6A6594"/>
-                </a:solidFill>
-                <a:latin typeface="Calibri" pitchFamily="34" charset="0"/>
-                <a:ea typeface="Calibri" pitchFamily="34" charset="-122"/>
-                <a:cs typeface="Calibri" pitchFamily="34" charset="-120"/>
-              </a:rPr>
-              <a:t>métriques &amp; logs exploitables</a:t>
-            </a:r>
-            <a:endParaRPr lang="en-US" sz="1200" dirty="0"/>
           </a:p>
         </p:txBody>
       </p:sp>
@@ -6553,7 +6678,7 @@
                 <a:ea typeface="Calibri" pitchFamily="34" charset="-122"/>
                 <a:cs typeface="Calibri" pitchFamily="34" charset="-120"/>
               </a:rPr>
-              <a:t>RECETTE &amp; ESSAIS</a:t>
+              <a:t>CYBERSÉCURITÉ</a:t>
             </a:r>
             <a:endParaRPr lang="en-US" sz="1200" dirty="0"/>
           </a:p>
@@ -6592,7 +6717,7 @@
                 <a:ea typeface="Calibri" pitchFamily="34" charset="-122"/>
                 <a:cs typeface="Calibri" pitchFamily="34" charset="-120"/>
               </a:rPr>
-              <a:t>Preuves de fonctionnement</a:t>
+              <a:t>Défense &amp; sécurité</a:t>
             </a:r>
             <a:endParaRPr lang="en-US" sz="3000" dirty="0"/>
           </a:p>
@@ -6606,16 +6731,16 @@
         </p:nvSpPr>
         <p:spPr>
           <a:xfrm>
-            <a:off x="548640" y="1645920"/>
-            <a:ext cx="2651760" cy="1737360"/>
+            <a:off x="548640" y="1737360"/>
+            <a:ext cx="3566160" cy="1828800"/>
           </a:xfrm>
           <a:prstGeom prst="roundRect">
             <a:avLst>
-              <a:gd name="adj" fmla="val 4211"/>
+              <a:gd name="adj" fmla="val 4000"/>
             </a:avLst>
           </a:prstGeom>
           <a:solidFill>
-            <a:srgbClr val="261E48"/>
+            <a:srgbClr val="EEF0F8"/>
           </a:solidFill>
           <a:ln/>
           <a:effectLst>
@@ -6635,34 +6760,34 @@
         </p:nvSpPr>
         <p:spPr>
           <a:xfrm>
-            <a:off x="548640" y="1874520"/>
-            <a:ext cx="2651760" cy="822960"/>
-          </a:xfrm>
-          <a:prstGeom prst="rect">
-            <a:avLst/>
-          </a:prstGeom>
-          <a:noFill/>
-          <a:ln/>
-        </p:spPr>
-        <p:txBody>
-          <a:bodyPr wrap="square" lIns="0" tIns="0" rIns="0" bIns="0" rtlCol="0" anchor="ctr"/>
-          <a:lstStyle/>
-          <a:p>
-            <a:pPr algn="ctr" indent="0" marL="0">
-              <a:buNone/>
-            </a:pPr>
-            <a:r>
-              <a:rPr lang="en-US" sz="3600" b="1" dirty="0">
-                <a:solidFill>
-                  <a:srgbClr val="FFFFFF"/>
-                </a:solidFill>
-                <a:latin typeface="Calibri" pitchFamily="34" charset="0"/>
-                <a:ea typeface="Calibri" pitchFamily="34" charset="-122"/>
-                <a:cs typeface="Calibri" pitchFamily="34" charset="-120"/>
-              </a:rPr>
-              <a:t>15/15</a:t>
-            </a:r>
-            <a:endParaRPr lang="en-US" sz="3600" dirty="0"/>
+            <a:off x="731520" y="1920240"/>
+            <a:ext cx="914400" cy="548640"/>
+          </a:xfrm>
+          <a:prstGeom prst="rect">
+            <a:avLst/>
+          </a:prstGeom>
+          <a:noFill/>
+          <a:ln/>
+        </p:spPr>
+        <p:txBody>
+          <a:bodyPr wrap="square" lIns="0" tIns="0" rIns="0" bIns="0" rtlCol="0" anchor="ctr"/>
+          <a:lstStyle/>
+          <a:p>
+            <a:pPr indent="0" marL="0">
+              <a:buNone/>
+            </a:pPr>
+            <a:r>
+              <a:rPr lang="en-US" sz="2600" dirty="0">
+                <a:solidFill>
+                  <a:srgbClr val="000000"/>
+                </a:solidFill>
+                <a:latin typeface="Calibri" pitchFamily="34" charset="0"/>
+                <a:ea typeface="Calibri" pitchFamily="34" charset="-122"/>
+                <a:cs typeface="Calibri" pitchFamily="34" charset="-120"/>
+              </a:rPr>
+              <a:t>🛡️</a:t>
+            </a:r>
+            <a:endParaRPr lang="en-US" sz="2600" dirty="0"/>
           </a:p>
         </p:txBody>
       </p:sp>
@@ -6674,32 +6799,71 @@
         </p:nvSpPr>
         <p:spPr>
           <a:xfrm>
-            <a:off x="640080" y="2697480"/>
-            <a:ext cx="2468880" cy="548640"/>
-          </a:xfrm>
-          <a:prstGeom prst="rect">
-            <a:avLst/>
-          </a:prstGeom>
-          <a:noFill/>
-          <a:ln/>
-        </p:spPr>
-        <p:txBody>
-          <a:bodyPr wrap="square" lIns="0" tIns="0" rIns="0" bIns="0" rtlCol="0" anchor="ctr"/>
-          <a:lstStyle/>
-          <a:p>
-            <a:pPr algn="ctr" indent="0" marL="0">
+            <a:off x="731520" y="2514600"/>
+            <a:ext cx="3200400" cy="365760"/>
+          </a:xfrm>
+          <a:prstGeom prst="rect">
+            <a:avLst/>
+          </a:prstGeom>
+          <a:noFill/>
+          <a:ln/>
+        </p:spPr>
+        <p:txBody>
+          <a:bodyPr wrap="square" lIns="0" tIns="0" rIns="0" bIns="0" rtlCol="0" anchor="ctr"/>
+          <a:lstStyle/>
+          <a:p>
+            <a:pPr indent="0" marL="0">
+              <a:buNone/>
+            </a:pPr>
+            <a:r>
+              <a:rPr lang="en-US" sz="1500" b="1" dirty="0">
+                <a:solidFill>
+                  <a:srgbClr val="261E48"/>
+                </a:solidFill>
+                <a:latin typeface="Calibri" pitchFamily="34" charset="0"/>
+                <a:ea typeface="Calibri" pitchFamily="34" charset="-122"/>
+                <a:cs typeface="Calibri" pitchFamily="34" charset="-120"/>
+              </a:rPr>
+              <a:t>WAF applicatif</a:t>
+            </a:r>
+            <a:endParaRPr lang="en-US" sz="1500" dirty="0"/>
+          </a:p>
+        </p:txBody>
+      </p:sp>
+      <p:sp>
+        <p:nvSpPr>
+          <p:cNvPr id="7" name="Text 5"/>
+          <p:cNvSpPr txBox="1"/>
+          <p:nvPr/>
+        </p:nvSpPr>
+        <p:spPr>
+          <a:xfrm>
+            <a:off x="731520" y="2880360"/>
+            <a:ext cx="3200400" cy="594360"/>
+          </a:xfrm>
+          <a:prstGeom prst="rect">
+            <a:avLst/>
+          </a:prstGeom>
+          <a:noFill/>
+          <a:ln/>
+        </p:spPr>
+        <p:txBody>
+          <a:bodyPr wrap="square" lIns="0" tIns="0" rIns="0" bIns="0" rtlCol="0" anchor="ctr"/>
+          <a:lstStyle/>
+          <a:p>
+            <a:pPr indent="0" marL="0">
               <a:buNone/>
             </a:pPr>
             <a:r>
               <a:rPr lang="en-US" sz="1200" dirty="0">
                 <a:solidFill>
-                  <a:srgbClr val="A1A6D4"/>
-                </a:solidFill>
-                <a:latin typeface="Calibri" pitchFamily="34" charset="0"/>
-                <a:ea typeface="Calibri" pitchFamily="34" charset="-122"/>
-                <a:cs typeface="Calibri" pitchFamily="34" charset="-120"/>
-              </a:rPr>
-              <a:t>vérifications de recette</a:t>
+                  <a:srgbClr val="6A6594"/>
+                </a:solidFill>
+                <a:latin typeface="Calibri" pitchFamily="34" charset="0"/>
+                <a:ea typeface="Calibri" pitchFamily="34" charset="-122"/>
+                <a:cs typeface="Calibri" pitchFamily="34" charset="-120"/>
+              </a:rPr>
+              <a:t>SQLi/XSS bloqués (403) + métrique + log</a:t>
             </a:r>
             <a:endParaRPr lang="en-US" sz="1200" dirty="0"/>
           </a:p>
@@ -6707,22 +6871,22 @@
       </p:sp>
       <p:sp>
         <p:nvSpPr>
-          <p:cNvPr id="7" name="Shape 5"/>
+          <p:cNvPr id="8" name="Shape 6"/>
           <p:cNvSpPr/>
           <p:nvPr/>
         </p:nvSpPr>
         <p:spPr>
           <a:xfrm>
-            <a:off x="3383280" y="1645920"/>
-            <a:ext cx="2651760" cy="1737360"/>
+            <a:off x="4297680" y="1737360"/>
+            <a:ext cx="3566160" cy="1828800"/>
           </a:xfrm>
           <a:prstGeom prst="roundRect">
             <a:avLst>
-              <a:gd name="adj" fmla="val 4211"/>
+              <a:gd name="adj" fmla="val 4000"/>
             </a:avLst>
           </a:prstGeom>
           <a:solidFill>
-            <a:srgbClr val="261E48"/>
+            <a:srgbClr val="EEF0F8"/>
           </a:solidFill>
           <a:ln/>
           <a:effectLst>
@@ -6736,77 +6900,116 @@
       </p:sp>
       <p:sp>
         <p:nvSpPr>
-          <p:cNvPr id="8" name="Text 6"/>
-          <p:cNvSpPr txBox="1"/>
-          <p:nvPr/>
-        </p:nvSpPr>
-        <p:spPr>
-          <a:xfrm>
-            <a:off x="3383280" y="1874520"/>
-            <a:ext cx="2651760" cy="822960"/>
-          </a:xfrm>
-          <a:prstGeom prst="rect">
-            <a:avLst/>
-          </a:prstGeom>
-          <a:noFill/>
-          <a:ln/>
-        </p:spPr>
-        <p:txBody>
-          <a:bodyPr wrap="square" lIns="0" tIns="0" rIns="0" bIns="0" rtlCol="0" anchor="ctr"/>
-          <a:lstStyle/>
-          <a:p>
-            <a:pPr algn="ctr" indent="0" marL="0">
-              <a:buNone/>
-            </a:pPr>
-            <a:r>
-              <a:rPr lang="en-US" sz="3600" b="1" dirty="0">
-                <a:solidFill>
-                  <a:srgbClr val="FFFFFF"/>
-                </a:solidFill>
-                <a:latin typeface="Calibri" pitchFamily="34" charset="0"/>
-                <a:ea typeface="Calibri" pitchFamily="34" charset="-122"/>
-                <a:cs typeface="Calibri" pitchFamily="34" charset="-120"/>
-              </a:rPr>
-              <a:t>~15 s</a:t>
-            </a:r>
-            <a:endParaRPr lang="en-US" sz="3600" dirty="0"/>
-          </a:p>
-        </p:txBody>
-      </p:sp>
-      <p:sp>
-        <p:nvSpPr>
           <p:cNvPr id="9" name="Text 7"/>
           <p:cNvSpPr txBox="1"/>
           <p:nvPr/>
         </p:nvSpPr>
         <p:spPr>
           <a:xfrm>
-            <a:off x="3474720" y="2697480"/>
-            <a:ext cx="2468880" cy="548640"/>
-          </a:xfrm>
-          <a:prstGeom prst="rect">
-            <a:avLst/>
-          </a:prstGeom>
-          <a:noFill/>
-          <a:ln/>
-        </p:spPr>
-        <p:txBody>
-          <a:bodyPr wrap="square" lIns="0" tIns="0" rIns="0" bIns="0" rtlCol="0" anchor="ctr"/>
-          <a:lstStyle/>
-          <a:p>
-            <a:pPr algn="ctr" indent="0" marL="0">
+            <a:off x="4480560" y="1920240"/>
+            <a:ext cx="914400" cy="548640"/>
+          </a:xfrm>
+          <a:prstGeom prst="rect">
+            <a:avLst/>
+          </a:prstGeom>
+          <a:noFill/>
+          <a:ln/>
+        </p:spPr>
+        <p:txBody>
+          <a:bodyPr wrap="square" lIns="0" tIns="0" rIns="0" bIns="0" rtlCol="0" anchor="ctr"/>
+          <a:lstStyle/>
+          <a:p>
+            <a:pPr indent="0" marL="0">
+              <a:buNone/>
+            </a:pPr>
+            <a:r>
+              <a:rPr lang="en-US" sz="2600" dirty="0">
+                <a:solidFill>
+                  <a:srgbClr val="000000"/>
+                </a:solidFill>
+                <a:latin typeface="Calibri" pitchFamily="34" charset="0"/>
+                <a:ea typeface="Calibri" pitchFamily="34" charset="-122"/>
+                <a:cs typeface="Calibri" pitchFamily="34" charset="-120"/>
+              </a:rPr>
+              <a:t>📊</a:t>
+            </a:r>
+            <a:endParaRPr lang="en-US" sz="2600" dirty="0"/>
+          </a:p>
+        </p:txBody>
+      </p:sp>
+      <p:sp>
+        <p:nvSpPr>
+          <p:cNvPr id="10" name="Text 8"/>
+          <p:cNvSpPr txBox="1"/>
+          <p:nvPr/>
+        </p:nvSpPr>
+        <p:spPr>
+          <a:xfrm>
+            <a:off x="4480560" y="2514600"/>
+            <a:ext cx="3200400" cy="365760"/>
+          </a:xfrm>
+          <a:prstGeom prst="rect">
+            <a:avLst/>
+          </a:prstGeom>
+          <a:noFill/>
+          <a:ln/>
+        </p:spPr>
+        <p:txBody>
+          <a:bodyPr wrap="square" lIns="0" tIns="0" rIns="0" bIns="0" rtlCol="0" anchor="ctr"/>
+          <a:lstStyle/>
+          <a:p>
+            <a:pPr indent="0" marL="0">
+              <a:buNone/>
+            </a:pPr>
+            <a:r>
+              <a:rPr lang="en-US" sz="1500" b="1" dirty="0">
+                <a:solidFill>
+                  <a:srgbClr val="261E48"/>
+                </a:solidFill>
+                <a:latin typeface="Calibri" pitchFamily="34" charset="0"/>
+                <a:ea typeface="Calibri" pitchFamily="34" charset="-122"/>
+                <a:cs typeface="Calibri" pitchFamily="34" charset="-120"/>
+              </a:rPr>
+              <a:t>Fonction SOC</a:t>
+            </a:r>
+            <a:endParaRPr lang="en-US" sz="1500" dirty="0"/>
+          </a:p>
+        </p:txBody>
+      </p:sp>
+      <p:sp>
+        <p:nvSpPr>
+          <p:cNvPr id="11" name="Text 9"/>
+          <p:cNvSpPr txBox="1"/>
+          <p:nvPr/>
+        </p:nvSpPr>
+        <p:spPr>
+          <a:xfrm>
+            <a:off x="4480560" y="2880360"/>
+            <a:ext cx="3200400" cy="594360"/>
+          </a:xfrm>
+          <a:prstGeom prst="rect">
+            <a:avLst/>
+          </a:prstGeom>
+          <a:noFill/>
+          <a:ln/>
+        </p:spPr>
+        <p:txBody>
+          <a:bodyPr wrap="square" lIns="0" tIns="0" rIns="0" bIns="0" rtlCol="0" anchor="ctr"/>
+          <a:lstStyle/>
+          <a:p>
+            <a:pPr indent="0" marL="0">
               <a:buNone/>
             </a:pPr>
             <a:r>
               <a:rPr lang="en-US" sz="1200" dirty="0">
                 <a:solidFill>
-                  <a:srgbClr val="A1A6D4"/>
-                </a:solidFill>
-                <a:latin typeface="Calibri" pitchFamily="34" charset="0"/>
-                <a:ea typeface="Calibri" pitchFamily="34" charset="-122"/>
-                <a:cs typeface="Calibri" pitchFamily="34" charset="-120"/>
-              </a:rPr>
-              <a:t>RTO détection → reprise</a:t>
+                  <a:srgbClr val="6A6594"/>
+                </a:solidFill>
+                <a:latin typeface="Calibri" pitchFamily="34" charset="0"/>
+                <a:ea typeface="Calibri" pitchFamily="34" charset="-122"/>
+                <a:cs typeface="Calibri" pitchFamily="34" charset="-120"/>
+              </a:rPr>
+              <a:t>Loki + Prometheus + vue SOC du cockpit</a:t>
             </a:r>
             <a:endParaRPr lang="en-US" sz="1200" dirty="0"/>
           </a:p>
@@ -6814,22 +7017,22 @@
       </p:sp>
       <p:sp>
         <p:nvSpPr>
-          <p:cNvPr id="10" name="Shape 8"/>
+          <p:cNvPr id="12" name="Shape 10"/>
           <p:cNvSpPr/>
           <p:nvPr/>
         </p:nvSpPr>
         <p:spPr>
           <a:xfrm>
-            <a:off x="6217920" y="1645920"/>
-            <a:ext cx="2651760" cy="1737360"/>
+            <a:off x="8046720" y="1737360"/>
+            <a:ext cx="3566160" cy="1828800"/>
           </a:xfrm>
           <a:prstGeom prst="roundRect">
             <a:avLst>
-              <a:gd name="adj" fmla="val 4211"/>
+              <a:gd name="adj" fmla="val 4000"/>
             </a:avLst>
           </a:prstGeom>
           <a:solidFill>
-            <a:srgbClr val="261E48"/>
+            <a:srgbClr val="EEF0F8"/>
           </a:solidFill>
           <a:ln/>
           <a:effectLst>
@@ -6843,77 +7046,116 @@
       </p:sp>
       <p:sp>
         <p:nvSpPr>
-          <p:cNvPr id="11" name="Text 9"/>
-          <p:cNvSpPr txBox="1"/>
-          <p:nvPr/>
-        </p:nvSpPr>
-        <p:spPr>
-          <a:xfrm>
-            <a:off x="6217920" y="1874520"/>
-            <a:ext cx="2651760" cy="822960"/>
-          </a:xfrm>
-          <a:prstGeom prst="rect">
-            <a:avLst/>
-          </a:prstGeom>
-          <a:noFill/>
-          <a:ln/>
-        </p:spPr>
-        <p:txBody>
-          <a:bodyPr wrap="square" lIns="0" tIns="0" rIns="0" bIns="0" rtlCol="0" anchor="ctr"/>
-          <a:lstStyle/>
-          <a:p>
-            <a:pPr algn="ctr" indent="0" marL="0">
-              <a:buNone/>
-            </a:pPr>
-            <a:r>
-              <a:rPr lang="en-US" sz="3600" b="1" dirty="0">
-                <a:solidFill>
-                  <a:srgbClr val="FFFFFF"/>
-                </a:solidFill>
-                <a:latin typeface="Calibri" pitchFamily="34" charset="0"/>
-                <a:ea typeface="Calibri" pitchFamily="34" charset="-122"/>
-                <a:cs typeface="Calibri" pitchFamily="34" charset="-120"/>
-              </a:rPr>
-              <a:t>100 %</a:t>
-            </a:r>
-            <a:endParaRPr lang="en-US" sz="3600" dirty="0"/>
-          </a:p>
-        </p:txBody>
-      </p:sp>
-      <p:sp>
-        <p:nvSpPr>
-          <p:cNvPr id="12" name="Text 10"/>
-          <p:cNvSpPr txBox="1"/>
-          <p:nvPr/>
-        </p:nvSpPr>
-        <p:spPr>
-          <a:xfrm>
-            <a:off x="6309360" y="2697480"/>
-            <a:ext cx="2468880" cy="548640"/>
-          </a:xfrm>
-          <a:prstGeom prst="rect">
-            <a:avLst/>
-          </a:prstGeom>
-          <a:noFill/>
-          <a:ln/>
-        </p:spPr>
-        <p:txBody>
-          <a:bodyPr wrap="square" lIns="0" tIns="0" rIns="0" bIns="0" rtlCol="0" anchor="ctr"/>
-          <a:lstStyle/>
-          <a:p>
-            <a:pPr algn="ctr" indent="0" marL="0">
+          <p:cNvPr id="13" name="Text 11"/>
+          <p:cNvSpPr txBox="1"/>
+          <p:nvPr/>
+        </p:nvSpPr>
+        <p:spPr>
+          <a:xfrm>
+            <a:off x="8229600" y="1920240"/>
+            <a:ext cx="914400" cy="548640"/>
+          </a:xfrm>
+          <a:prstGeom prst="rect">
+            <a:avLst/>
+          </a:prstGeom>
+          <a:noFill/>
+          <a:ln/>
+        </p:spPr>
+        <p:txBody>
+          <a:bodyPr wrap="square" lIns="0" tIns="0" rIns="0" bIns="0" rtlCol="0" anchor="ctr"/>
+          <a:lstStyle/>
+          <a:p>
+            <a:pPr indent="0" marL="0">
+              <a:buNone/>
+            </a:pPr>
+            <a:r>
+              <a:rPr lang="en-US" sz="2600" dirty="0">
+                <a:solidFill>
+                  <a:srgbClr val="000000"/>
+                </a:solidFill>
+                <a:latin typeface="Calibri" pitchFamily="34" charset="0"/>
+                <a:ea typeface="Calibri" pitchFamily="34" charset="-122"/>
+                <a:cs typeface="Calibri" pitchFamily="34" charset="-120"/>
+              </a:rPr>
+              <a:t>🔑</a:t>
+            </a:r>
+            <a:endParaRPr lang="en-US" sz="2600" dirty="0"/>
+          </a:p>
+        </p:txBody>
+      </p:sp>
+      <p:sp>
+        <p:nvSpPr>
+          <p:cNvPr id="14" name="Text 12"/>
+          <p:cNvSpPr txBox="1"/>
+          <p:nvPr/>
+        </p:nvSpPr>
+        <p:spPr>
+          <a:xfrm>
+            <a:off x="8229600" y="2514600"/>
+            <a:ext cx="3200400" cy="365760"/>
+          </a:xfrm>
+          <a:prstGeom prst="rect">
+            <a:avLst/>
+          </a:prstGeom>
+          <a:noFill/>
+          <a:ln/>
+        </p:spPr>
+        <p:txBody>
+          <a:bodyPr wrap="square" lIns="0" tIns="0" rIns="0" bIns="0" rtlCol="0" anchor="ctr"/>
+          <a:lstStyle/>
+          <a:p>
+            <a:pPr indent="0" marL="0">
+              <a:buNone/>
+            </a:pPr>
+            <a:r>
+              <a:rPr lang="en-US" sz="1500" b="1" dirty="0">
+                <a:solidFill>
+                  <a:srgbClr val="261E48"/>
+                </a:solidFill>
+                <a:latin typeface="Calibri" pitchFamily="34" charset="0"/>
+                <a:ea typeface="Calibri" pitchFamily="34" charset="-122"/>
+                <a:cs typeface="Calibri" pitchFamily="34" charset="-120"/>
+              </a:rPr>
+              <a:t>Secrets</a:t>
+            </a:r>
+            <a:endParaRPr lang="en-US" sz="1500" dirty="0"/>
+          </a:p>
+        </p:txBody>
+      </p:sp>
+      <p:sp>
+        <p:nvSpPr>
+          <p:cNvPr id="15" name="Text 13"/>
+          <p:cNvSpPr txBox="1"/>
+          <p:nvPr/>
+        </p:nvSpPr>
+        <p:spPr>
+          <a:xfrm>
+            <a:off x="8229600" y="2880360"/>
+            <a:ext cx="3200400" cy="594360"/>
+          </a:xfrm>
+          <a:prstGeom prst="rect">
+            <a:avLst/>
+          </a:prstGeom>
+          <a:noFill/>
+          <a:ln/>
+        </p:spPr>
+        <p:txBody>
+          <a:bodyPr wrap="square" lIns="0" tIns="0" rIns="0" bIns="0" rtlCol="0" anchor="ctr"/>
+          <a:lstStyle/>
+          <a:p>
+            <a:pPr indent="0" marL="0">
               <a:buNone/>
             </a:pPr>
             <a:r>
               <a:rPr lang="en-US" sz="1200" dirty="0">
                 <a:solidFill>
-                  <a:srgbClr val="A1A6D4"/>
-                </a:solidFill>
-                <a:latin typeface="Calibri" pitchFamily="34" charset="0"/>
-                <a:ea typeface="Calibri" pitchFamily="34" charset="-122"/>
-                <a:cs typeface="Calibri" pitchFamily="34" charset="-120"/>
-              </a:rPr>
-              <a:t>reprise sans humain</a:t>
+                  <a:srgbClr val="6A6594"/>
+                </a:solidFill>
+                <a:latin typeface="Calibri" pitchFamily="34" charset="0"/>
+                <a:ea typeface="Calibri" pitchFamily="34" charset="-122"/>
+                <a:cs typeface="Calibri" pitchFamily="34" charset="-120"/>
+              </a:rPr>
+              <a:t>chiffrés (SOPS + age), rien en clair</a:t>
             </a:r>
             <a:endParaRPr lang="en-US" sz="1200" dirty="0"/>
           </a:p>
@@ -6921,22 +7163,22 @@
       </p:sp>
       <p:sp>
         <p:nvSpPr>
-          <p:cNvPr id="13" name="Shape 11"/>
+          <p:cNvPr id="16" name="Shape 14"/>
           <p:cNvSpPr/>
           <p:nvPr/>
         </p:nvSpPr>
         <p:spPr>
           <a:xfrm>
-            <a:off x="9052560" y="1645920"/>
-            <a:ext cx="2651760" cy="1737360"/>
+            <a:off x="548640" y="3840480"/>
+            <a:ext cx="3566160" cy="1828800"/>
           </a:xfrm>
           <a:prstGeom prst="roundRect">
             <a:avLst>
-              <a:gd name="adj" fmla="val 4211"/>
+              <a:gd name="adj" fmla="val 4000"/>
             </a:avLst>
           </a:prstGeom>
           <a:solidFill>
-            <a:srgbClr val="261E48"/>
+            <a:srgbClr val="EEF0F8"/>
           </a:solidFill>
           <a:ln/>
           <a:effectLst>
@@ -6950,77 +7192,116 @@
       </p:sp>
       <p:sp>
         <p:nvSpPr>
-          <p:cNvPr id="14" name="Text 12"/>
-          <p:cNvSpPr txBox="1"/>
-          <p:nvPr/>
-        </p:nvSpPr>
-        <p:spPr>
-          <a:xfrm>
-            <a:off x="9052560" y="1874520"/>
-            <a:ext cx="2651760" cy="822960"/>
-          </a:xfrm>
-          <a:prstGeom prst="rect">
-            <a:avLst/>
-          </a:prstGeom>
-          <a:noFill/>
-          <a:ln/>
-        </p:spPr>
-        <p:txBody>
-          <a:bodyPr wrap="square" lIns="0" tIns="0" rIns="0" bIns="0" rtlCol="0" anchor="ctr"/>
-          <a:lstStyle/>
-          <a:p>
-            <a:pPr algn="ctr" indent="0" marL="0">
-              <a:buNone/>
-            </a:pPr>
-            <a:r>
-              <a:rPr lang="en-US" sz="3600" b="1" dirty="0">
-                <a:solidFill>
-                  <a:srgbClr val="FFFFFF"/>
-                </a:solidFill>
-                <a:latin typeface="Calibri" pitchFamily="34" charset="0"/>
-                <a:ea typeface="Calibri" pitchFamily="34" charset="-122"/>
-                <a:cs typeface="Calibri" pitchFamily="34" charset="-120"/>
-              </a:rPr>
-              <a:t>748</a:t>
-            </a:r>
-            <a:endParaRPr lang="en-US" sz="3600" dirty="0"/>
-          </a:p>
-        </p:txBody>
-      </p:sp>
-      <p:sp>
-        <p:nvSpPr>
-          <p:cNvPr id="15" name="Text 13"/>
-          <p:cNvSpPr txBox="1"/>
-          <p:nvPr/>
-        </p:nvSpPr>
-        <p:spPr>
-          <a:xfrm>
-            <a:off x="9144000" y="2697480"/>
-            <a:ext cx="2468880" cy="548640"/>
-          </a:xfrm>
-          <a:prstGeom prst="rect">
-            <a:avLst/>
-          </a:prstGeom>
-          <a:noFill/>
-          <a:ln/>
-        </p:spPr>
-        <p:txBody>
-          <a:bodyPr wrap="square" lIns="0" tIns="0" rIns="0" bIns="0" rtlCol="0" anchor="ctr"/>
-          <a:lstStyle/>
-          <a:p>
-            <a:pPr algn="ctr" indent="0" marL="0">
+          <p:cNvPr id="17" name="Text 15"/>
+          <p:cNvSpPr txBox="1"/>
+          <p:nvPr/>
+        </p:nvSpPr>
+        <p:spPr>
+          <a:xfrm>
+            <a:off x="731520" y="4023360"/>
+            <a:ext cx="914400" cy="548640"/>
+          </a:xfrm>
+          <a:prstGeom prst="rect">
+            <a:avLst/>
+          </a:prstGeom>
+          <a:noFill/>
+          <a:ln/>
+        </p:spPr>
+        <p:txBody>
+          <a:bodyPr wrap="square" lIns="0" tIns="0" rIns="0" bIns="0" rtlCol="0" anchor="ctr"/>
+          <a:lstStyle/>
+          <a:p>
+            <a:pPr indent="0" marL="0">
+              <a:buNone/>
+            </a:pPr>
+            <a:r>
+              <a:rPr lang="en-US" sz="2600" dirty="0">
+                <a:solidFill>
+                  <a:srgbClr val="000000"/>
+                </a:solidFill>
+                <a:latin typeface="Calibri" pitchFamily="34" charset="0"/>
+                <a:ea typeface="Calibri" pitchFamily="34" charset="-122"/>
+                <a:cs typeface="Calibri" pitchFamily="34" charset="-120"/>
+              </a:rPr>
+              <a:t>🔒</a:t>
+            </a:r>
+            <a:endParaRPr lang="en-US" sz="2600" dirty="0"/>
+          </a:p>
+        </p:txBody>
+      </p:sp>
+      <p:sp>
+        <p:nvSpPr>
+          <p:cNvPr id="18" name="Text 16"/>
+          <p:cNvSpPr txBox="1"/>
+          <p:nvPr/>
+        </p:nvSpPr>
+        <p:spPr>
+          <a:xfrm>
+            <a:off x="731520" y="4617720"/>
+            <a:ext cx="3200400" cy="365760"/>
+          </a:xfrm>
+          <a:prstGeom prst="rect">
+            <a:avLst/>
+          </a:prstGeom>
+          <a:noFill/>
+          <a:ln/>
+        </p:spPr>
+        <p:txBody>
+          <a:bodyPr wrap="square" lIns="0" tIns="0" rIns="0" bIns="0" rtlCol="0" anchor="ctr"/>
+          <a:lstStyle/>
+          <a:p>
+            <a:pPr indent="0" marL="0">
+              <a:buNone/>
+            </a:pPr>
+            <a:r>
+              <a:rPr lang="en-US" sz="1500" b="1" dirty="0">
+                <a:solidFill>
+                  <a:srgbClr val="261E48"/>
+                </a:solidFill>
+                <a:latin typeface="Calibri" pitchFamily="34" charset="0"/>
+                <a:ea typeface="Calibri" pitchFamily="34" charset="-122"/>
+                <a:cs typeface="Calibri" pitchFamily="34" charset="-120"/>
+              </a:rPr>
+              <a:t>Durcissement</a:t>
+            </a:r>
+            <a:endParaRPr lang="en-US" sz="1500" dirty="0"/>
+          </a:p>
+        </p:txBody>
+      </p:sp>
+      <p:sp>
+        <p:nvSpPr>
+          <p:cNvPr id="19" name="Text 17"/>
+          <p:cNvSpPr txBox="1"/>
+          <p:nvPr/>
+        </p:nvSpPr>
+        <p:spPr>
+          <a:xfrm>
+            <a:off x="731520" y="4983480"/>
+            <a:ext cx="3200400" cy="594360"/>
+          </a:xfrm>
+          <a:prstGeom prst="rect">
+            <a:avLst/>
+          </a:prstGeom>
+          <a:noFill/>
+          <a:ln/>
+        </p:spPr>
+        <p:txBody>
+          <a:bodyPr wrap="square" lIns="0" tIns="0" rIns="0" bIns="0" rtlCol="0" anchor="ctr"/>
+          <a:lstStyle/>
+          <a:p>
+            <a:pPr indent="0" marL="0">
               <a:buNone/>
             </a:pPr>
             <a:r>
               <a:rPr lang="en-US" sz="1200" dirty="0">
                 <a:solidFill>
-                  <a:srgbClr val="A1A6D4"/>
-                </a:solidFill>
-                <a:latin typeface="Calibri" pitchFamily="34" charset="0"/>
-                <a:ea typeface="Calibri" pitchFamily="34" charset="-122"/>
-                <a:cs typeface="Calibri" pitchFamily="34" charset="-120"/>
-              </a:rPr>
-              <a:t>requêtes bloquées (WAF)</a:t>
+                  <a:srgbClr val="6A6594"/>
+                </a:solidFill>
+                <a:latin typeface="Calibri" pitchFamily="34" charset="0"/>
+                <a:ea typeface="Calibri" pitchFamily="34" charset="-122"/>
+                <a:cs typeface="Calibri" pitchFamily="34" charset="-120"/>
+              </a:rPr>
+              <a:t>no-new-privileges, base non exposée</a:t>
             </a:r>
             <a:endParaRPr lang="en-US" sz="1200" dirty="0"/>
           </a:p>
@@ -7028,44 +7309,98 @@
       </p:sp>
       <p:sp>
         <p:nvSpPr>
-          <p:cNvPr id="16" name="Text 14"/>
-          <p:cNvSpPr txBox="1"/>
-          <p:nvPr/>
-        </p:nvSpPr>
-        <p:spPr>
-          <a:xfrm>
-            <a:off x="731520" y="3749040"/>
-            <a:ext cx="10972800" cy="411480"/>
-          </a:xfrm>
-          <a:prstGeom prst="rect">
-            <a:avLst/>
-          </a:prstGeom>
-          <a:noFill/>
-          <a:ln/>
-        </p:spPr>
-        <p:txBody>
-          <a:bodyPr wrap="square" lIns="0" tIns="0" rIns="0" bIns="0" rtlCol="0" anchor="ctr"/>
-          <a:lstStyle/>
-          <a:p>
-            <a:pPr indent="0" marL="0">
-              <a:buNone/>
-            </a:pPr>
-            <a:r>
-              <a:rPr lang="en-US" sz="1400" b="1" dirty="0">
-                <a:solidFill>
-                  <a:srgbClr val="1E8E6A"/>
-                </a:solidFill>
-                <a:latin typeface="Calibri" pitchFamily="34" charset="0"/>
-                <a:ea typeface="Calibri" pitchFamily="34" charset="-122"/>
-                <a:cs typeface="Calibri" pitchFamily="34" charset="-120"/>
-              </a:rPr>
-              <a:t>✓  </a:t>
-            </a:r>
-            <a:pPr indent="0" marL="0">
-              <a:buNone/>
-            </a:pPr>
-            <a:r>
-              <a:rPr lang="en-US" sz="1400" dirty="0">
+          <p:cNvPr id="20" name="Shape 18"/>
+          <p:cNvSpPr/>
+          <p:nvPr/>
+        </p:nvSpPr>
+        <p:spPr>
+          <a:xfrm>
+            <a:off x="4297680" y="3840480"/>
+            <a:ext cx="3566160" cy="1828800"/>
+          </a:xfrm>
+          <a:prstGeom prst="roundRect">
+            <a:avLst>
+              <a:gd name="adj" fmla="val 4000"/>
+            </a:avLst>
+          </a:prstGeom>
+          <a:solidFill>
+            <a:srgbClr val="EEF0F8"/>
+          </a:solidFill>
+          <a:ln/>
+          <a:effectLst>
+            <a:outerShdw sx="100000" sy="100000" kx="0" ky="0" algn="bl" rotWithShape="0" blurRad="76200" dist="25400" dir="5400000">
+              <a:srgbClr val="888888">
+                <a:alpha val="25000"/>
+              </a:srgbClr>
+            </a:outerShdw>
+          </a:effectLst>
+        </p:spPr>
+      </p:sp>
+      <p:sp>
+        <p:nvSpPr>
+          <p:cNvPr id="21" name="Text 19"/>
+          <p:cNvSpPr txBox="1"/>
+          <p:nvPr/>
+        </p:nvSpPr>
+        <p:spPr>
+          <a:xfrm>
+            <a:off x="4480560" y="4023360"/>
+            <a:ext cx="914400" cy="548640"/>
+          </a:xfrm>
+          <a:prstGeom prst="rect">
+            <a:avLst/>
+          </a:prstGeom>
+          <a:noFill/>
+          <a:ln/>
+        </p:spPr>
+        <p:txBody>
+          <a:bodyPr wrap="square" lIns="0" tIns="0" rIns="0" bIns="0" rtlCol="0" anchor="ctr"/>
+          <a:lstStyle/>
+          <a:p>
+            <a:pPr indent="0" marL="0">
+              <a:buNone/>
+            </a:pPr>
+            <a:r>
+              <a:rPr lang="en-US" sz="2600" dirty="0">
+                <a:solidFill>
+                  <a:srgbClr val="000000"/>
+                </a:solidFill>
+                <a:latin typeface="Calibri" pitchFamily="34" charset="0"/>
+                <a:ea typeface="Calibri" pitchFamily="34" charset="-122"/>
+                <a:cs typeface="Calibri" pitchFamily="34" charset="-120"/>
+              </a:rPr>
+              <a:t>🧩</a:t>
+            </a:r>
+            <a:endParaRPr lang="en-US" sz="2600" dirty="0"/>
+          </a:p>
+        </p:txBody>
+      </p:sp>
+      <p:sp>
+        <p:nvSpPr>
+          <p:cNvPr id="22" name="Text 20"/>
+          <p:cNvSpPr txBox="1"/>
+          <p:nvPr/>
+        </p:nvSpPr>
+        <p:spPr>
+          <a:xfrm>
+            <a:off x="4480560" y="4617720"/>
+            <a:ext cx="3200400" cy="365760"/>
+          </a:xfrm>
+          <a:prstGeom prst="rect">
+            <a:avLst/>
+          </a:prstGeom>
+          <a:noFill/>
+          <a:ln/>
+        </p:spPr>
+        <p:txBody>
+          <a:bodyPr wrap="square" lIns="0" tIns="0" rIns="0" bIns="0" rtlCol="0" anchor="ctr"/>
+          <a:lstStyle/>
+          <a:p>
+            <a:pPr indent="0" marL="0">
+              <a:buNone/>
+            </a:pPr>
+            <a:r>
+              <a:rPr lang="en-US" sz="1500" b="1" dirty="0">
                 <a:solidFill>
                   <a:srgbClr val="261E48"/>
                 </a:solidFill>
@@ -7073,52 +7408,145 @@
                 <a:ea typeface="Calibri" pitchFamily="34" charset="-122"/>
                 <a:cs typeface="Calibri" pitchFamily="34" charset="-120"/>
               </a:rPr>
-              <a:t>Services opérationnels + modèle ML entraîné</a:t>
-            </a:r>
-            <a:endParaRPr lang="en-US" sz="1400" dirty="0"/>
-          </a:p>
-        </p:txBody>
-      </p:sp>
-      <p:sp>
-        <p:nvSpPr>
-          <p:cNvPr id="17" name="Text 15"/>
-          <p:cNvSpPr txBox="1"/>
-          <p:nvPr/>
-        </p:nvSpPr>
-        <p:spPr>
-          <a:xfrm>
-            <a:off x="731520" y="4224528"/>
-            <a:ext cx="10972800" cy="411480"/>
-          </a:xfrm>
-          <a:prstGeom prst="rect">
-            <a:avLst/>
-          </a:prstGeom>
-          <a:noFill/>
-          <a:ln/>
-        </p:spPr>
-        <p:txBody>
-          <a:bodyPr wrap="square" lIns="0" tIns="0" rIns="0" bIns="0" rtlCol="0" anchor="ctr"/>
-          <a:lstStyle/>
-          <a:p>
-            <a:pPr indent="0" marL="0">
-              <a:buNone/>
-            </a:pPr>
-            <a:r>
-              <a:rPr lang="en-US" sz="1400" b="1" dirty="0">
-                <a:solidFill>
-                  <a:srgbClr val="1E8E6A"/>
-                </a:solidFill>
-                <a:latin typeface="Calibri" pitchFamily="34" charset="0"/>
-                <a:ea typeface="Calibri" pitchFamily="34" charset="-122"/>
-                <a:cs typeface="Calibri" pitchFamily="34" charset="-120"/>
-              </a:rPr>
-              <a:t>✓  </a:t>
-            </a:r>
-            <a:pPr indent="0" marL="0">
-              <a:buNone/>
-            </a:pPr>
-            <a:r>
-              <a:rPr lang="en-US" sz="1400" dirty="0">
+              <a:t>Moindre privilège</a:t>
+            </a:r>
+            <a:endParaRPr lang="en-US" sz="1500" dirty="0"/>
+          </a:p>
+        </p:txBody>
+      </p:sp>
+      <p:sp>
+        <p:nvSpPr>
+          <p:cNvPr id="23" name="Text 21"/>
+          <p:cNvSpPr txBox="1"/>
+          <p:nvPr/>
+        </p:nvSpPr>
+        <p:spPr>
+          <a:xfrm>
+            <a:off x="4480560" y="4983480"/>
+            <a:ext cx="3200400" cy="594360"/>
+          </a:xfrm>
+          <a:prstGeom prst="rect">
+            <a:avLst/>
+          </a:prstGeom>
+          <a:noFill/>
+          <a:ln/>
+        </p:spPr>
+        <p:txBody>
+          <a:bodyPr wrap="square" lIns="0" tIns="0" rIns="0" bIns="0" rtlCol="0" anchor="ctr"/>
+          <a:lstStyle/>
+          <a:p>
+            <a:pPr indent="0" marL="0">
+              <a:buNone/>
+            </a:pPr>
+            <a:r>
+              <a:rPr lang="en-US" sz="1200" dirty="0">
+                <a:solidFill>
+                  <a:srgbClr val="6A6594"/>
+                </a:solidFill>
+                <a:latin typeface="Calibri" pitchFamily="34" charset="0"/>
+                <a:ea typeface="Calibri" pitchFamily="34" charset="-122"/>
+                <a:cs typeface="Calibri" pitchFamily="34" charset="-120"/>
+              </a:rPr>
+              <a:t>token d'admin dédié à l'orchestrateur</a:t>
+            </a:r>
+            <a:endParaRPr lang="en-US" sz="1200" dirty="0"/>
+          </a:p>
+        </p:txBody>
+      </p:sp>
+      <p:sp>
+        <p:nvSpPr>
+          <p:cNvPr id="24" name="Shape 22"/>
+          <p:cNvSpPr/>
+          <p:nvPr/>
+        </p:nvSpPr>
+        <p:spPr>
+          <a:xfrm>
+            <a:off x="8046720" y="3840480"/>
+            <a:ext cx="3566160" cy="1828800"/>
+          </a:xfrm>
+          <a:prstGeom prst="roundRect">
+            <a:avLst>
+              <a:gd name="adj" fmla="val 4000"/>
+            </a:avLst>
+          </a:prstGeom>
+          <a:solidFill>
+            <a:srgbClr val="EEF0F8"/>
+          </a:solidFill>
+          <a:ln/>
+          <a:effectLst>
+            <a:outerShdw sx="100000" sy="100000" kx="0" ky="0" algn="bl" rotWithShape="0" blurRad="76200" dist="25400" dir="5400000">
+              <a:srgbClr val="888888">
+                <a:alpha val="25000"/>
+              </a:srgbClr>
+            </a:outerShdw>
+          </a:effectLst>
+        </p:spPr>
+      </p:sp>
+      <p:sp>
+        <p:nvSpPr>
+          <p:cNvPr id="25" name="Text 23"/>
+          <p:cNvSpPr txBox="1"/>
+          <p:nvPr/>
+        </p:nvSpPr>
+        <p:spPr>
+          <a:xfrm>
+            <a:off x="8229600" y="4023360"/>
+            <a:ext cx="914400" cy="548640"/>
+          </a:xfrm>
+          <a:prstGeom prst="rect">
+            <a:avLst/>
+          </a:prstGeom>
+          <a:noFill/>
+          <a:ln/>
+        </p:spPr>
+        <p:txBody>
+          <a:bodyPr wrap="square" lIns="0" tIns="0" rIns="0" bIns="0" rtlCol="0" anchor="ctr"/>
+          <a:lstStyle/>
+          <a:p>
+            <a:pPr indent="0" marL="0">
+              <a:buNone/>
+            </a:pPr>
+            <a:r>
+              <a:rPr lang="en-US" sz="2600" dirty="0">
+                <a:solidFill>
+                  <a:srgbClr val="000000"/>
+                </a:solidFill>
+                <a:latin typeface="Calibri" pitchFamily="34" charset="0"/>
+                <a:ea typeface="Calibri" pitchFamily="34" charset="-122"/>
+                <a:cs typeface="Calibri" pitchFamily="34" charset="-120"/>
+              </a:rPr>
+              <a:t>📈</a:t>
+            </a:r>
+            <a:endParaRPr lang="en-US" sz="2600" dirty="0"/>
+          </a:p>
+        </p:txBody>
+      </p:sp>
+      <p:sp>
+        <p:nvSpPr>
+          <p:cNvPr id="26" name="Text 24"/>
+          <p:cNvSpPr txBox="1"/>
+          <p:nvPr/>
+        </p:nvSpPr>
+        <p:spPr>
+          <a:xfrm>
+            <a:off x="8229600" y="4617720"/>
+            <a:ext cx="3200400" cy="365760"/>
+          </a:xfrm>
+          <a:prstGeom prst="rect">
+            <a:avLst/>
+          </a:prstGeom>
+          <a:noFill/>
+          <a:ln/>
+        </p:spPr>
+        <p:txBody>
+          <a:bodyPr wrap="square" lIns="0" tIns="0" rIns="0" bIns="0" rtlCol="0" anchor="ctr"/>
+          <a:lstStyle/>
+          <a:p>
+            <a:pPr indent="0" marL="0">
+              <a:buNone/>
+            </a:pPr>
+            <a:r>
+              <a:rPr lang="en-US" sz="1500" b="1" dirty="0">
                 <a:solidFill>
                   <a:srgbClr val="261E48"/>
                 </a:solidFill>
@@ -7126,221 +7554,48 @@
                 <a:ea typeface="Calibri" pitchFamily="34" charset="-122"/>
                 <a:cs typeface="Calibri" pitchFamily="34" charset="-120"/>
               </a:rPr>
-              <a:t>DoS → reprise autonome + bouclier actif</a:t>
-            </a:r>
-            <a:endParaRPr lang="en-US" sz="1400" dirty="0"/>
-          </a:p>
-        </p:txBody>
-      </p:sp>
-      <p:sp>
-        <p:nvSpPr>
-          <p:cNvPr id="18" name="Text 16"/>
-          <p:cNvSpPr txBox="1"/>
-          <p:nvPr/>
-        </p:nvSpPr>
-        <p:spPr>
-          <a:xfrm>
-            <a:off x="731520" y="4700016"/>
-            <a:ext cx="10972800" cy="411480"/>
-          </a:xfrm>
-          <a:prstGeom prst="rect">
-            <a:avLst/>
-          </a:prstGeom>
-          <a:noFill/>
-          <a:ln/>
-        </p:spPr>
-        <p:txBody>
-          <a:bodyPr wrap="square" lIns="0" tIns="0" rIns="0" bIns="0" rtlCol="0" anchor="ctr"/>
-          <a:lstStyle/>
-          <a:p>
-            <a:pPr indent="0" marL="0">
-              <a:buNone/>
-            </a:pPr>
-            <a:r>
-              <a:rPr lang="en-US" sz="1400" b="1" dirty="0">
-                <a:solidFill>
-                  <a:srgbClr val="1E8E6A"/>
-                </a:solidFill>
-                <a:latin typeface="Calibri" pitchFamily="34" charset="0"/>
-                <a:ea typeface="Calibri" pitchFamily="34" charset="-122"/>
-                <a:cs typeface="Calibri" pitchFamily="34" charset="-120"/>
-              </a:rPr>
-              <a:t>✓  </a:t>
-            </a:r>
-            <a:pPr indent="0" marL="0">
-              <a:buNone/>
-            </a:pPr>
-            <a:r>
-              <a:rPr lang="en-US" sz="1400" dirty="0">
-                <a:solidFill>
-                  <a:srgbClr val="261E48"/>
-                </a:solidFill>
-                <a:latin typeface="Calibri" pitchFamily="34" charset="0"/>
-                <a:ea typeface="Calibri" pitchFamily="34" charset="-122"/>
-                <a:cs typeface="Calibri" pitchFamily="34" charset="-120"/>
-              </a:rPr>
-              <a:t>Transaction réussie PENDANT l'attaque</a:t>
-            </a:r>
-            <a:endParaRPr lang="en-US" sz="1400" dirty="0"/>
-          </a:p>
-        </p:txBody>
-      </p:sp>
-      <p:sp>
-        <p:nvSpPr>
-          <p:cNvPr id="19" name="Text 17"/>
-          <p:cNvSpPr txBox="1"/>
-          <p:nvPr/>
-        </p:nvSpPr>
-        <p:spPr>
-          <a:xfrm>
-            <a:off x="731520" y="5175504"/>
-            <a:ext cx="10972800" cy="411480"/>
-          </a:xfrm>
-          <a:prstGeom prst="rect">
-            <a:avLst/>
-          </a:prstGeom>
-          <a:noFill/>
-          <a:ln/>
-        </p:spPr>
-        <p:txBody>
-          <a:bodyPr wrap="square" lIns="0" tIns="0" rIns="0" bIns="0" rtlCol="0" anchor="ctr"/>
-          <a:lstStyle/>
-          <a:p>
-            <a:pPr indent="0" marL="0">
-              <a:buNone/>
-            </a:pPr>
-            <a:r>
-              <a:rPr lang="en-US" sz="1400" b="1" dirty="0">
-                <a:solidFill>
-                  <a:srgbClr val="1E8E6A"/>
-                </a:solidFill>
-                <a:latin typeface="Calibri" pitchFamily="34" charset="0"/>
-                <a:ea typeface="Calibri" pitchFamily="34" charset="-122"/>
-                <a:cs typeface="Calibri" pitchFamily="34" charset="-120"/>
-              </a:rPr>
-              <a:t>✓  </a:t>
-            </a:r>
-            <a:pPr indent="0" marL="0">
-              <a:buNone/>
-            </a:pPr>
-            <a:r>
-              <a:rPr lang="en-US" sz="1400" dirty="0">
-                <a:solidFill>
-                  <a:srgbClr val="261E48"/>
-                </a:solidFill>
-                <a:latin typeface="Calibri" pitchFamily="34" charset="0"/>
-                <a:ea typeface="Calibri" pitchFamily="34" charset="-122"/>
-                <a:cs typeface="Calibri" pitchFamily="34" charset="-120"/>
-              </a:rPr>
-              <a:t>Injection SQL contenue par le WAF</a:t>
-            </a:r>
-            <a:endParaRPr lang="en-US" sz="1400" dirty="0"/>
-          </a:p>
-        </p:txBody>
-      </p:sp>
-      <p:sp>
-        <p:nvSpPr>
-          <p:cNvPr id="20" name="Text 18"/>
-          <p:cNvSpPr txBox="1"/>
-          <p:nvPr/>
-        </p:nvSpPr>
-        <p:spPr>
-          <a:xfrm>
-            <a:off x="731520" y="5650992"/>
-            <a:ext cx="10972800" cy="411480"/>
-          </a:xfrm>
-          <a:prstGeom prst="rect">
-            <a:avLst/>
-          </a:prstGeom>
-          <a:noFill/>
-          <a:ln/>
-        </p:spPr>
-        <p:txBody>
-          <a:bodyPr wrap="square" lIns="0" tIns="0" rIns="0" bIns="0" rtlCol="0" anchor="ctr"/>
-          <a:lstStyle/>
-          <a:p>
-            <a:pPr indent="0" marL="0">
-              <a:buNone/>
-            </a:pPr>
-            <a:r>
-              <a:rPr lang="en-US" sz="1400" b="1" dirty="0">
-                <a:solidFill>
-                  <a:srgbClr val="1E8E6A"/>
-                </a:solidFill>
-                <a:latin typeface="Calibri" pitchFamily="34" charset="0"/>
-                <a:ea typeface="Calibri" pitchFamily="34" charset="-122"/>
-                <a:cs typeface="Calibri" pitchFamily="34" charset="-120"/>
-              </a:rPr>
-              <a:t>✓  </a:t>
-            </a:r>
-            <a:pPr indent="0" marL="0">
-              <a:buNone/>
-            </a:pPr>
-            <a:r>
-              <a:rPr lang="en-US" sz="1400" dirty="0">
-                <a:solidFill>
-                  <a:srgbClr val="261E48"/>
-                </a:solidFill>
-                <a:latin typeface="Calibri" pitchFamily="34" charset="0"/>
-                <a:ea typeface="Calibri" pitchFamily="34" charset="-122"/>
-                <a:cs typeface="Calibri" pitchFamily="34" charset="-120"/>
-              </a:rPr>
-              <a:t>Intégrité des données confirmée</a:t>
-            </a:r>
-            <a:endParaRPr lang="en-US" sz="1400" dirty="0"/>
-          </a:p>
-        </p:txBody>
-      </p:sp>
-      <p:sp>
-        <p:nvSpPr>
-          <p:cNvPr id="21" name="Text 19"/>
-          <p:cNvSpPr txBox="1"/>
-          <p:nvPr/>
-        </p:nvSpPr>
-        <p:spPr>
-          <a:xfrm>
-            <a:off x="731520" y="6126480"/>
-            <a:ext cx="10972800" cy="411480"/>
-          </a:xfrm>
-          <a:prstGeom prst="rect">
-            <a:avLst/>
-          </a:prstGeom>
-          <a:noFill/>
-          <a:ln/>
-        </p:spPr>
-        <p:txBody>
-          <a:bodyPr wrap="square" lIns="0" tIns="0" rIns="0" bIns="0" rtlCol="0" anchor="ctr"/>
-          <a:lstStyle/>
-          <a:p>
-            <a:pPr indent="0" marL="0">
-              <a:buNone/>
-            </a:pPr>
-            <a:r>
-              <a:rPr lang="en-US" sz="1400" b="1" dirty="0">
-                <a:solidFill>
-                  <a:srgbClr val="1E8E6A"/>
-                </a:solidFill>
-                <a:latin typeface="Calibri" pitchFamily="34" charset="0"/>
-                <a:ea typeface="Calibri" pitchFamily="34" charset="-122"/>
-                <a:cs typeface="Calibri" pitchFamily="34" charset="-120"/>
-              </a:rPr>
-              <a:t>✓  </a:t>
-            </a:r>
-            <a:pPr indent="0" marL="0">
-              <a:buNone/>
-            </a:pPr>
-            <a:r>
-              <a:rPr lang="en-US" sz="1400" dirty="0">
-                <a:solidFill>
-                  <a:srgbClr val="261E48"/>
-                </a:solidFill>
-                <a:latin typeface="Calibri" pitchFamily="34" charset="0"/>
-                <a:ea typeface="Calibri" pitchFamily="34" charset="-122"/>
-                <a:cs typeface="Calibri" pitchFamily="34" charset="-120"/>
-              </a:rPr>
-              <a:t>Transaction finale réussie après incidents</a:t>
-            </a:r>
-            <a:endParaRPr lang="en-US" sz="1400" dirty="0"/>
+              <a:t>Observabilité</a:t>
+            </a:r>
+            <a:endParaRPr lang="en-US" sz="1500" dirty="0"/>
+          </a:p>
+        </p:txBody>
+      </p:sp>
+      <p:sp>
+        <p:nvSpPr>
+          <p:cNvPr id="27" name="Text 25"/>
+          <p:cNvSpPr txBox="1"/>
+          <p:nvPr/>
+        </p:nvSpPr>
+        <p:spPr>
+          <a:xfrm>
+            <a:off x="8229600" y="4983480"/>
+            <a:ext cx="3200400" cy="594360"/>
+          </a:xfrm>
+          <a:prstGeom prst="rect">
+            <a:avLst/>
+          </a:prstGeom>
+          <a:noFill/>
+          <a:ln/>
+        </p:spPr>
+        <p:txBody>
+          <a:bodyPr wrap="square" lIns="0" tIns="0" rIns="0" bIns="0" rtlCol="0" anchor="ctr"/>
+          <a:lstStyle/>
+          <a:p>
+            <a:pPr indent="0" marL="0">
+              <a:buNone/>
+            </a:pPr>
+            <a:r>
+              <a:rPr lang="en-US" sz="1200" dirty="0">
+                <a:solidFill>
+                  <a:srgbClr val="6A6594"/>
+                </a:solidFill>
+                <a:latin typeface="Calibri" pitchFamily="34" charset="0"/>
+                <a:ea typeface="Calibri" pitchFamily="34" charset="-122"/>
+                <a:cs typeface="Calibri" pitchFamily="34" charset="-120"/>
+              </a:rPr>
+              <a:t>métriques &amp; logs exploitables</a:t>
+            </a:r>
+            <a:endParaRPr lang="en-US" sz="1200" dirty="0"/>
           </a:p>
         </p:txBody>
       </p:sp>
@@ -7409,7 +7664,7 @@
                 <a:ea typeface="Calibri" pitchFamily="34" charset="-122"/>
                 <a:cs typeface="Calibri" pitchFamily="34" charset="-120"/>
               </a:rPr>
-              <a:t>TRANSFORMATION</a:t>
+              <a:t>RECETTE &amp; ESSAIS</a:t>
             </a:r>
             <a:endParaRPr lang="en-US" sz="1200" dirty="0"/>
           </a:p>
@@ -7448,7 +7703,7 @@
                 <a:ea typeface="Calibri" pitchFamily="34" charset="-122"/>
                 <a:cs typeface="Calibri" pitchFamily="34" charset="-120"/>
               </a:rPr>
-              <a:t>Gouvernance &amp; conformité</a:t>
+              <a:t>Preuves de fonctionnement</a:t>
             </a:r>
             <a:endParaRPr lang="en-US" sz="3000" dirty="0"/>
           </a:p>
@@ -7462,16 +7717,16 @@
         </p:nvSpPr>
         <p:spPr>
           <a:xfrm>
-            <a:off x="548640" y="1737360"/>
-            <a:ext cx="11064240" cy="1005840"/>
+            <a:off x="548640" y="1645920"/>
+            <a:ext cx="2651760" cy="1737360"/>
           </a:xfrm>
           <a:prstGeom prst="roundRect">
             <a:avLst>
-              <a:gd name="adj" fmla="val 7273"/>
+              <a:gd name="adj" fmla="val 4211"/>
             </a:avLst>
           </a:prstGeom>
           <a:solidFill>
-            <a:srgbClr val="EEF0F8"/>
+            <a:srgbClr val="261E48"/>
           </a:solidFill>
           <a:ln/>
           <a:effectLst>
@@ -7491,34 +7746,34 @@
         </p:nvSpPr>
         <p:spPr>
           <a:xfrm>
-            <a:off x="777240" y="1901952"/>
-            <a:ext cx="2743200" cy="640080"/>
-          </a:xfrm>
-          <a:prstGeom prst="rect">
-            <a:avLst/>
-          </a:prstGeom>
-          <a:noFill/>
-          <a:ln/>
-        </p:spPr>
-        <p:txBody>
-          <a:bodyPr wrap="square" lIns="0" tIns="0" rIns="0" bIns="0" rtlCol="0" anchor="ctr"/>
-          <a:lstStyle/>
-          <a:p>
-            <a:pPr indent="0" marL="0">
-              <a:buNone/>
-            </a:pPr>
-            <a:r>
-              <a:rPr lang="en-US" sz="1600" b="1" dirty="0">
-                <a:solidFill>
-                  <a:srgbClr val="4B3FA6"/>
-                </a:solidFill>
-                <a:latin typeface="Calibri" pitchFamily="34" charset="0"/>
-                <a:ea typeface="Calibri" pitchFamily="34" charset="-122"/>
-                <a:cs typeface="Calibri" pitchFamily="34" charset="-120"/>
-              </a:rPr>
-              <a:t>EBIOS RM</a:t>
-            </a:r>
-            <a:endParaRPr lang="en-US" sz="1600" dirty="0"/>
+            <a:off x="548640" y="1874520"/>
+            <a:ext cx="2651760" cy="822960"/>
+          </a:xfrm>
+          <a:prstGeom prst="rect">
+            <a:avLst/>
+          </a:prstGeom>
+          <a:noFill/>
+          <a:ln/>
+        </p:spPr>
+        <p:txBody>
+          <a:bodyPr wrap="square" lIns="0" tIns="0" rIns="0" bIns="0" rtlCol="0" anchor="ctr"/>
+          <a:lstStyle/>
+          <a:p>
+            <a:pPr algn="ctr" indent="0" marL="0">
+              <a:buNone/>
+            </a:pPr>
+            <a:r>
+              <a:rPr lang="en-US" sz="3600" b="1" dirty="0">
+                <a:solidFill>
+                  <a:srgbClr val="FFFFFF"/>
+                </a:solidFill>
+                <a:latin typeface="Calibri" pitchFamily="34" charset="0"/>
+                <a:ea typeface="Calibri" pitchFamily="34" charset="-122"/>
+                <a:cs typeface="Calibri" pitchFamily="34" charset="-120"/>
+              </a:rPr>
+              <a:t>15/15</a:t>
+            </a:r>
+            <a:endParaRPr lang="en-US" sz="3600" dirty="0"/>
           </a:p>
         </p:txBody>
       </p:sp>
@@ -7530,34 +7785,34 @@
         </p:nvSpPr>
         <p:spPr>
           <a:xfrm>
-            <a:off x="3566160" y="1920240"/>
-            <a:ext cx="7863840" cy="685800"/>
-          </a:xfrm>
-          <a:prstGeom prst="rect">
-            <a:avLst/>
-          </a:prstGeom>
-          <a:noFill/>
-          <a:ln/>
-        </p:spPr>
-        <p:txBody>
-          <a:bodyPr wrap="square" lIns="0" tIns="0" rIns="0" bIns="0" rtlCol="0" anchor="ctr"/>
-          <a:lstStyle/>
-          <a:p>
-            <a:pPr indent="0" marL="0">
-              <a:buNone/>
-            </a:pPr>
-            <a:r>
-              <a:rPr lang="en-US" sz="1350" dirty="0">
-                <a:solidFill>
-                  <a:srgbClr val="261E48"/>
-                </a:solidFill>
-                <a:latin typeface="Calibri" pitchFamily="34" charset="0"/>
-                <a:ea typeface="Calibri" pitchFamily="34" charset="-122"/>
-                <a:cs typeface="Calibri" pitchFamily="34" charset="-120"/>
-              </a:rPr>
-              <a:t>Risques reliés à l'architecture et aux attaques réellement testées</a:t>
-            </a:r>
-            <a:endParaRPr lang="en-US" sz="1350" dirty="0"/>
+            <a:off x="640080" y="2697480"/>
+            <a:ext cx="2468880" cy="548640"/>
+          </a:xfrm>
+          <a:prstGeom prst="rect">
+            <a:avLst/>
+          </a:prstGeom>
+          <a:noFill/>
+          <a:ln/>
+        </p:spPr>
+        <p:txBody>
+          <a:bodyPr wrap="square" lIns="0" tIns="0" rIns="0" bIns="0" rtlCol="0" anchor="ctr"/>
+          <a:lstStyle/>
+          <a:p>
+            <a:pPr algn="ctr" indent="0" marL="0">
+              <a:buNone/>
+            </a:pPr>
+            <a:r>
+              <a:rPr lang="en-US" sz="1200" dirty="0">
+                <a:solidFill>
+                  <a:srgbClr val="A1A6D4"/>
+                </a:solidFill>
+                <a:latin typeface="Calibri" pitchFamily="34" charset="0"/>
+                <a:ea typeface="Calibri" pitchFamily="34" charset="-122"/>
+                <a:cs typeface="Calibri" pitchFamily="34" charset="-120"/>
+              </a:rPr>
+              <a:t>vérifications de recette</a:t>
+            </a:r>
+            <a:endParaRPr lang="en-US" sz="1200" dirty="0"/>
           </a:p>
         </p:txBody>
       </p:sp>
@@ -7569,16 +7824,16 @@
         </p:nvSpPr>
         <p:spPr>
           <a:xfrm>
-            <a:off x="548640" y="2926080"/>
-            <a:ext cx="11064240" cy="1005840"/>
+            <a:off x="3383280" y="1645920"/>
+            <a:ext cx="2651760" cy="1737360"/>
           </a:xfrm>
           <a:prstGeom prst="roundRect">
             <a:avLst>
-              <a:gd name="adj" fmla="val 7273"/>
+              <a:gd name="adj" fmla="val 4211"/>
             </a:avLst>
           </a:prstGeom>
           <a:solidFill>
-            <a:srgbClr val="EEF0F8"/>
+            <a:srgbClr val="261E48"/>
           </a:solidFill>
           <a:ln/>
           <a:effectLst>
@@ -7598,34 +7853,34 @@
         </p:nvSpPr>
         <p:spPr>
           <a:xfrm>
-            <a:off x="777240" y="3090672"/>
-            <a:ext cx="2743200" cy="640080"/>
-          </a:xfrm>
-          <a:prstGeom prst="rect">
-            <a:avLst/>
-          </a:prstGeom>
-          <a:noFill/>
-          <a:ln/>
-        </p:spPr>
-        <p:txBody>
-          <a:bodyPr wrap="square" lIns="0" tIns="0" rIns="0" bIns="0" rtlCol="0" anchor="ctr"/>
-          <a:lstStyle/>
-          <a:p>
-            <a:pPr indent="0" marL="0">
-              <a:buNone/>
-            </a:pPr>
-            <a:r>
-              <a:rPr lang="en-US" sz="1600" b="1" dirty="0">
-                <a:solidFill>
-                  <a:srgbClr val="4B3FA6"/>
-                </a:solidFill>
-                <a:latin typeface="Calibri" pitchFamily="34" charset="0"/>
-                <a:ea typeface="Calibri" pitchFamily="34" charset="-122"/>
-                <a:cs typeface="Calibri" pitchFamily="34" charset="-120"/>
-              </a:rPr>
-              <a:t>PCA / PRA</a:t>
-            </a:r>
-            <a:endParaRPr lang="en-US" sz="1600" dirty="0"/>
+            <a:off x="3383280" y="1874520"/>
+            <a:ext cx="2651760" cy="822960"/>
+          </a:xfrm>
+          <a:prstGeom prst="rect">
+            <a:avLst/>
+          </a:prstGeom>
+          <a:noFill/>
+          <a:ln/>
+        </p:spPr>
+        <p:txBody>
+          <a:bodyPr wrap="square" lIns="0" tIns="0" rIns="0" bIns="0" rtlCol="0" anchor="ctr"/>
+          <a:lstStyle/>
+          <a:p>
+            <a:pPr algn="ctr" indent="0" marL="0">
+              <a:buNone/>
+            </a:pPr>
+            <a:r>
+              <a:rPr lang="en-US" sz="3600" b="1" dirty="0">
+                <a:solidFill>
+                  <a:srgbClr val="FFFFFF"/>
+                </a:solidFill>
+                <a:latin typeface="Calibri" pitchFamily="34" charset="0"/>
+                <a:ea typeface="Calibri" pitchFamily="34" charset="-122"/>
+                <a:cs typeface="Calibri" pitchFamily="34" charset="-120"/>
+              </a:rPr>
+              <a:t>~15 s</a:t>
+            </a:r>
+            <a:endParaRPr lang="en-US" sz="3600" dirty="0"/>
           </a:p>
         </p:txBody>
       </p:sp>
@@ -7637,34 +7892,34 @@
         </p:nvSpPr>
         <p:spPr>
           <a:xfrm>
-            <a:off x="3566160" y="3108960"/>
-            <a:ext cx="7863840" cy="685800"/>
-          </a:xfrm>
-          <a:prstGeom prst="rect">
-            <a:avLst/>
-          </a:prstGeom>
-          <a:noFill/>
-          <a:ln/>
-        </p:spPr>
-        <p:txBody>
-          <a:bodyPr wrap="square" lIns="0" tIns="0" rIns="0" bIns="0" rtlCol="0" anchor="ctr"/>
-          <a:lstStyle/>
-          <a:p>
-            <a:pPr indent="0" marL="0">
-              <a:buNone/>
-            </a:pPr>
-            <a:r>
-              <a:rPr lang="en-US" sz="1350" dirty="0">
-                <a:solidFill>
-                  <a:srgbClr val="261E48"/>
-                </a:solidFill>
-                <a:latin typeface="Calibri" pitchFamily="34" charset="0"/>
-                <a:ea typeface="Calibri" pitchFamily="34" charset="-122"/>
-                <a:cs typeface="Calibri" pitchFamily="34" charset="-120"/>
-              </a:rPr>
-              <a:t>Services vitaux, RTO ~15 s mesuré, 2 playbooks, responsabilités</a:t>
-            </a:r>
-            <a:endParaRPr lang="en-US" sz="1350" dirty="0"/>
+            <a:off x="3474720" y="2697480"/>
+            <a:ext cx="2468880" cy="548640"/>
+          </a:xfrm>
+          <a:prstGeom prst="rect">
+            <a:avLst/>
+          </a:prstGeom>
+          <a:noFill/>
+          <a:ln/>
+        </p:spPr>
+        <p:txBody>
+          <a:bodyPr wrap="square" lIns="0" tIns="0" rIns="0" bIns="0" rtlCol="0" anchor="ctr"/>
+          <a:lstStyle/>
+          <a:p>
+            <a:pPr algn="ctr" indent="0" marL="0">
+              <a:buNone/>
+            </a:pPr>
+            <a:r>
+              <a:rPr lang="en-US" sz="1200" dirty="0">
+                <a:solidFill>
+                  <a:srgbClr val="A1A6D4"/>
+                </a:solidFill>
+                <a:latin typeface="Calibri" pitchFamily="34" charset="0"/>
+                <a:ea typeface="Calibri" pitchFamily="34" charset="-122"/>
+                <a:cs typeface="Calibri" pitchFamily="34" charset="-120"/>
+              </a:rPr>
+              <a:t>RTO détection → reprise</a:t>
+            </a:r>
+            <a:endParaRPr lang="en-US" sz="1200" dirty="0"/>
           </a:p>
         </p:txBody>
       </p:sp>
@@ -7676,16 +7931,16 @@
         </p:nvSpPr>
         <p:spPr>
           <a:xfrm>
-            <a:off x="548640" y="4114800"/>
-            <a:ext cx="11064240" cy="1005840"/>
+            <a:off x="6217920" y="1645920"/>
+            <a:ext cx="2651760" cy="1737360"/>
           </a:xfrm>
           <a:prstGeom prst="roundRect">
             <a:avLst>
-              <a:gd name="adj" fmla="val 7273"/>
+              <a:gd name="adj" fmla="val 4211"/>
             </a:avLst>
           </a:prstGeom>
           <a:solidFill>
-            <a:srgbClr val="EEF0F8"/>
+            <a:srgbClr val="261E48"/>
           </a:solidFill>
           <a:ln/>
           <a:effectLst>
@@ -7705,34 +7960,34 @@
         </p:nvSpPr>
         <p:spPr>
           <a:xfrm>
-            <a:off x="777240" y="4279392"/>
-            <a:ext cx="2743200" cy="640080"/>
-          </a:xfrm>
-          <a:prstGeom prst="rect">
-            <a:avLst/>
-          </a:prstGeom>
-          <a:noFill/>
-          <a:ln/>
-        </p:spPr>
-        <p:txBody>
-          <a:bodyPr wrap="square" lIns="0" tIns="0" rIns="0" bIns="0" rtlCol="0" anchor="ctr"/>
-          <a:lstStyle/>
-          <a:p>
-            <a:pPr indent="0" marL="0">
-              <a:buNone/>
-            </a:pPr>
-            <a:r>
-              <a:rPr lang="en-US" sz="1600" b="1" dirty="0">
-                <a:solidFill>
-                  <a:srgbClr val="4B3FA6"/>
-                </a:solidFill>
-                <a:latin typeface="Calibri" pitchFamily="34" charset="0"/>
-                <a:ea typeface="Calibri" pitchFamily="34" charset="-122"/>
-                <a:cs typeface="Calibri" pitchFamily="34" charset="-120"/>
-              </a:rPr>
-              <a:t>NIS2 / DORA</a:t>
-            </a:r>
-            <a:endParaRPr lang="en-US" sz="1600" dirty="0"/>
+            <a:off x="6217920" y="1874520"/>
+            <a:ext cx="2651760" cy="822960"/>
+          </a:xfrm>
+          <a:prstGeom prst="rect">
+            <a:avLst/>
+          </a:prstGeom>
+          <a:noFill/>
+          <a:ln/>
+        </p:spPr>
+        <p:txBody>
+          <a:bodyPr wrap="square" lIns="0" tIns="0" rIns="0" bIns="0" rtlCol="0" anchor="ctr"/>
+          <a:lstStyle/>
+          <a:p>
+            <a:pPr algn="ctr" indent="0" marL="0">
+              <a:buNone/>
+            </a:pPr>
+            <a:r>
+              <a:rPr lang="en-US" sz="3600" b="1" dirty="0">
+                <a:solidFill>
+                  <a:srgbClr val="FFFFFF"/>
+                </a:solidFill>
+                <a:latin typeface="Calibri" pitchFamily="34" charset="0"/>
+                <a:ea typeface="Calibri" pitchFamily="34" charset="-122"/>
+                <a:cs typeface="Calibri" pitchFamily="34" charset="-120"/>
+              </a:rPr>
+              <a:t>100 %</a:t>
+            </a:r>
+            <a:endParaRPr lang="en-US" sz="3600" dirty="0"/>
           </a:p>
         </p:txBody>
       </p:sp>
@@ -7744,24 +7999,184 @@
         </p:nvSpPr>
         <p:spPr>
           <a:xfrm>
-            <a:off x="3566160" y="4297680"/>
-            <a:ext cx="7863840" cy="685800"/>
-          </a:xfrm>
-          <a:prstGeom prst="rect">
-            <a:avLst/>
-          </a:prstGeom>
-          <a:noFill/>
-          <a:ln/>
-        </p:spPr>
-        <p:txBody>
-          <a:bodyPr wrap="square" lIns="0" tIns="0" rIns="0" bIns="0" rtlCol="0" anchor="ctr"/>
-          <a:lstStyle/>
-          <a:p>
-            <a:pPr indent="0" marL="0">
-              <a:buNone/>
-            </a:pPr>
-            <a:r>
-              <a:rPr lang="en-US" sz="1350" dirty="0">
+            <a:off x="6309360" y="2697480"/>
+            <a:ext cx="2468880" cy="548640"/>
+          </a:xfrm>
+          <a:prstGeom prst="rect">
+            <a:avLst/>
+          </a:prstGeom>
+          <a:noFill/>
+          <a:ln/>
+        </p:spPr>
+        <p:txBody>
+          <a:bodyPr wrap="square" lIns="0" tIns="0" rIns="0" bIns="0" rtlCol="0" anchor="ctr"/>
+          <a:lstStyle/>
+          <a:p>
+            <a:pPr algn="ctr" indent="0" marL="0">
+              <a:buNone/>
+            </a:pPr>
+            <a:r>
+              <a:rPr lang="en-US" sz="1200" dirty="0">
+                <a:solidFill>
+                  <a:srgbClr val="A1A6D4"/>
+                </a:solidFill>
+                <a:latin typeface="Calibri" pitchFamily="34" charset="0"/>
+                <a:ea typeface="Calibri" pitchFamily="34" charset="-122"/>
+                <a:cs typeface="Calibri" pitchFamily="34" charset="-120"/>
+              </a:rPr>
+              <a:t>reprise sans humain</a:t>
+            </a:r>
+            <a:endParaRPr lang="en-US" sz="1200" dirty="0"/>
+          </a:p>
+        </p:txBody>
+      </p:sp>
+      <p:sp>
+        <p:nvSpPr>
+          <p:cNvPr id="13" name="Shape 11"/>
+          <p:cNvSpPr/>
+          <p:nvPr/>
+        </p:nvSpPr>
+        <p:spPr>
+          <a:xfrm>
+            <a:off x="9052560" y="1645920"/>
+            <a:ext cx="2651760" cy="1737360"/>
+          </a:xfrm>
+          <a:prstGeom prst="roundRect">
+            <a:avLst>
+              <a:gd name="adj" fmla="val 4211"/>
+            </a:avLst>
+          </a:prstGeom>
+          <a:solidFill>
+            <a:srgbClr val="261E48"/>
+          </a:solidFill>
+          <a:ln/>
+          <a:effectLst>
+            <a:outerShdw sx="100000" sy="100000" kx="0" ky="0" algn="bl" rotWithShape="0" blurRad="76200" dist="25400" dir="5400000">
+              <a:srgbClr val="888888">
+                <a:alpha val="25000"/>
+              </a:srgbClr>
+            </a:outerShdw>
+          </a:effectLst>
+        </p:spPr>
+      </p:sp>
+      <p:sp>
+        <p:nvSpPr>
+          <p:cNvPr id="14" name="Text 12"/>
+          <p:cNvSpPr txBox="1"/>
+          <p:nvPr/>
+        </p:nvSpPr>
+        <p:spPr>
+          <a:xfrm>
+            <a:off x="9052560" y="1874520"/>
+            <a:ext cx="2651760" cy="822960"/>
+          </a:xfrm>
+          <a:prstGeom prst="rect">
+            <a:avLst/>
+          </a:prstGeom>
+          <a:noFill/>
+          <a:ln/>
+        </p:spPr>
+        <p:txBody>
+          <a:bodyPr wrap="square" lIns="0" tIns="0" rIns="0" bIns="0" rtlCol="0" anchor="ctr"/>
+          <a:lstStyle/>
+          <a:p>
+            <a:pPr algn="ctr" indent="0" marL="0">
+              <a:buNone/>
+            </a:pPr>
+            <a:r>
+              <a:rPr lang="en-US" sz="3600" b="1" dirty="0">
+                <a:solidFill>
+                  <a:srgbClr val="FFFFFF"/>
+                </a:solidFill>
+                <a:latin typeface="Calibri" pitchFamily="34" charset="0"/>
+                <a:ea typeface="Calibri" pitchFamily="34" charset="-122"/>
+                <a:cs typeface="Calibri" pitchFamily="34" charset="-120"/>
+              </a:rPr>
+              <a:t>748</a:t>
+            </a:r>
+            <a:endParaRPr lang="en-US" sz="3600" dirty="0"/>
+          </a:p>
+        </p:txBody>
+      </p:sp>
+      <p:sp>
+        <p:nvSpPr>
+          <p:cNvPr id="15" name="Text 13"/>
+          <p:cNvSpPr txBox="1"/>
+          <p:nvPr/>
+        </p:nvSpPr>
+        <p:spPr>
+          <a:xfrm>
+            <a:off x="9144000" y="2697480"/>
+            <a:ext cx="2468880" cy="548640"/>
+          </a:xfrm>
+          <a:prstGeom prst="rect">
+            <a:avLst/>
+          </a:prstGeom>
+          <a:noFill/>
+          <a:ln/>
+        </p:spPr>
+        <p:txBody>
+          <a:bodyPr wrap="square" lIns="0" tIns="0" rIns="0" bIns="0" rtlCol="0" anchor="ctr"/>
+          <a:lstStyle/>
+          <a:p>
+            <a:pPr algn="ctr" indent="0" marL="0">
+              <a:buNone/>
+            </a:pPr>
+            <a:r>
+              <a:rPr lang="en-US" sz="1200" dirty="0">
+                <a:solidFill>
+                  <a:srgbClr val="A1A6D4"/>
+                </a:solidFill>
+                <a:latin typeface="Calibri" pitchFamily="34" charset="0"/>
+                <a:ea typeface="Calibri" pitchFamily="34" charset="-122"/>
+                <a:cs typeface="Calibri" pitchFamily="34" charset="-120"/>
+              </a:rPr>
+              <a:t>requêtes bloquées (WAF)</a:t>
+            </a:r>
+            <a:endParaRPr lang="en-US" sz="1200" dirty="0"/>
+          </a:p>
+        </p:txBody>
+      </p:sp>
+      <p:sp>
+        <p:nvSpPr>
+          <p:cNvPr id="16" name="Text 14"/>
+          <p:cNvSpPr txBox="1"/>
+          <p:nvPr/>
+        </p:nvSpPr>
+        <p:spPr>
+          <a:xfrm>
+            <a:off x="731520" y="3749040"/>
+            <a:ext cx="10972800" cy="411480"/>
+          </a:xfrm>
+          <a:prstGeom prst="rect">
+            <a:avLst/>
+          </a:prstGeom>
+          <a:noFill/>
+          <a:ln/>
+        </p:spPr>
+        <p:txBody>
+          <a:bodyPr wrap="square" lIns="0" tIns="0" rIns="0" bIns="0" rtlCol="0" anchor="ctr"/>
+          <a:lstStyle/>
+          <a:p>
+            <a:pPr indent="0" marL="0">
+              <a:buNone/>
+            </a:pPr>
+            <a:r>
+              <a:rPr lang="en-US" sz="1400" b="1" dirty="0">
+                <a:solidFill>
+                  <a:srgbClr val="1E8E6A"/>
+                </a:solidFill>
+                <a:latin typeface="Calibri" pitchFamily="34" charset="0"/>
+                <a:ea typeface="Calibri" pitchFamily="34" charset="-122"/>
+                <a:cs typeface="Calibri" pitchFamily="34" charset="-120"/>
+              </a:rPr>
+              <a:t>✓  </a:t>
+            </a:r>
+            <a:pPr indent="0" marL="0">
+              <a:buNone/>
+            </a:pPr>
+            <a:r>
+              <a:rPr lang="en-US" sz="1400" dirty="0">
                 <a:solidFill>
                   <a:srgbClr val="261E48"/>
                 </a:solidFill>
@@ -7769,41 +8184,52 @@
                 <a:ea typeface="Calibri" pitchFamily="34" charset="-122"/>
                 <a:cs typeface="Calibri" pitchFamily="34" charset="-120"/>
               </a:rPr>
-              <a:t>Exigences pertinentes vs non démontrables en 4 jours</a:t>
-            </a:r>
-            <a:endParaRPr lang="en-US" sz="1350" dirty="0"/>
-          </a:p>
-        </p:txBody>
-      </p:sp>
-      <p:sp>
-        <p:nvSpPr>
-          <p:cNvPr id="13" name="Text 11"/>
-          <p:cNvSpPr txBox="1"/>
-          <p:nvPr/>
-        </p:nvSpPr>
-        <p:spPr>
-          <a:xfrm>
-            <a:off x="548640" y="5486400"/>
-            <a:ext cx="10972800" cy="822960"/>
-          </a:xfrm>
-          <a:prstGeom prst="rect">
-            <a:avLst/>
-          </a:prstGeom>
-          <a:noFill/>
-          <a:ln/>
-        </p:spPr>
-        <p:txBody>
-          <a:bodyPr wrap="square" lIns="0" tIns="0" rIns="0" bIns="0" rtlCol="0" anchor="ctr"/>
-          <a:lstStyle/>
-          <a:p>
-            <a:pPr indent="0" marL="0">
-              <a:lnSpc>
-                <a:spcPct val="120000"/>
-              </a:lnSpc>
-              <a:buNone/>
-            </a:pPr>
-            <a:r>
-              <a:rPr lang="en-US" sz="1350" b="1" dirty="0">
+              <a:t>Services opérationnels + modèle ML entraîné</a:t>
+            </a:r>
+            <a:endParaRPr lang="en-US" sz="1400" dirty="0"/>
+          </a:p>
+        </p:txBody>
+      </p:sp>
+      <p:sp>
+        <p:nvSpPr>
+          <p:cNvPr id="17" name="Text 15"/>
+          <p:cNvSpPr txBox="1"/>
+          <p:nvPr/>
+        </p:nvSpPr>
+        <p:spPr>
+          <a:xfrm>
+            <a:off x="731520" y="4224528"/>
+            <a:ext cx="10972800" cy="411480"/>
+          </a:xfrm>
+          <a:prstGeom prst="rect">
+            <a:avLst/>
+          </a:prstGeom>
+          <a:noFill/>
+          <a:ln/>
+        </p:spPr>
+        <p:txBody>
+          <a:bodyPr wrap="square" lIns="0" tIns="0" rIns="0" bIns="0" rtlCol="0" anchor="ctr"/>
+          <a:lstStyle/>
+          <a:p>
+            <a:pPr indent="0" marL="0">
+              <a:buNone/>
+            </a:pPr>
+            <a:r>
+              <a:rPr lang="en-US" sz="1400" b="1" dirty="0">
+                <a:solidFill>
+                  <a:srgbClr val="1E8E6A"/>
+                </a:solidFill>
+                <a:latin typeface="Calibri" pitchFamily="34" charset="0"/>
+                <a:ea typeface="Calibri" pitchFamily="34" charset="-122"/>
+                <a:cs typeface="Calibri" pitchFamily="34" charset="-120"/>
+              </a:rPr>
+              <a:t>✓  </a:t>
+            </a:r>
+            <a:pPr indent="0" marL="0">
+              <a:buNone/>
+            </a:pPr>
+            <a:r>
+              <a:rPr lang="en-US" sz="1400" dirty="0">
                 <a:solidFill>
                   <a:srgbClr val="261E48"/>
                 </a:solidFill>
@@ -7811,9 +8237,221 @@
                 <a:ea typeface="Calibri" pitchFamily="34" charset="-122"/>
                 <a:cs typeface="Calibri" pitchFamily="34" charset="-120"/>
               </a:rPr>
-              <a:t>Recommandations : industrialiser la reprise (HA + WAF réseau) · formaliser la notification d'incident · tests de résilience réguliers.</a:t>
-            </a:r>
-            <a:endParaRPr lang="en-US" sz="1350" dirty="0"/>
+              <a:t>DoS → reprise autonome + bouclier actif</a:t>
+            </a:r>
+            <a:endParaRPr lang="en-US" sz="1400" dirty="0"/>
+          </a:p>
+        </p:txBody>
+      </p:sp>
+      <p:sp>
+        <p:nvSpPr>
+          <p:cNvPr id="18" name="Text 16"/>
+          <p:cNvSpPr txBox="1"/>
+          <p:nvPr/>
+        </p:nvSpPr>
+        <p:spPr>
+          <a:xfrm>
+            <a:off x="731520" y="4700016"/>
+            <a:ext cx="10972800" cy="411480"/>
+          </a:xfrm>
+          <a:prstGeom prst="rect">
+            <a:avLst/>
+          </a:prstGeom>
+          <a:noFill/>
+          <a:ln/>
+        </p:spPr>
+        <p:txBody>
+          <a:bodyPr wrap="square" lIns="0" tIns="0" rIns="0" bIns="0" rtlCol="0" anchor="ctr"/>
+          <a:lstStyle/>
+          <a:p>
+            <a:pPr indent="0" marL="0">
+              <a:buNone/>
+            </a:pPr>
+            <a:r>
+              <a:rPr lang="en-US" sz="1400" b="1" dirty="0">
+                <a:solidFill>
+                  <a:srgbClr val="1E8E6A"/>
+                </a:solidFill>
+                <a:latin typeface="Calibri" pitchFamily="34" charset="0"/>
+                <a:ea typeface="Calibri" pitchFamily="34" charset="-122"/>
+                <a:cs typeface="Calibri" pitchFamily="34" charset="-120"/>
+              </a:rPr>
+              <a:t>✓  </a:t>
+            </a:r>
+            <a:pPr indent="0" marL="0">
+              <a:buNone/>
+            </a:pPr>
+            <a:r>
+              <a:rPr lang="en-US" sz="1400" dirty="0">
+                <a:solidFill>
+                  <a:srgbClr val="261E48"/>
+                </a:solidFill>
+                <a:latin typeface="Calibri" pitchFamily="34" charset="0"/>
+                <a:ea typeface="Calibri" pitchFamily="34" charset="-122"/>
+                <a:cs typeface="Calibri" pitchFamily="34" charset="-120"/>
+              </a:rPr>
+              <a:t>Transaction réussie PENDANT l'attaque</a:t>
+            </a:r>
+            <a:endParaRPr lang="en-US" sz="1400" dirty="0"/>
+          </a:p>
+        </p:txBody>
+      </p:sp>
+      <p:sp>
+        <p:nvSpPr>
+          <p:cNvPr id="19" name="Text 17"/>
+          <p:cNvSpPr txBox="1"/>
+          <p:nvPr/>
+        </p:nvSpPr>
+        <p:spPr>
+          <a:xfrm>
+            <a:off x="731520" y="5175504"/>
+            <a:ext cx="10972800" cy="411480"/>
+          </a:xfrm>
+          <a:prstGeom prst="rect">
+            <a:avLst/>
+          </a:prstGeom>
+          <a:noFill/>
+          <a:ln/>
+        </p:spPr>
+        <p:txBody>
+          <a:bodyPr wrap="square" lIns="0" tIns="0" rIns="0" bIns="0" rtlCol="0" anchor="ctr"/>
+          <a:lstStyle/>
+          <a:p>
+            <a:pPr indent="0" marL="0">
+              <a:buNone/>
+            </a:pPr>
+            <a:r>
+              <a:rPr lang="en-US" sz="1400" b="1" dirty="0">
+                <a:solidFill>
+                  <a:srgbClr val="1E8E6A"/>
+                </a:solidFill>
+                <a:latin typeface="Calibri" pitchFamily="34" charset="0"/>
+                <a:ea typeface="Calibri" pitchFamily="34" charset="-122"/>
+                <a:cs typeface="Calibri" pitchFamily="34" charset="-120"/>
+              </a:rPr>
+              <a:t>✓  </a:t>
+            </a:r>
+            <a:pPr indent="0" marL="0">
+              <a:buNone/>
+            </a:pPr>
+            <a:r>
+              <a:rPr lang="en-US" sz="1400" dirty="0">
+                <a:solidFill>
+                  <a:srgbClr val="261E48"/>
+                </a:solidFill>
+                <a:latin typeface="Calibri" pitchFamily="34" charset="0"/>
+                <a:ea typeface="Calibri" pitchFamily="34" charset="-122"/>
+                <a:cs typeface="Calibri" pitchFamily="34" charset="-120"/>
+              </a:rPr>
+              <a:t>Injection SQL contenue par le WAF</a:t>
+            </a:r>
+            <a:endParaRPr lang="en-US" sz="1400" dirty="0"/>
+          </a:p>
+        </p:txBody>
+      </p:sp>
+      <p:sp>
+        <p:nvSpPr>
+          <p:cNvPr id="20" name="Text 18"/>
+          <p:cNvSpPr txBox="1"/>
+          <p:nvPr/>
+        </p:nvSpPr>
+        <p:spPr>
+          <a:xfrm>
+            <a:off x="731520" y="5650992"/>
+            <a:ext cx="10972800" cy="411480"/>
+          </a:xfrm>
+          <a:prstGeom prst="rect">
+            <a:avLst/>
+          </a:prstGeom>
+          <a:noFill/>
+          <a:ln/>
+        </p:spPr>
+        <p:txBody>
+          <a:bodyPr wrap="square" lIns="0" tIns="0" rIns="0" bIns="0" rtlCol="0" anchor="ctr"/>
+          <a:lstStyle/>
+          <a:p>
+            <a:pPr indent="0" marL="0">
+              <a:buNone/>
+            </a:pPr>
+            <a:r>
+              <a:rPr lang="en-US" sz="1400" b="1" dirty="0">
+                <a:solidFill>
+                  <a:srgbClr val="1E8E6A"/>
+                </a:solidFill>
+                <a:latin typeface="Calibri" pitchFamily="34" charset="0"/>
+                <a:ea typeface="Calibri" pitchFamily="34" charset="-122"/>
+                <a:cs typeface="Calibri" pitchFamily="34" charset="-120"/>
+              </a:rPr>
+              <a:t>✓  </a:t>
+            </a:r>
+            <a:pPr indent="0" marL="0">
+              <a:buNone/>
+            </a:pPr>
+            <a:r>
+              <a:rPr lang="en-US" sz="1400" dirty="0">
+                <a:solidFill>
+                  <a:srgbClr val="261E48"/>
+                </a:solidFill>
+                <a:latin typeface="Calibri" pitchFamily="34" charset="0"/>
+                <a:ea typeface="Calibri" pitchFamily="34" charset="-122"/>
+                <a:cs typeface="Calibri" pitchFamily="34" charset="-120"/>
+              </a:rPr>
+              <a:t>Intégrité des données confirmée</a:t>
+            </a:r>
+            <a:endParaRPr lang="en-US" sz="1400" dirty="0"/>
+          </a:p>
+        </p:txBody>
+      </p:sp>
+      <p:sp>
+        <p:nvSpPr>
+          <p:cNvPr id="21" name="Text 19"/>
+          <p:cNvSpPr txBox="1"/>
+          <p:nvPr/>
+        </p:nvSpPr>
+        <p:spPr>
+          <a:xfrm>
+            <a:off x="731520" y="6126480"/>
+            <a:ext cx="10972800" cy="411480"/>
+          </a:xfrm>
+          <a:prstGeom prst="rect">
+            <a:avLst/>
+          </a:prstGeom>
+          <a:noFill/>
+          <a:ln/>
+        </p:spPr>
+        <p:txBody>
+          <a:bodyPr wrap="square" lIns="0" tIns="0" rIns="0" bIns="0" rtlCol="0" anchor="ctr"/>
+          <a:lstStyle/>
+          <a:p>
+            <a:pPr indent="0" marL="0">
+              <a:buNone/>
+            </a:pPr>
+            <a:r>
+              <a:rPr lang="en-US" sz="1400" b="1" dirty="0">
+                <a:solidFill>
+                  <a:srgbClr val="1E8E6A"/>
+                </a:solidFill>
+                <a:latin typeface="Calibri" pitchFamily="34" charset="0"/>
+                <a:ea typeface="Calibri" pitchFamily="34" charset="-122"/>
+                <a:cs typeface="Calibri" pitchFamily="34" charset="-120"/>
+              </a:rPr>
+              <a:t>✓  </a:t>
+            </a:r>
+            <a:pPr indent="0" marL="0">
+              <a:buNone/>
+            </a:pPr>
+            <a:r>
+              <a:rPr lang="en-US" sz="1400" dirty="0">
+                <a:solidFill>
+                  <a:srgbClr val="261E48"/>
+                </a:solidFill>
+                <a:latin typeface="Calibri" pitchFamily="34" charset="0"/>
+                <a:ea typeface="Calibri" pitchFamily="34" charset="-122"/>
+                <a:cs typeface="Calibri" pitchFamily="34" charset="-120"/>
+              </a:rPr>
+              <a:t>Transaction finale réussie après incidents</a:t>
+            </a:r>
+            <a:endParaRPr lang="en-US" sz="1400" dirty="0"/>
           </a:p>
         </p:txBody>
       </p:sp>

</xml_diff>

<commit_message>
Livrables : noms de l'équipe intégrés (dossier + deck)
Équipe : Téo Debay, Timéo Quehen, Hodari Bigwi, Théo Vambre, Adrien Planquelle.
Répartition par module proposée (à ajuster). N° de groupe encore à fixer (G<n>).

Co-Authored-By: Claude Opus 4.8 <noreply@anthropic.com>
</commit_message>
<xml_diff>
--- a/livrables/Presentation-RESILIENCE-ALPHA.pptx
+++ b/livrables/Presentation-RESILIENCE-ALPHA.pptx
@@ -2203,6 +2203,45 @@
         </p:nvSpPr>
         <p:spPr>
           <a:xfrm>
+            <a:off x="731520" y="4754880"/>
+            <a:ext cx="10698480" cy="365760"/>
+          </a:xfrm>
+          <a:prstGeom prst="rect">
+            <a:avLst/>
+          </a:prstGeom>
+          <a:noFill/>
+          <a:ln/>
+        </p:spPr>
+        <p:txBody>
+          <a:bodyPr wrap="square" lIns="0" tIns="0" rIns="0" bIns="0" rtlCol="0" anchor="ctr"/>
+          <a:lstStyle/>
+          <a:p>
+            <a:pPr indent="0" marL="0">
+              <a:buNone/>
+            </a:pPr>
+            <a:r>
+              <a:rPr lang="en-US" sz="1300" dirty="0">
+                <a:solidFill>
+                  <a:srgbClr val="FFFFFF"/>
+                </a:solidFill>
+                <a:latin typeface="Calibri" pitchFamily="34" charset="0"/>
+                <a:ea typeface="Calibri" pitchFamily="34" charset="-122"/>
+                <a:cs typeface="Calibri" pitchFamily="34" charset="-120"/>
+              </a:rPr>
+              <a:t>Équipe : Téo Debay · Timéo Quehen · Hodari Bigwi · Théo Vambre · Adrien Planquelle</a:t>
+            </a:r>
+            <a:endParaRPr lang="en-US" sz="1300" dirty="0"/>
+          </a:p>
+        </p:txBody>
+      </p:sp>
+      <p:sp>
+        <p:nvSpPr>
+          <p:cNvPr id="8" name="Text 6"/>
+          <p:cNvSpPr txBox="1"/>
+          <p:nvPr/>
+        </p:nvSpPr>
+        <p:spPr>
+          <a:xfrm>
             <a:off x="731520" y="6126480"/>
             <a:ext cx="10698480" cy="365760"/>
           </a:xfrm>

</xml_diff>

<commit_message>
docs(jeu): guide + dossier + deck couvrent la zone jeu ; fix orchestrateur + PDF/PPTX regeneres
- orchestrator: expose loot_neutralized/loot immediatement apres le claw-back
  (evite une valeur perimee lue juste apres le blocage).
- GUIDE-LANCEMENT (html+md): etape "zone Reconnaissance/Operation" + scenario jeu.
- livrables/dossier.html: section "jeu de hacker" (compromission -> blocage -> bascule).
- livrables/build-deck.js: slide "Jeu de hacker : voler... ou se faire bloquer".
- Dossier PDF + Presentation PPTX regeneres.

Co-Authored-By: Claude Opus 4.8 <noreply@anthropic.com>
</commit_message>
<xml_diff>
--- a/livrables/Presentation-RESILIENCE-ALPHA.pptx
+++ b/livrables/Presentation-RESILIENCE-ALPHA.pptx
@@ -19,9 +19,10 @@
     <p:sldId id="267" r:id="rId13"/>
     <p:sldId id="268" r:id="rId14"/>
     <p:sldId id="269" r:id="rId15"/>
+    <p:sldId id="270" r:id="rId16"/>
   </p:sldIdLst>
   <p:notesMasterIdLst>
-    <p:notesMasterId r:id="rId16"/>
+    <p:notesMasterId r:id="rId17"/>
   </p:notesMasterIdLst>
   <p:sldSz cx="12192000" cy="6858000"/>
   <p:notesSz cx="6858000" cy="12192000"/>
@@ -1231,6 +1232,94 @@
             <a:fld id="{F7021451-1387-4CA6-816F-3879F97B5CBC}" type="slidenum">
               <a:rPr lang="en-US"/>
               <a:t>14</a:t>
+            </a:fld>
+            <a:endParaRPr lang="en-US"/>
+          </a:p>
+        </p:txBody>
+      </p:sp>
+    </p:spTree>
+    <p:extLst>
+      <p:ext uri="{BB962C8B-B14F-4D97-AF65-F5344CB8AC3E}">
+        <p14:creationId xmlns:p14="http://schemas.microsoft.com/office/powerpoint/2010/main" val="1024086991"/>
+      </p:ext>
+    </p:extLst>
+  </p:cSld>
+  <p:clrMapOvr>
+    <a:masterClrMapping/>
+  </p:clrMapOvr>
+</p:notes>
+</file>
+
+<file path=ppt/notesSlides/notesSlide15.xml><?xml version="1.0" encoding="utf-8"?>
+<p:notes xmlns:a="http://schemas.openxmlformats.org/drawingml/2006/main" xmlns:r="http://schemas.openxmlformats.org/officeDocument/2006/relationships" xmlns:p="http://schemas.openxmlformats.org/presentationml/2006/main">
+  <p:cSld>
+    <p:spTree>
+      <p:nvGrpSpPr>
+        <p:cNvPr id="1" name=""/>
+        <p:cNvGrpSpPr/>
+        <p:nvPr/>
+      </p:nvGrpSpPr>
+      <p:grpSpPr>
+        <a:xfrm>
+          <a:off x="0" y="0"/>
+          <a:ext cx="0" cy="0"/>
+          <a:chOff x="0" y="0"/>
+          <a:chExt cx="0" cy="0"/>
+        </a:xfrm>
+      </p:grpSpPr>
+      <p:sp>
+        <p:nvSpPr>
+          <p:cNvPr id="2" name="Slide Image Placeholder 1"/>
+          <p:cNvSpPr>
+            <a:spLocks noGrp="1" noRot="1" noChangeAspect="1"/>
+          </p:cNvSpPr>
+          <p:nvPr>
+            <p:ph type="sldImg"/>
+          </p:nvPr>
+        </p:nvSpPr>
+        <p:spPr/>
+      </p:sp>
+      <p:sp>
+        <p:nvSpPr>
+          <p:cNvPr id="3" name="Notes Placeholder 2"/>
+          <p:cNvSpPr>
+            <a:spLocks noGrp="1"/>
+          </p:cNvSpPr>
+          <p:nvPr>
+            <p:ph type="body" idx="1"/>
+          </p:nvPr>
+        </p:nvSpPr>
+        <p:spPr/>
+        <p:txBody>
+          <a:bodyPr/>
+          <a:lstStyle/>
+          <a:p>
+            <a:r>
+              <a:rPr lang="en-US" dirty="0"/>
+              <a:t/>
+            </a:r>
+            <a:endParaRPr lang="en-US" dirty="0"/>
+          </a:p>
+        </p:txBody>
+      </p:sp>
+      <p:sp>
+        <p:nvSpPr>
+          <p:cNvPr id="4" name="Slide Number Placeholder 3"/>
+          <p:cNvSpPr>
+            <a:spLocks noGrp="1"/>
+          </p:cNvSpPr>
+          <p:nvPr>
+            <p:ph type="sldNum" sz="quarter" idx="10"/>
+          </p:nvPr>
+        </p:nvSpPr>
+        <p:spPr/>
+        <p:txBody>
+          <a:bodyPr/>
+          <a:lstStyle/>
+          <a:p>
+            <a:fld id="{F7021451-1387-4CA6-816F-3879F97B5CBC}" type="slidenum">
+              <a:rPr lang="en-US"/>
+              <a:t>15</a:t>
             </a:fld>
             <a:endParaRPr lang="en-US"/>
           </a:p>
@@ -5577,6 +5666,924 @@
     <p:bg>
       <p:bgPr>
         <a:solidFill>
+          <a:srgbClr val="FFFFFF"/>
+        </a:solidFill>
+      </p:bgPr>
+    </p:bg>
+    <p:spTree>
+      <p:nvGrpSpPr>
+        <p:cNvPr id="1" name=""/>
+        <p:cNvGrpSpPr/>
+        <p:nvPr/>
+      </p:nvGrpSpPr>
+      <p:grpSpPr>
+        <a:xfrm>
+          <a:off x="0" y="0"/>
+          <a:ext cx="0" cy="0"/>
+          <a:chOff x="0" y="0"/>
+          <a:chExt cx="0" cy="0"/>
+        </a:xfrm>
+      </p:grpSpPr>
+      <p:sp>
+        <p:nvSpPr>
+          <p:cNvPr id="2" name="Text 0"/>
+          <p:cNvSpPr txBox="1"/>
+          <p:nvPr/>
+        </p:nvSpPr>
+        <p:spPr>
+          <a:xfrm>
+            <a:off x="548640" y="411480"/>
+            <a:ext cx="10972800" cy="274320"/>
+          </a:xfrm>
+          <a:prstGeom prst="rect">
+            <a:avLst/>
+          </a:prstGeom>
+          <a:noFill/>
+          <a:ln/>
+        </p:spPr>
+        <p:txBody>
+          <a:bodyPr wrap="square" lIns="0" tIns="0" rIns="0" bIns="0" rtlCol="0" anchor="ctr"/>
+          <a:lstStyle/>
+          <a:p>
+            <a:pPr indent="0" marL="0">
+              <a:buNone/>
+            </a:pPr>
+            <a:r>
+              <a:rPr lang="en-US" sz="1200" b="1" spc="200" kern="0" dirty="0">
+                <a:solidFill>
+                  <a:srgbClr val="4B3FA6"/>
+                </a:solidFill>
+                <a:latin typeface="Calibri" pitchFamily="34" charset="0"/>
+                <a:ea typeface="Calibri" pitchFamily="34" charset="-122"/>
+                <a:cs typeface="Calibri" pitchFamily="34" charset="-120"/>
+              </a:rPr>
+              <a:t>DÉMONSTRATION INTERACTIVE</a:t>
+            </a:r>
+            <a:endParaRPr lang="en-US" sz="1200" dirty="0"/>
+          </a:p>
+        </p:txBody>
+      </p:sp>
+      <p:sp>
+        <p:nvSpPr>
+          <p:cNvPr id="3" name="Text 1"/>
+          <p:cNvSpPr txBox="1"/>
+          <p:nvPr/>
+        </p:nvSpPr>
+        <p:spPr>
+          <a:xfrm>
+            <a:off x="548640" y="658368"/>
+            <a:ext cx="11064240" cy="640080"/>
+          </a:xfrm>
+          <a:prstGeom prst="rect">
+            <a:avLst/>
+          </a:prstGeom>
+          <a:noFill/>
+          <a:ln/>
+        </p:spPr>
+        <p:txBody>
+          <a:bodyPr wrap="square" lIns="0" tIns="0" rIns="0" bIns="0" rtlCol="0" anchor="ctr"/>
+          <a:lstStyle/>
+          <a:p>
+            <a:pPr indent="0" marL="0">
+              <a:buNone/>
+            </a:pPr>
+            <a:r>
+              <a:rPr lang="en-US" sz="3000" b="1" dirty="0">
+                <a:solidFill>
+                  <a:srgbClr val="261E48"/>
+                </a:solidFill>
+                <a:latin typeface="Calibri" pitchFamily="34" charset="0"/>
+                <a:ea typeface="Calibri" pitchFamily="34" charset="-122"/>
+                <a:cs typeface="Calibri" pitchFamily="34" charset="-120"/>
+              </a:rPr>
+              <a:t>Jeu de hacker : voler… ou se faire bloquer</a:t>
+            </a:r>
+            <a:endParaRPr lang="en-US" sz="3000" dirty="0"/>
+          </a:p>
+        </p:txBody>
+      </p:sp>
+      <p:sp>
+        <p:nvSpPr>
+          <p:cNvPr id="4" name="Text 2"/>
+          <p:cNvSpPr txBox="1"/>
+          <p:nvPr/>
+        </p:nvSpPr>
+        <p:spPr>
+          <a:xfrm>
+            <a:off x="548640" y="1371600"/>
+            <a:ext cx="11064240" cy="365760"/>
+          </a:xfrm>
+          <a:prstGeom prst="rect">
+            <a:avLst/>
+          </a:prstGeom>
+          <a:noFill/>
+          <a:ln/>
+        </p:spPr>
+        <p:txBody>
+          <a:bodyPr wrap="square" lIns="0" tIns="0" rIns="0" bIns="0" rtlCol="0" anchor="ctr"/>
+          <a:lstStyle/>
+          <a:p>
+            <a:pPr indent="0" marL="0">
+              <a:buNone/>
+            </a:pPr>
+            <a:r>
+              <a:rPr lang="en-US" sz="1350" dirty="0">
+                <a:solidFill>
+                  <a:srgbClr val="6A6594"/>
+                </a:solidFill>
+                <a:latin typeface="Calibri" pitchFamily="34" charset="0"/>
+                <a:ea typeface="Calibri" pitchFamily="34" charset="-122"/>
+                <a:cs typeface="Calibri" pitchFamily="34" charset="-120"/>
+              </a:rPr>
+              <a:t>Zone « Reconnaissance / Opération » ajoutée à la console attaquant : un jeu d'équilibre.</a:t>
+            </a:r>
+            <a:endParaRPr lang="en-US" sz="1350" dirty="0"/>
+          </a:p>
+        </p:txBody>
+      </p:sp>
+      <p:sp>
+        <p:nvSpPr>
+          <p:cNvPr id="5" name="Shape 3"/>
+          <p:cNvSpPr/>
+          <p:nvPr/>
+        </p:nvSpPr>
+        <p:spPr>
+          <a:xfrm>
+            <a:off x="548640" y="1828800"/>
+            <a:ext cx="11064240" cy="749808"/>
+          </a:xfrm>
+          <a:prstGeom prst="roundRect">
+            <a:avLst>
+              <a:gd name="adj" fmla="val 9756"/>
+            </a:avLst>
+          </a:prstGeom>
+          <a:solidFill>
+            <a:srgbClr val="EEF0F8"/>
+          </a:solidFill>
+          <a:ln/>
+          <a:effectLst>
+            <a:outerShdw sx="100000" sy="100000" kx="0" ky="0" algn="bl" rotWithShape="0" blurRad="76200" dist="25400" dir="5400000">
+              <a:srgbClr val="888888">
+                <a:alpha val="25000"/>
+              </a:srgbClr>
+            </a:outerShdw>
+          </a:effectLst>
+        </p:spPr>
+      </p:sp>
+      <p:sp>
+        <p:nvSpPr>
+          <p:cNvPr id="6" name="Text 4"/>
+          <p:cNvSpPr txBox="1"/>
+          <p:nvPr/>
+        </p:nvSpPr>
+        <p:spPr>
+          <a:xfrm>
+            <a:off x="731520" y="1938528"/>
+            <a:ext cx="731520" cy="548640"/>
+          </a:xfrm>
+          <a:prstGeom prst="rect">
+            <a:avLst/>
+          </a:prstGeom>
+          <a:noFill/>
+          <a:ln/>
+        </p:spPr>
+        <p:txBody>
+          <a:bodyPr wrap="square" lIns="0" tIns="0" rIns="0" bIns="0" rtlCol="0" anchor="ctr"/>
+          <a:lstStyle/>
+          <a:p>
+            <a:pPr algn="ctr" indent="0" marL="0">
+              <a:buNone/>
+            </a:pPr>
+            <a:r>
+              <a:rPr lang="en-US" sz="2400" dirty="0">
+                <a:solidFill>
+                  <a:srgbClr val="000000"/>
+                </a:solidFill>
+                <a:latin typeface="Calibri" pitchFamily="34" charset="0"/>
+                <a:ea typeface="Calibri" pitchFamily="34" charset="-122"/>
+                <a:cs typeface="Calibri" pitchFamily="34" charset="-120"/>
+              </a:rPr>
+              <a:t>🔍</a:t>
+            </a:r>
+            <a:endParaRPr lang="en-US" sz="2400" dirty="0"/>
+          </a:p>
+        </p:txBody>
+      </p:sp>
+      <p:sp>
+        <p:nvSpPr>
+          <p:cNvPr id="7" name="Text 5"/>
+          <p:cNvSpPr txBox="1"/>
+          <p:nvPr/>
+        </p:nvSpPr>
+        <p:spPr>
+          <a:xfrm>
+            <a:off x="1554480" y="1929384"/>
+            <a:ext cx="9784080" cy="320040"/>
+          </a:xfrm>
+          <a:prstGeom prst="rect">
+            <a:avLst/>
+          </a:prstGeom>
+          <a:noFill/>
+          <a:ln/>
+        </p:spPr>
+        <p:txBody>
+          <a:bodyPr wrap="square" lIns="0" tIns="0" rIns="0" bIns="0" rtlCol="0" anchor="ctr"/>
+          <a:lstStyle/>
+          <a:p>
+            <a:pPr indent="0" marL="0">
+              <a:buNone/>
+            </a:pPr>
+            <a:r>
+              <a:rPr lang="en-US" sz="1450" b="1" dirty="0">
+                <a:solidFill>
+                  <a:srgbClr val="261E48"/>
+                </a:solidFill>
+                <a:latin typeface="Calibri" pitchFamily="34" charset="0"/>
+                <a:ea typeface="Calibri" pitchFamily="34" charset="-122"/>
+                <a:cs typeface="Calibri" pitchFamily="34" charset="-120"/>
+              </a:rPr>
+              <a:t>Reconnaissance discrète</a:t>
+            </a:r>
+            <a:endParaRPr lang="en-US" sz="1450" dirty="0"/>
+          </a:p>
+        </p:txBody>
+      </p:sp>
+      <p:sp>
+        <p:nvSpPr>
+          <p:cNvPr id="8" name="Text 6"/>
+          <p:cNvSpPr txBox="1"/>
+          <p:nvPr/>
+        </p:nvSpPr>
+        <p:spPr>
+          <a:xfrm>
+            <a:off x="1554480" y="2249424"/>
+            <a:ext cx="9784080" cy="274320"/>
+          </a:xfrm>
+          <a:prstGeom prst="rect">
+            <a:avLst/>
+          </a:prstGeom>
+          <a:noFill/>
+          <a:ln/>
+        </p:spPr>
+        <p:txBody>
+          <a:bodyPr wrap="square" lIns="0" tIns="0" rIns="0" bIns="0" rtlCol="0" anchor="ctr"/>
+          <a:lstStyle/>
+          <a:p>
+            <a:pPr indent="0" marL="0">
+              <a:buNone/>
+            </a:pPr>
+            <a:r>
+              <a:rPr lang="en-US" sz="1150" dirty="0">
+                <a:solidFill>
+                  <a:srgbClr val="6A6594"/>
+                </a:solidFill>
+                <a:latin typeface="Calibri" pitchFamily="34" charset="0"/>
+                <a:ea typeface="Calibri" pitchFamily="34" charset="-122"/>
+                <a:cs typeface="Calibri" pitchFamily="34" charset="-120"/>
+              </a:rPr>
+              <a:t>fuite progressive : comptes, soldes approximatifs, livret d'épargne</a:t>
+            </a:r>
+            <a:endParaRPr lang="en-US" sz="1150" dirty="0"/>
+          </a:p>
+        </p:txBody>
+      </p:sp>
+      <p:sp>
+        <p:nvSpPr>
+          <p:cNvPr id="9" name="Shape 7"/>
+          <p:cNvSpPr/>
+          <p:nvPr/>
+        </p:nvSpPr>
+        <p:spPr>
+          <a:xfrm>
+            <a:off x="548640" y="2715768"/>
+            <a:ext cx="11064240" cy="749808"/>
+          </a:xfrm>
+          <a:prstGeom prst="roundRect">
+            <a:avLst>
+              <a:gd name="adj" fmla="val 9756"/>
+            </a:avLst>
+          </a:prstGeom>
+          <a:solidFill>
+            <a:srgbClr val="EEF0F8"/>
+          </a:solidFill>
+          <a:ln/>
+          <a:effectLst>
+            <a:outerShdw sx="100000" sy="100000" kx="0" ky="0" algn="bl" rotWithShape="0" blurRad="76200" dist="25400" dir="5400000">
+              <a:srgbClr val="888888">
+                <a:alpha val="25000"/>
+              </a:srgbClr>
+            </a:outerShdw>
+          </a:effectLst>
+        </p:spPr>
+      </p:sp>
+      <p:sp>
+        <p:nvSpPr>
+          <p:cNvPr id="10" name="Text 8"/>
+          <p:cNvSpPr txBox="1"/>
+          <p:nvPr/>
+        </p:nvSpPr>
+        <p:spPr>
+          <a:xfrm>
+            <a:off x="731520" y="2825496"/>
+            <a:ext cx="731520" cy="548640"/>
+          </a:xfrm>
+          <a:prstGeom prst="rect">
+            <a:avLst/>
+          </a:prstGeom>
+          <a:noFill/>
+          <a:ln/>
+        </p:spPr>
+        <p:txBody>
+          <a:bodyPr wrap="square" lIns="0" tIns="0" rIns="0" bIns="0" rtlCol="0" anchor="ctr"/>
+          <a:lstStyle/>
+          <a:p>
+            <a:pPr algn="ctr" indent="0" marL="0">
+              <a:buNone/>
+            </a:pPr>
+            <a:r>
+              <a:rPr lang="en-US" sz="2400" dirty="0">
+                <a:solidFill>
+                  <a:srgbClr val="000000"/>
+                </a:solidFill>
+                <a:latin typeface="Calibri" pitchFamily="34" charset="0"/>
+                <a:ea typeface="Calibri" pitchFamily="34" charset="-122"/>
+                <a:cs typeface="Calibri" pitchFamily="34" charset="-120"/>
+              </a:rPr>
+              <a:t>💡</a:t>
+            </a:r>
+            <a:endParaRPr lang="en-US" sz="2400" dirty="0"/>
+          </a:p>
+        </p:txBody>
+      </p:sp>
+      <p:sp>
+        <p:nvSpPr>
+          <p:cNvPr id="11" name="Text 9"/>
+          <p:cNvSpPr txBox="1"/>
+          <p:nvPr/>
+        </p:nvSpPr>
+        <p:spPr>
+          <a:xfrm>
+            <a:off x="1554480" y="2816352"/>
+            <a:ext cx="9784080" cy="320040"/>
+          </a:xfrm>
+          <a:prstGeom prst="rect">
+            <a:avLst/>
+          </a:prstGeom>
+          <a:noFill/>
+          <a:ln/>
+        </p:spPr>
+        <p:txBody>
+          <a:bodyPr wrap="square" lIns="0" tIns="0" rIns="0" bIns="0" rtlCol="0" anchor="ctr"/>
+          <a:lstStyle/>
+          <a:p>
+            <a:pPr indent="0" marL="0">
+              <a:buNone/>
+            </a:pPr>
+            <a:r>
+              <a:rPr lang="en-US" sz="1450" b="1" dirty="0">
+                <a:solidFill>
+                  <a:srgbClr val="261E48"/>
+                </a:solidFill>
+                <a:latin typeface="Calibri" pitchFamily="34" charset="0"/>
+                <a:ea typeface="Calibri" pitchFamily="34" charset="-122"/>
+                <a:cs typeface="Calibri" pitchFamily="34" charset="-120"/>
+              </a:rPr>
+              <a:t>Astuces débloquées</a:t>
+            </a:r>
+            <a:endParaRPr lang="en-US" sz="1450" dirty="0"/>
+          </a:p>
+        </p:txBody>
+      </p:sp>
+      <p:sp>
+        <p:nvSpPr>
+          <p:cNvPr id="12" name="Text 10"/>
+          <p:cNvSpPr txBox="1"/>
+          <p:nvPr/>
+        </p:nvSpPr>
+        <p:spPr>
+          <a:xfrm>
+            <a:off x="1554480" y="3136392"/>
+            <a:ext cx="9784080" cy="274320"/>
+          </a:xfrm>
+          <a:prstGeom prst="rect">
+            <a:avLst/>
+          </a:prstGeom>
+          <a:noFill/>
+          <a:ln/>
+        </p:spPr>
+        <p:txBody>
+          <a:bodyPr wrap="square" lIns="0" tIns="0" rIns="0" bIns="0" rtlCol="0" anchor="ctr"/>
+          <a:lstStyle/>
+          <a:p>
+            <a:pPr indent="0" marL="0">
+              <a:buNone/>
+            </a:pPr>
+            <a:r>
+              <a:rPr lang="en-US" sz="1150" dirty="0">
+                <a:solidFill>
+                  <a:srgbClr val="6A6594"/>
+                </a:solidFill>
+                <a:latin typeface="Calibri" pitchFamily="34" charset="0"/>
+                <a:ea typeface="Calibri" pitchFamily="34" charset="-122"/>
+                <a:cs typeface="Calibri" pitchFamily="34" charset="-120"/>
+              </a:rPr>
+              <a:t>au minuteur (compte à rebours) ET à chaque attaque réussie</a:t>
+            </a:r>
+            <a:endParaRPr lang="en-US" sz="1150" dirty="0"/>
+          </a:p>
+        </p:txBody>
+      </p:sp>
+      <p:sp>
+        <p:nvSpPr>
+          <p:cNvPr id="13" name="Shape 11"/>
+          <p:cNvSpPr/>
+          <p:nvPr/>
+        </p:nvSpPr>
+        <p:spPr>
+          <a:xfrm>
+            <a:off x="548640" y="3602736"/>
+            <a:ext cx="11064240" cy="749808"/>
+          </a:xfrm>
+          <a:prstGeom prst="roundRect">
+            <a:avLst>
+              <a:gd name="adj" fmla="val 9756"/>
+            </a:avLst>
+          </a:prstGeom>
+          <a:solidFill>
+            <a:srgbClr val="EEF0F8"/>
+          </a:solidFill>
+          <a:ln/>
+          <a:effectLst>
+            <a:outerShdw sx="100000" sy="100000" kx="0" ky="0" algn="bl" rotWithShape="0" blurRad="76200" dist="25400" dir="5400000">
+              <a:srgbClr val="888888">
+                <a:alpha val="25000"/>
+              </a:srgbClr>
+            </a:outerShdw>
+          </a:effectLst>
+        </p:spPr>
+      </p:sp>
+      <p:sp>
+        <p:nvSpPr>
+          <p:cNvPr id="14" name="Text 12"/>
+          <p:cNvSpPr txBox="1"/>
+          <p:nvPr/>
+        </p:nvSpPr>
+        <p:spPr>
+          <a:xfrm>
+            <a:off x="731520" y="3712464"/>
+            <a:ext cx="731520" cy="548640"/>
+          </a:xfrm>
+          <a:prstGeom prst="rect">
+            <a:avLst/>
+          </a:prstGeom>
+          <a:noFill/>
+          <a:ln/>
+        </p:spPr>
+        <p:txBody>
+          <a:bodyPr wrap="square" lIns="0" tIns="0" rIns="0" bIns="0" rtlCol="0" anchor="ctr"/>
+          <a:lstStyle/>
+          <a:p>
+            <a:pPr algn="ctr" indent="0" marL="0">
+              <a:buNone/>
+            </a:pPr>
+            <a:r>
+              <a:rPr lang="en-US" sz="2400" dirty="0">
+                <a:solidFill>
+                  <a:srgbClr val="000000"/>
+                </a:solidFill>
+                <a:latin typeface="Calibri" pitchFamily="34" charset="0"/>
+                <a:ea typeface="Calibri" pitchFamily="34" charset="-122"/>
+                <a:cs typeface="Calibri" pitchFamily="34" charset="-120"/>
+              </a:rPr>
+              <a:t>💰</a:t>
+            </a:r>
+            <a:endParaRPr lang="en-US" sz="2400" dirty="0"/>
+          </a:p>
+        </p:txBody>
+      </p:sp>
+      <p:sp>
+        <p:nvSpPr>
+          <p:cNvPr id="15" name="Text 13"/>
+          <p:cNvSpPr txBox="1"/>
+          <p:nvPr/>
+        </p:nvSpPr>
+        <p:spPr>
+          <a:xfrm>
+            <a:off x="1554480" y="3703320"/>
+            <a:ext cx="9784080" cy="320040"/>
+          </a:xfrm>
+          <a:prstGeom prst="rect">
+            <a:avLst/>
+          </a:prstGeom>
+          <a:noFill/>
+          <a:ln/>
+        </p:spPr>
+        <p:txBody>
+          <a:bodyPr wrap="square" lIns="0" tIns="0" rIns="0" bIns="0" rtlCol="0" anchor="ctr"/>
+          <a:lstStyle/>
+          <a:p>
+            <a:pPr indent="0" marL="0">
+              <a:buNone/>
+            </a:pPr>
+            <a:r>
+              <a:rPr lang="en-US" sz="1450" b="1" dirty="0">
+                <a:solidFill>
+                  <a:srgbClr val="261E48"/>
+                </a:solidFill>
+                <a:latin typeface="Calibri" pitchFamily="34" charset="0"/>
+                <a:ea typeface="Calibri" pitchFamily="34" charset="-122"/>
+                <a:cs typeface="Calibri" pitchFamily="34" charset="-120"/>
+              </a:rPr>
+              <a:t>Vol plafonné</a:t>
+            </a:r>
+            <a:endParaRPr lang="en-US" sz="1450" dirty="0"/>
+          </a:p>
+        </p:txBody>
+      </p:sp>
+      <p:sp>
+        <p:nvSpPr>
+          <p:cNvPr id="16" name="Text 14"/>
+          <p:cNvSpPr txBox="1"/>
+          <p:nvPr/>
+        </p:nvSpPr>
+        <p:spPr>
+          <a:xfrm>
+            <a:off x="1554480" y="4023360"/>
+            <a:ext cx="9784080" cy="274320"/>
+          </a:xfrm>
+          <a:prstGeom prst="rect">
+            <a:avLst/>
+          </a:prstGeom>
+          <a:noFill/>
+          <a:ln/>
+        </p:spPr>
+        <p:txBody>
+          <a:bodyPr wrap="square" lIns="0" tIns="0" rIns="0" bIns="0" rtlCol="0" anchor="ctr"/>
+          <a:lstStyle/>
+          <a:p>
+            <a:pPr indent="0" marL="0">
+              <a:buNone/>
+            </a:pPr>
+            <a:r>
+              <a:rPr lang="en-US" sz="1150" dirty="0">
+                <a:solidFill>
+                  <a:srgbClr val="6A6594"/>
+                </a:solidFill>
+                <a:latin typeface="Calibri" pitchFamily="34" charset="0"/>
+                <a:ea typeface="Calibri" pitchFamily="34" charset="-122"/>
+                <a:cs typeface="Calibri" pitchFamily="34" charset="-120"/>
+              </a:rPr>
+              <a:t>retrait atomique, jamais négatif, plafonné par coup et en cumulé</a:t>
+            </a:r>
+            <a:endParaRPr lang="en-US" sz="1150" dirty="0"/>
+          </a:p>
+        </p:txBody>
+      </p:sp>
+      <p:sp>
+        <p:nvSpPr>
+          <p:cNvPr id="17" name="Shape 15"/>
+          <p:cNvSpPr/>
+          <p:nvPr/>
+        </p:nvSpPr>
+        <p:spPr>
+          <a:xfrm>
+            <a:off x="548640" y="4489704"/>
+            <a:ext cx="11064240" cy="749808"/>
+          </a:xfrm>
+          <a:prstGeom prst="roundRect">
+            <a:avLst>
+              <a:gd name="adj" fmla="val 9756"/>
+            </a:avLst>
+          </a:prstGeom>
+          <a:solidFill>
+            <a:srgbClr val="EEF0F8"/>
+          </a:solidFill>
+          <a:ln/>
+          <a:effectLst>
+            <a:outerShdw sx="100000" sy="100000" kx="0" ky="0" algn="bl" rotWithShape="0" blurRad="76200" dist="25400" dir="5400000">
+              <a:srgbClr val="888888">
+                <a:alpha val="25000"/>
+              </a:srgbClr>
+            </a:outerShdw>
+          </a:effectLst>
+        </p:spPr>
+      </p:sp>
+      <p:sp>
+        <p:nvSpPr>
+          <p:cNvPr id="18" name="Text 16"/>
+          <p:cNvSpPr txBox="1"/>
+          <p:nvPr/>
+        </p:nvSpPr>
+        <p:spPr>
+          <a:xfrm>
+            <a:off x="731520" y="4599432"/>
+            <a:ext cx="731520" cy="548640"/>
+          </a:xfrm>
+          <a:prstGeom prst="rect">
+            <a:avLst/>
+          </a:prstGeom>
+          <a:noFill/>
+          <a:ln/>
+        </p:spPr>
+        <p:txBody>
+          <a:bodyPr wrap="square" lIns="0" tIns="0" rIns="0" bIns="0" rtlCol="0" anchor="ctr"/>
+          <a:lstStyle/>
+          <a:p>
+            <a:pPr algn="ctr" indent="0" marL="0">
+              <a:buNone/>
+            </a:pPr>
+            <a:r>
+              <a:rPr lang="en-US" sz="2400" dirty="0">
+                <a:solidFill>
+                  <a:srgbClr val="000000"/>
+                </a:solidFill>
+                <a:latin typeface="Calibri" pitchFamily="34" charset="0"/>
+                <a:ea typeface="Calibri" pitchFamily="34" charset="-122"/>
+                <a:cs typeface="Calibri" pitchFamily="34" charset="-120"/>
+              </a:rPr>
+              <a:t>🧠</a:t>
+            </a:r>
+            <a:endParaRPr lang="en-US" sz="2400" dirty="0"/>
+          </a:p>
+        </p:txBody>
+      </p:sp>
+      <p:sp>
+        <p:nvSpPr>
+          <p:cNvPr id="19" name="Text 17"/>
+          <p:cNvSpPr txBox="1"/>
+          <p:nvPr/>
+        </p:nvSpPr>
+        <p:spPr>
+          <a:xfrm>
+            <a:off x="1554480" y="4590288"/>
+            <a:ext cx="9784080" cy="320040"/>
+          </a:xfrm>
+          <a:prstGeom prst="rect">
+            <a:avLst/>
+          </a:prstGeom>
+          <a:noFill/>
+          <a:ln/>
+        </p:spPr>
+        <p:txBody>
+          <a:bodyPr wrap="square" lIns="0" tIns="0" rIns="0" bIns="0" rtlCol="0" anchor="ctr"/>
+          <a:lstStyle/>
+          <a:p>
+            <a:pPr indent="0" marL="0">
+              <a:buNone/>
+            </a:pPr>
+            <a:r>
+              <a:rPr lang="en-US" sz="1450" b="1" dirty="0">
+                <a:solidFill>
+                  <a:srgbClr val="261E48"/>
+                </a:solidFill>
+                <a:latin typeface="Calibri" pitchFamily="34" charset="0"/>
+                <a:ea typeface="Calibri" pitchFamily="34" charset="-122"/>
+                <a:cs typeface="Calibri" pitchFamily="34" charset="-120"/>
+              </a:rPr>
+              <a:t>Détection IA + réponse</a:t>
+            </a:r>
+            <a:endParaRPr lang="en-US" sz="1450" dirty="0"/>
+          </a:p>
+        </p:txBody>
+      </p:sp>
+      <p:sp>
+        <p:nvSpPr>
+          <p:cNvPr id="20" name="Text 18"/>
+          <p:cNvSpPr txBox="1"/>
+          <p:nvPr/>
+        </p:nvSpPr>
+        <p:spPr>
+          <a:xfrm>
+            <a:off x="1554480" y="4910328"/>
+            <a:ext cx="9784080" cy="274320"/>
+          </a:xfrm>
+          <a:prstGeom prst="rect">
+            <a:avLst/>
+          </a:prstGeom>
+          <a:noFill/>
+          <a:ln/>
+        </p:spPr>
+        <p:txBody>
+          <a:bodyPr wrap="square" lIns="0" tIns="0" rIns="0" bIns="0" rtlCol="0" anchor="ctr"/>
+          <a:lstStyle/>
+          <a:p>
+            <a:pPr indent="0" marL="0">
+              <a:buNone/>
+            </a:pPr>
+            <a:r>
+              <a:rPr lang="en-US" sz="1150" dirty="0">
+                <a:solidFill>
+                  <a:srgbClr val="6A6594"/>
+                </a:solidFill>
+                <a:latin typeface="Calibri" pitchFamily="34" charset="0"/>
+                <a:ea typeface="Calibri" pitchFamily="34" charset="-122"/>
+                <a:cs typeface="Calibri" pitchFamily="34" charset="-120"/>
+              </a:rPr>
+              <a:t>butin anormal ou attaque trop forte → blocage (cooldown)</a:t>
+            </a:r>
+            <a:endParaRPr lang="en-US" sz="1150" dirty="0"/>
+          </a:p>
+        </p:txBody>
+      </p:sp>
+      <p:sp>
+        <p:nvSpPr>
+          <p:cNvPr id="21" name="Shape 19"/>
+          <p:cNvSpPr/>
+          <p:nvPr/>
+        </p:nvSpPr>
+        <p:spPr>
+          <a:xfrm>
+            <a:off x="548640" y="5376672"/>
+            <a:ext cx="11064240" cy="749808"/>
+          </a:xfrm>
+          <a:prstGeom prst="roundRect">
+            <a:avLst>
+              <a:gd name="adj" fmla="val 9756"/>
+            </a:avLst>
+          </a:prstGeom>
+          <a:solidFill>
+            <a:srgbClr val="EEF0F8"/>
+          </a:solidFill>
+          <a:ln/>
+          <a:effectLst>
+            <a:outerShdw sx="100000" sy="100000" kx="0" ky="0" algn="bl" rotWithShape="0" blurRad="76200" dist="25400" dir="5400000">
+              <a:srgbClr val="888888">
+                <a:alpha val="25000"/>
+              </a:srgbClr>
+            </a:outerShdw>
+          </a:effectLst>
+        </p:spPr>
+      </p:sp>
+      <p:sp>
+        <p:nvSpPr>
+          <p:cNvPr id="22" name="Text 20"/>
+          <p:cNvSpPr txBox="1"/>
+          <p:nvPr/>
+        </p:nvSpPr>
+        <p:spPr>
+          <a:xfrm>
+            <a:off x="731520" y="5486400"/>
+            <a:ext cx="731520" cy="548640"/>
+          </a:xfrm>
+          <a:prstGeom prst="rect">
+            <a:avLst/>
+          </a:prstGeom>
+          <a:noFill/>
+          <a:ln/>
+        </p:spPr>
+        <p:txBody>
+          <a:bodyPr wrap="square" lIns="0" tIns="0" rIns="0" bIns="0" rtlCol="0" anchor="ctr"/>
+          <a:lstStyle/>
+          <a:p>
+            <a:pPr algn="ctr" indent="0" marL="0">
+              <a:buNone/>
+            </a:pPr>
+            <a:r>
+              <a:rPr lang="en-US" sz="2400" dirty="0">
+                <a:solidFill>
+                  <a:srgbClr val="000000"/>
+                </a:solidFill>
+                <a:latin typeface="Calibri" pitchFamily="34" charset="0"/>
+                <a:ea typeface="Calibri" pitchFamily="34" charset="-122"/>
+                <a:cs typeface="Calibri" pitchFamily="34" charset="-120"/>
+              </a:rPr>
+              <a:t>🛡️</a:t>
+            </a:r>
+            <a:endParaRPr lang="en-US" sz="2400" dirty="0"/>
+          </a:p>
+        </p:txBody>
+      </p:sp>
+      <p:sp>
+        <p:nvSpPr>
+          <p:cNvPr id="23" name="Text 21"/>
+          <p:cNvSpPr txBox="1"/>
+          <p:nvPr/>
+        </p:nvSpPr>
+        <p:spPr>
+          <a:xfrm>
+            <a:off x="1554480" y="5477256"/>
+            <a:ext cx="9784080" cy="320040"/>
+          </a:xfrm>
+          <a:prstGeom prst="rect">
+            <a:avLst/>
+          </a:prstGeom>
+          <a:noFill/>
+          <a:ln/>
+        </p:spPr>
+        <p:txBody>
+          <a:bodyPr wrap="square" lIns="0" tIns="0" rIns="0" bIns="0" rtlCol="0" anchor="ctr"/>
+          <a:lstStyle/>
+          <a:p>
+            <a:pPr indent="0" marL="0">
+              <a:buNone/>
+            </a:pPr>
+            <a:r>
+              <a:rPr lang="en-US" sz="1450" b="1" dirty="0">
+                <a:solidFill>
+                  <a:srgbClr val="261E48"/>
+                </a:solidFill>
+                <a:latin typeface="Calibri" pitchFamily="34" charset="0"/>
+                <a:ea typeface="Calibri" pitchFamily="34" charset="-122"/>
+                <a:cs typeface="Calibri" pitchFamily="34" charset="-120"/>
+              </a:rPr>
+              <a:t>Bascule secours + butin annulé</a:t>
+            </a:r>
+            <a:endParaRPr lang="en-US" sz="1450" dirty="0"/>
+          </a:p>
+        </p:txBody>
+      </p:sp>
+      <p:sp>
+        <p:nvSpPr>
+          <p:cNvPr id="24" name="Text 22"/>
+          <p:cNvSpPr txBox="1"/>
+          <p:nvPr/>
+        </p:nvSpPr>
+        <p:spPr>
+          <a:xfrm>
+            <a:off x="1554480" y="5797296"/>
+            <a:ext cx="9784080" cy="274320"/>
+          </a:xfrm>
+          <a:prstGeom prst="rect">
+            <a:avLst/>
+          </a:prstGeom>
+          <a:noFill/>
+          <a:ln/>
+        </p:spPr>
+        <p:txBody>
+          <a:bodyPr wrap="square" lIns="0" tIns="0" rIns="0" bIns="0" rtlCol="0" anchor="ctr"/>
+          <a:lstStyle/>
+          <a:p>
+            <a:pPr indent="0" marL="0">
+              <a:buNone/>
+            </a:pPr>
+            <a:r>
+              <a:rPr lang="en-US" sz="1150" dirty="0">
+                <a:solidFill>
+                  <a:srgbClr val="6A6594"/>
+                </a:solidFill>
+                <a:latin typeface="Calibri" pitchFamily="34" charset="0"/>
+                <a:ea typeface="Calibri" pitchFamily="34" charset="-122"/>
+                <a:cs typeface="Calibri" pitchFamily="34" charset="-120"/>
+              </a:rPr>
+              <a:t>l'argent volé ne « gagne » pas si l'IA bascule à temps</a:t>
+            </a:r>
+            <a:endParaRPr lang="en-US" sz="1150" dirty="0"/>
+          </a:p>
+        </p:txBody>
+      </p:sp>
+      <p:sp>
+        <p:nvSpPr>
+          <p:cNvPr id="25" name="Text 23"/>
+          <p:cNvSpPr txBox="1"/>
+          <p:nvPr/>
+        </p:nvSpPr>
+        <p:spPr>
+          <a:xfrm>
+            <a:off x="548640" y="6355080"/>
+            <a:ext cx="11064240" cy="365760"/>
+          </a:xfrm>
+          <a:prstGeom prst="rect">
+            <a:avLst/>
+          </a:prstGeom>
+          <a:noFill/>
+          <a:ln/>
+        </p:spPr>
+        <p:txBody>
+          <a:bodyPr wrap="square" lIns="0" tIns="0" rIns="0" bIns="0" rtlCol="0" anchor="ctr"/>
+          <a:lstStyle/>
+          <a:p>
+            <a:pPr indent="0" marL="0">
+              <a:buNone/>
+            </a:pPr>
+            <a:r>
+              <a:rPr lang="en-US" sz="1200" b="1" dirty="0">
+                <a:solidFill>
+                  <a:srgbClr val="4B3FA6"/>
+                </a:solidFill>
+                <a:latin typeface="Calibri" pitchFamily="34" charset="0"/>
+                <a:ea typeface="Calibri" pitchFamily="34" charset="-122"/>
+                <a:cs typeface="Calibri" pitchFamily="34" charset="-120"/>
+              </a:rPr>
+              <a:t>Doser : jouer discret rapporte un petit butin ; forcer déclenche le blocage, la bascule et la restauration.</a:t>
+            </a:r>
+            <a:endParaRPr lang="en-US" sz="1200" dirty="0"/>
+          </a:p>
+        </p:txBody>
+      </p:sp>
+    </p:spTree>
+  </p:cSld>
+  <p:clrMapOvr>
+    <a:masterClrMapping/>
+  </p:clrMapOvr>
+</p:sld>
+</file>
+
+<file path=ppt/slides/slide15.xml><?xml version="1.0" encoding="utf-8"?>
+<p:sld xmlns:a="http://schemas.openxmlformats.org/drawingml/2006/main" xmlns:r="http://schemas.openxmlformats.org/officeDocument/2006/relationships" xmlns:p="http://schemas.openxmlformats.org/presentationml/2006/main">
+  <p:cSld name="Slide 15">
+    <p:bg>
+      <p:bgPr>
+        <a:solidFill>
           <a:srgbClr val="261E48"/>
         </a:solidFill>
       </p:bgPr>

</xml_diff>